<commit_message>
feat: redesign slide 6 of P005 - 4-action key points card layout
Replace the "組み合わせ方" overview with a 2x2 card grid explaining
each action's key points (Initialize variable / Compose / Apply to each / Condition)

Co-Authored-By: Claude Sonnet 4.6 <noreply@anthropic.com>
</commit_message>
<xml_diff>
--- a/assets/pa45/P005_PA45_MatomeFuro_20260409.pptx
+++ b/assets/pa45/P005_PA45_MatomeFuro_20260409.pptx
@@ -15550,2117 +15550,6 @@
       </p:sp>
       <p:sp>
         <p:nvSpPr>
-          <p:cNvPr id="6" name="Shape 4"/>
-          <p:cNvSpPr/>
-          <p:nvPr/>
-        </p:nvSpPr>
-        <p:spPr>
-          <a:xfrm>
-            <a:off x="8174242" y="1002854"/>
-            <a:ext cx="4067251" cy="5829300"/>
-          </a:xfrm>
-          <a:prstGeom prst="rect">
-            <a:avLst/>
-          </a:prstGeom>
-          <a:solidFill>
-            <a:srgbClr val="EFF6FF">
-              <a:alpha val="30000"/>
-            </a:srgbClr>
-          </a:solidFill>
-          <a:ln w="12700">
-            <a:solidFill>
-              <a:srgbClr val="FFFFFF">
-                <a:alpha val="0"/>
-              </a:srgbClr>
-            </a:solidFill>
-            <a:prstDash val="solid"/>
-          </a:ln>
-        </p:spPr>
-        <p:txBody>
-          <a:bodyPr wrap="square"/>
-          <a:lstStyle/>
-          <a:p>
-            <a:endParaRPr lang="ja-JP" altLang="en-US"/>
-          </a:p>
-        </p:txBody>
-      </p:sp>
-      <p:sp>
-        <p:nvSpPr>
-          <p:cNvPr id="8" name="Shape 6"/>
-          <p:cNvSpPr/>
-          <p:nvPr/>
-        </p:nvSpPr>
-        <p:spPr>
-          <a:xfrm>
-            <a:off x="7519904" y="1012241"/>
-            <a:ext cx="9144" cy="5829300"/>
-          </a:xfrm>
-          <a:prstGeom prst="rect">
-            <a:avLst/>
-          </a:prstGeom>
-          <a:solidFill>
-            <a:srgbClr val="E5E7EB"/>
-          </a:solidFill>
-          <a:ln w="12700">
-            <a:solidFill>
-              <a:srgbClr val="E5E7EB">
-                <a:alpha val="0"/>
-              </a:srgbClr>
-            </a:solidFill>
-            <a:prstDash val="solid"/>
-          </a:ln>
-        </p:spPr>
-        <p:txBody>
-          <a:bodyPr wrap="square"/>
-          <a:lstStyle/>
-          <a:p>
-            <a:endParaRPr lang="ja-JP" altLang="en-US"/>
-          </a:p>
-        </p:txBody>
-      </p:sp>
-      <p:sp>
-        <p:nvSpPr>
-          <p:cNvPr id="9" name="Text 7"/>
-          <p:cNvSpPr txBox="1"/>
-          <p:nvPr/>
-        </p:nvSpPr>
-        <p:spPr>
-          <a:xfrm>
-            <a:off x="793242" y="1196847"/>
-            <a:ext cx="3705149" cy="381305"/>
-          </a:xfrm>
-          <a:prstGeom prst="rect">
-            <a:avLst/>
-          </a:prstGeom>
-          <a:noFill/>
-          <a:ln/>
-        </p:spPr>
-        <p:txBody>
-          <a:bodyPr wrap="square" lIns="0" tIns="0" rIns="0" bIns="0" rtlCol="0" anchor="ctr"/>
-          <a:lstStyle/>
-          <a:p>
-            <a:pPr marL="0" indent="0" algn="l">
-              <a:buNone/>
-            </a:pPr>
-            <a:r>
-              <a:rPr lang="en-US" sz="2400" b="1" dirty="0">
-                <a:solidFill>
-                  <a:srgbClr val="1F2937"/>
-                </a:solidFill>
-                <a:latin typeface="Noto Sans JP" pitchFamily="34" charset="0"/>
-                <a:ea typeface="Noto Sans JP" pitchFamily="34" charset="-122"/>
-                <a:cs typeface="Noto Sans JP" pitchFamily="34" charset="-120"/>
-              </a:rPr>
-              <a:t>4つのアクション　おさらいと組み合わせ方</a:t>
-            </a:r>
-            <a:endParaRPr lang="en-US" sz="2400" dirty="0"/>
-          </a:p>
-        </p:txBody>
-      </p:sp>
-      <p:pic>
-        <p:nvPicPr>
-          <p:cNvPr id="10" name="Image 0" descr="preencoded.png"/>
-          <p:cNvPicPr>
-            <a:picLocks noChangeAspect="1"/>
-          </p:cNvPicPr>
-          <p:nvPr/>
-        </p:nvPicPr>
-        <p:blipFill>
-          <a:blip r:embed="rId3"/>
-          <a:srcRect/>
-          <a:stretch/>
-        </p:blipFill>
-        <p:spPr>
-          <a:xfrm>
-            <a:off x="327045" y="1121429"/>
-            <a:ext cx="340157" cy="453543"/>
-          </a:xfrm>
-          <a:prstGeom prst="rect">
-            <a:avLst/>
-          </a:prstGeom>
-        </p:spPr>
-      </p:pic>
-      <p:sp>
-        <p:nvSpPr>
-          <p:cNvPr id="22" name="Shape 19"/>
-          <p:cNvSpPr/>
-          <p:nvPr/>
-        </p:nvSpPr>
-        <p:spPr>
-          <a:xfrm>
-            <a:off x="7539562" y="990752"/>
-            <a:ext cx="4476902" cy="5829300"/>
-          </a:xfrm>
-          <a:prstGeom prst="rect">
-            <a:avLst/>
-          </a:prstGeom>
-          <a:solidFill>
-            <a:srgbClr val="EFF6FF">
-              <a:alpha val="30000"/>
-            </a:srgbClr>
-          </a:solidFill>
-          <a:ln w="12700">
-            <a:solidFill>
-              <a:srgbClr val="FFFFFF">
-                <a:alpha val="0"/>
-              </a:srgbClr>
-            </a:solidFill>
-            <a:prstDash val="solid"/>
-          </a:ln>
-        </p:spPr>
-        <p:txBody>
-          <a:bodyPr wrap="square"/>
-          <a:lstStyle/>
-          <a:p>
-            <a:endParaRPr lang="ja-JP" altLang="en-US"/>
-          </a:p>
-        </p:txBody>
-      </p:sp>
-      <p:sp>
-        <p:nvSpPr>
-          <p:cNvPr id="23" name="Text 20"/>
-          <p:cNvSpPr txBox="1"/>
-          <p:nvPr/>
-        </p:nvSpPr>
-        <p:spPr>
-          <a:xfrm>
-            <a:off x="8395104" y="1314654"/>
-            <a:ext cx="3715207" cy="483716"/>
-          </a:xfrm>
-          <a:prstGeom prst="rect">
-            <a:avLst/>
-          </a:prstGeom>
-          <a:noFill/>
-          <a:ln/>
-        </p:spPr>
-        <p:txBody>
-          <a:bodyPr wrap="square" lIns="0" tIns="0" rIns="0" bIns="0" rtlCol="0" anchor="ctr"/>
-          <a:lstStyle/>
-          <a:p>
-            <a:pPr marL="0" indent="0" algn="l">
-              <a:buNone/>
-            </a:pPr>
-            <a:r>
-              <a:rPr lang="en-US" sz="2000" b="1" dirty="0">
-                <a:solidFill>
-                  <a:srgbClr val="1F2937"/>
-                </a:solidFill>
-                <a:latin typeface="Noto Sans JP" pitchFamily="34" charset="0"/>
-                <a:ea typeface="Noto Sans JP" pitchFamily="34" charset="-122"/>
-                <a:cs typeface="Noto Sans JP" pitchFamily="34" charset="-120"/>
-              </a:rPr>
-              <a:t>今日使うアクション（4つ）</a:t>
-            </a:r>
-            <a:endParaRPr lang="en-US" sz="3200" dirty="0"/>
-          </a:p>
-        </p:txBody>
-      </p:sp>
-      <p:pic>
-        <p:nvPicPr>
-          <p:cNvPr id="24" name="Image 1" descr="preencoded.png"/>
-          <p:cNvPicPr>
-            <a:picLocks noChangeAspect="1"/>
-          </p:cNvPicPr>
-          <p:nvPr/>
-        </p:nvPicPr>
-        <p:blipFill>
-          <a:blip r:embed="rId4"/>
-          <a:srcRect/>
-          <a:stretch/>
-        </p:blipFill>
-        <p:spPr>
-          <a:xfrm>
-            <a:off x="7812175" y="1373277"/>
-            <a:ext cx="389534" cy="389534"/>
-          </a:xfrm>
-          <a:prstGeom prst="rect">
-            <a:avLst/>
-          </a:prstGeom>
-        </p:spPr>
-      </p:pic>
-      <p:pic>
-        <p:nvPicPr>
-          <p:cNvPr id="25" name="Image 2" descr="preencoded.png"/>
-          <p:cNvPicPr>
-            <a:picLocks noChangeAspect="1"/>
-          </p:cNvPicPr>
-          <p:nvPr/>
-        </p:nvPicPr>
-        <p:blipFill>
-          <a:blip r:embed="rId5"/>
-          <a:srcRect l="-15" r="-15"/>
-          <a:stretch/>
-        </p:blipFill>
-        <p:spPr>
-          <a:xfrm>
-            <a:off x="7689452" y="2131466"/>
-            <a:ext cx="4012387" cy="1128370"/>
-          </a:xfrm>
-          <a:prstGeom prst="rect">
-            <a:avLst/>
-          </a:prstGeom>
-        </p:spPr>
-      </p:pic>
-      <p:sp>
-        <p:nvSpPr>
-          <p:cNvPr id="26" name="Shape 21"/>
-          <p:cNvSpPr/>
-          <p:nvPr/>
-        </p:nvSpPr>
-        <p:spPr>
-          <a:xfrm>
-            <a:off x="7851301" y="2467051"/>
-            <a:ext cx="457200" cy="457200"/>
-          </a:xfrm>
-          <a:prstGeom prst="ellipse">
-            <a:avLst/>
-          </a:prstGeom>
-          <a:solidFill>
-            <a:srgbClr val="DBEAFE"/>
-          </a:solidFill>
-          <a:ln w="12700">
-            <a:solidFill>
-              <a:srgbClr val="FFFFFF">
-                <a:alpha val="0"/>
-              </a:srgbClr>
-            </a:solidFill>
-            <a:prstDash val="solid"/>
-          </a:ln>
-        </p:spPr>
-        <p:txBody>
-          <a:bodyPr wrap="square"/>
-          <a:lstStyle/>
-          <a:p>
-            <a:endParaRPr lang="ja-JP" altLang="en-US" sz="3200"/>
-          </a:p>
-        </p:txBody>
-      </p:sp>
-      <p:pic>
-        <p:nvPicPr>
-          <p:cNvPr id="27" name="Image 3" descr="preencoded.png"/>
-          <p:cNvPicPr>
-            <a:picLocks noChangeAspect="1"/>
-          </p:cNvPicPr>
-          <p:nvPr/>
-        </p:nvPicPr>
-        <p:blipFill>
-          <a:blip r:embed="rId6"/>
-          <a:srcRect l="-57" r="-57"/>
-          <a:stretch/>
-        </p:blipFill>
-        <p:spPr>
-          <a:xfrm>
-            <a:off x="7980231" y="2581351"/>
-            <a:ext cx="200254" cy="228600"/>
-          </a:xfrm>
-          <a:prstGeom prst="rect">
-            <a:avLst/>
-          </a:prstGeom>
-        </p:spPr>
-      </p:pic>
-      <p:sp>
-        <p:nvSpPr>
-          <p:cNvPr id="28" name="Text 22"/>
-          <p:cNvSpPr txBox="1"/>
-          <p:nvPr/>
-        </p:nvSpPr>
-        <p:spPr>
-          <a:xfrm>
-            <a:off x="8408097" y="2090324"/>
-            <a:ext cx="1636138" cy="193655"/>
-          </a:xfrm>
-          <a:prstGeom prst="rect">
-            <a:avLst/>
-          </a:prstGeom>
-          <a:noFill/>
-          <a:ln/>
-        </p:spPr>
-        <p:txBody>
-          <a:bodyPr wrap="square" lIns="0" tIns="0" rIns="0" bIns="0" rtlCol="0" anchor="ctr"/>
-          <a:lstStyle/>
-          <a:p>
-            <a:pPr marL="0" indent="0" algn="l">
-              <a:buNone/>
-            </a:pPr>
-            <a:r>
-              <a:rPr lang="en-US" sz="1600" b="1" dirty="0">
-                <a:solidFill>
-                  <a:srgbClr val="1F2937"/>
-                </a:solidFill>
-                <a:latin typeface="Noto Sans JP" pitchFamily="34" charset="0"/>
-                <a:ea typeface="Noto Sans JP" pitchFamily="34" charset="-122"/>
-                <a:cs typeface="Noto Sans JP" pitchFamily="34" charset="-120"/>
-              </a:rPr>
-              <a:t>Initialize variable</a:t>
-            </a:r>
-            <a:endParaRPr lang="en-US" sz="2000" dirty="0"/>
-          </a:p>
-        </p:txBody>
-      </p:sp>
-      <p:sp>
-        <p:nvSpPr>
-          <p:cNvPr id="29" name="Shape 23"/>
-          <p:cNvSpPr/>
-          <p:nvPr/>
-        </p:nvSpPr>
-        <p:spPr>
-          <a:xfrm>
-            <a:off x="11030670" y="2296972"/>
-            <a:ext cx="514807" cy="228600"/>
-          </a:xfrm>
-          <a:prstGeom prst="roundRect">
-            <a:avLst>
-              <a:gd name="adj" fmla="val 400000"/>
-            </a:avLst>
-          </a:prstGeom>
-          <a:solidFill>
-            <a:srgbClr val="DBEAFE"/>
-          </a:solidFill>
-          <a:ln w="12700">
-            <a:solidFill>
-              <a:srgbClr val="FFFFFF">
-                <a:alpha val="0"/>
-              </a:srgbClr>
-            </a:solidFill>
-            <a:prstDash val="solid"/>
-          </a:ln>
-        </p:spPr>
-        <p:txBody>
-          <a:bodyPr wrap="square"/>
-          <a:lstStyle/>
-          <a:p>
-            <a:endParaRPr lang="ja-JP" altLang="en-US" sz="3200"/>
-          </a:p>
-        </p:txBody>
-      </p:sp>
-      <p:sp>
-        <p:nvSpPr>
-          <p:cNvPr id="30" name="Text 24"/>
-          <p:cNvSpPr/>
-          <p:nvPr/>
-        </p:nvSpPr>
-        <p:spPr>
-          <a:xfrm>
-            <a:off x="10495911" y="2230892"/>
-            <a:ext cx="1406412" cy="294680"/>
-          </a:xfrm>
-          <a:prstGeom prst="rect">
-            <a:avLst/>
-          </a:prstGeom>
-          <a:solidFill>
-            <a:srgbClr val="FFFFFF">
-              <a:alpha val="0"/>
-            </a:srgbClr>
-          </a:solidFill>
-          <a:ln>
-            <a:solidFill>
-              <a:srgbClr val="FFFFFF">
-                <a:alpha val="0"/>
-              </a:srgbClr>
-            </a:solidFill>
-          </a:ln>
-        </p:spPr>
-        <p:txBody>
-          <a:bodyPr wrap="square" lIns="114300" tIns="38100" rIns="114300" bIns="38100" rtlCol="0" anchor="ctr"/>
-          <a:lstStyle/>
-          <a:p>
-            <a:pPr marL="0" indent="0" algn="ctr">
-              <a:buNone/>
-            </a:pPr>
-            <a:endParaRPr lang="en-US" sz="4000" dirty="0"/>
-          </a:p>
-        </p:txBody>
-      </p:sp>
-      <p:sp>
-        <p:nvSpPr>
-          <p:cNvPr id="31" name="Text 25"/>
-          <p:cNvSpPr txBox="1"/>
-          <p:nvPr/>
-        </p:nvSpPr>
-        <p:spPr>
-          <a:xfrm>
-            <a:off x="8408097" y="2473702"/>
-            <a:ext cx="3314700" cy="432000"/>
-          </a:xfrm>
-          <a:prstGeom prst="rect">
-            <a:avLst/>
-          </a:prstGeom>
-          <a:noFill/>
-          <a:ln/>
-        </p:spPr>
-        <p:txBody>
-          <a:bodyPr wrap="square" lIns="0" tIns="0" rIns="0" bIns="0" rtlCol="0" anchor="ctr"/>
-          <a:lstStyle/>
-          <a:p>
-            <a:pPr marL="0" indent="0" algn="l">
-              <a:buNone/>
-            </a:pPr>
-            <a:r>
-              <a:rPr lang="en-US" sz="1600" dirty="0">
-                <a:solidFill>
-                  <a:srgbClr val="6B7280"/>
-                </a:solidFill>
-                <a:latin typeface="Noto Sans JP" pitchFamily="34" charset="0"/>
-                <a:ea typeface="Noto Sans JP" pitchFamily="34" charset="-122"/>
-                <a:cs typeface="Noto Sans JP" pitchFamily="34" charset="-120"/>
-              </a:rPr>
-              <a:t>スコアカウンターを0で初期化</a:t>
-            </a:r>
-          </a:p>
-          <a:p>
-            <a:pPr marL="0" indent="0" algn="l">
-              <a:buNone/>
-            </a:pPr>
-            <a:r>
-              <a:rPr lang="en-US" sz="1600">
-                <a:solidFill>
-                  <a:srgbClr val="6B7280"/>
-                </a:solidFill>
-                <a:latin typeface="Noto Sans JP" pitchFamily="34" charset="0"/>
-                <a:ea typeface="Noto Sans JP" pitchFamily="34" charset="-122"/>
-                <a:cs typeface="Noto Sans JP" pitchFamily="34" charset="-120"/>
-              </a:rPr>
-              <a:t>変数を作る</a:t>
-            </a:r>
-            <a:endParaRPr lang="en-US" dirty="0"/>
-          </a:p>
-        </p:txBody>
-      </p:sp>
-      <p:pic>
-        <p:nvPicPr>
-          <p:cNvPr id="32" name="Image 4" descr="preencoded.png"/>
-          <p:cNvPicPr>
-            <a:picLocks noChangeAspect="1"/>
-          </p:cNvPicPr>
-          <p:nvPr/>
-        </p:nvPicPr>
-        <p:blipFill>
-          <a:blip r:embed="rId5"/>
-          <a:srcRect l="-15" r="-15"/>
-          <a:stretch/>
-        </p:blipFill>
-        <p:spPr>
-          <a:xfrm>
-            <a:off x="7728329" y="3535437"/>
-            <a:ext cx="4012387" cy="1128370"/>
-          </a:xfrm>
-          <a:prstGeom prst="rect">
-            <a:avLst/>
-          </a:prstGeom>
-        </p:spPr>
-      </p:pic>
-      <p:sp>
-        <p:nvSpPr>
-          <p:cNvPr id="33" name="Shape 26"/>
-          <p:cNvSpPr/>
-          <p:nvPr/>
-        </p:nvSpPr>
-        <p:spPr>
-          <a:xfrm>
-            <a:off x="7890178" y="3871936"/>
-            <a:ext cx="457200" cy="457200"/>
-          </a:xfrm>
-          <a:prstGeom prst="ellipse">
-            <a:avLst/>
-          </a:prstGeom>
-          <a:solidFill>
-            <a:srgbClr val="D1FAE5"/>
-          </a:solidFill>
-          <a:ln w="12700">
-            <a:solidFill>
-              <a:srgbClr val="FFFFFF">
-                <a:alpha val="0"/>
-              </a:srgbClr>
-            </a:solidFill>
-            <a:prstDash val="solid"/>
-          </a:ln>
-        </p:spPr>
-        <p:txBody>
-          <a:bodyPr wrap="square"/>
-          <a:lstStyle/>
-          <a:p>
-            <a:endParaRPr lang="ja-JP" altLang="en-US" sz="3200"/>
-          </a:p>
-        </p:txBody>
-      </p:sp>
-      <p:pic>
-        <p:nvPicPr>
-          <p:cNvPr id="34" name="Image 5" descr="preencoded.png"/>
-          <p:cNvPicPr>
-            <a:picLocks noChangeAspect="1"/>
-          </p:cNvPicPr>
-          <p:nvPr/>
-        </p:nvPicPr>
-        <p:blipFill>
-          <a:blip r:embed="rId7"/>
-          <a:srcRect l="-57" r="-57"/>
-          <a:stretch/>
-        </p:blipFill>
-        <p:spPr>
-          <a:xfrm>
-            <a:off x="8019108" y="3986236"/>
-            <a:ext cx="200254" cy="228600"/>
-          </a:xfrm>
-          <a:prstGeom prst="rect">
-            <a:avLst/>
-          </a:prstGeom>
-        </p:spPr>
-      </p:pic>
-      <p:sp>
-        <p:nvSpPr>
-          <p:cNvPr id="35" name="Text 27"/>
-          <p:cNvSpPr txBox="1"/>
-          <p:nvPr/>
-        </p:nvSpPr>
-        <p:spPr>
-          <a:xfrm>
-            <a:off x="8476596" y="3646329"/>
-            <a:ext cx="1783417" cy="295350"/>
-          </a:xfrm>
-          <a:prstGeom prst="rect">
-            <a:avLst/>
-          </a:prstGeom>
-          <a:noFill/>
-          <a:ln/>
-        </p:spPr>
-        <p:txBody>
-          <a:bodyPr wrap="square" lIns="0" tIns="0" rIns="0" bIns="0" rtlCol="0" anchor="ctr"/>
-          <a:lstStyle/>
-          <a:p>
-            <a:pPr marL="0" indent="0" algn="l">
-              <a:buNone/>
-            </a:pPr>
-            <a:r>
-              <a:rPr lang="en-US" sz="1600" b="1" dirty="0">
-                <a:solidFill>
-                  <a:srgbClr val="1F2937"/>
-                </a:solidFill>
-                <a:latin typeface="Noto Sans JP" pitchFamily="34" charset="0"/>
-                <a:ea typeface="Noto Sans JP" pitchFamily="34" charset="-122"/>
-                <a:cs typeface="Noto Sans JP" pitchFamily="34" charset="-120"/>
-              </a:rPr>
-              <a:t>Apply to each</a:t>
-            </a:r>
-            <a:endParaRPr lang="en-US" sz="2000" dirty="0"/>
-          </a:p>
-        </p:txBody>
-      </p:sp>
-      <p:sp>
-        <p:nvSpPr>
-          <p:cNvPr id="36" name="Shape 28"/>
-          <p:cNvSpPr/>
-          <p:nvPr/>
-        </p:nvSpPr>
-        <p:spPr>
-          <a:xfrm>
-            <a:off x="11069547" y="3700943"/>
-            <a:ext cx="514807" cy="228600"/>
-          </a:xfrm>
-          <a:prstGeom prst="roundRect">
-            <a:avLst>
-              <a:gd name="adj" fmla="val 400000"/>
-            </a:avLst>
-          </a:prstGeom>
-          <a:solidFill>
-            <a:srgbClr val="D1FAE5"/>
-          </a:solidFill>
-          <a:ln w="12700">
-            <a:solidFill>
-              <a:srgbClr val="FFFFFF">
-                <a:alpha val="0"/>
-              </a:srgbClr>
-            </a:solidFill>
-            <a:prstDash val="solid"/>
-          </a:ln>
-        </p:spPr>
-        <p:txBody>
-          <a:bodyPr wrap="square"/>
-          <a:lstStyle/>
-          <a:p>
-            <a:endParaRPr lang="ja-JP" altLang="en-US" sz="3200"/>
-          </a:p>
-        </p:txBody>
-      </p:sp>
-      <p:sp>
-        <p:nvSpPr>
-          <p:cNvPr id="37" name="Text 29"/>
-          <p:cNvSpPr/>
-          <p:nvPr/>
-        </p:nvSpPr>
-        <p:spPr>
-          <a:xfrm>
-            <a:off x="10397060" y="3669625"/>
-            <a:ext cx="1406412" cy="251460"/>
-          </a:xfrm>
-          <a:prstGeom prst="rect">
-            <a:avLst/>
-          </a:prstGeom>
-          <a:solidFill>
-            <a:srgbClr val="FFFFFF">
-              <a:alpha val="0"/>
-            </a:srgbClr>
-          </a:solidFill>
-          <a:ln>
-            <a:solidFill>
-              <a:srgbClr val="FFFFFF">
-                <a:alpha val="0"/>
-              </a:srgbClr>
-            </a:solidFill>
-          </a:ln>
-        </p:spPr>
-        <p:txBody>
-          <a:bodyPr wrap="square" lIns="114300" tIns="38100" rIns="114300" bIns="38100" rtlCol="0" anchor="ctr"/>
-          <a:lstStyle/>
-          <a:p>
-            <a:pPr marL="0" indent="0" algn="ctr">
-              <a:buNone/>
-            </a:pPr>
-            <a:r>
-              <a:rPr lang="en-US" sz="2000" b="1" kern="0" spc="52" dirty="0">
-                <a:solidFill>
-                  <a:srgbClr val="047857"/>
-                </a:solidFill>
-                <a:latin typeface="Noto Sans JP" pitchFamily="34" charset="0"/>
-                <a:ea typeface="Noto Sans JP" pitchFamily="34" charset="-122"/>
-                <a:cs typeface="Noto Sans JP" pitchFamily="34" charset="-120"/>
-              </a:rPr>
-              <a:t>繰り返す</a:t>
-            </a:r>
-            <a:endParaRPr lang="en-US" sz="4000" dirty="0"/>
-          </a:p>
-        </p:txBody>
-      </p:sp>
-      <p:sp>
-        <p:nvSpPr>
-          <p:cNvPr id="38" name="Text 30"/>
-          <p:cNvSpPr txBox="1"/>
-          <p:nvPr/>
-        </p:nvSpPr>
-        <p:spPr>
-          <a:xfrm>
-            <a:off x="8612589" y="3952403"/>
-            <a:ext cx="3490193" cy="432000"/>
-          </a:xfrm>
-          <a:prstGeom prst="rect">
-            <a:avLst/>
-          </a:prstGeom>
-          <a:noFill/>
-          <a:ln/>
-        </p:spPr>
-        <p:txBody>
-          <a:bodyPr wrap="square" lIns="0" tIns="0" rIns="0" bIns="0" rtlCol="0" anchor="ctr"/>
-          <a:lstStyle/>
-          <a:p>
-            <a:pPr marL="0" indent="0" algn="l">
-              <a:buNone/>
-            </a:pPr>
-            <a:r>
-              <a:rPr lang="en-US" sz="1600" dirty="0">
-                <a:solidFill>
-                  <a:srgbClr val="6B7280"/>
-                </a:solidFill>
-                <a:latin typeface="Noto Sans JP" pitchFamily="34" charset="0"/>
-                <a:ea typeface="Noto Sans JP" pitchFamily="34" charset="-122"/>
-                <a:cs typeface="Noto Sans JP" pitchFamily="34" charset="-120"/>
-              </a:rPr>
-              <a:t>スコアリストを1件ずつループ</a:t>
-            </a:r>
-          </a:p>
-          <a:p>
-            <a:pPr marL="0" indent="0" algn="l">
-              <a:buNone/>
-            </a:pPr>
-            <a:endParaRPr lang="en-US" sz="1600" dirty="0"/>
-          </a:p>
-        </p:txBody>
-      </p:sp>
-      <p:pic>
-        <p:nvPicPr>
-          <p:cNvPr id="39" name="Image 6" descr="preencoded.png"/>
-          <p:cNvPicPr>
-            <a:picLocks noChangeAspect="1"/>
-          </p:cNvPicPr>
-          <p:nvPr/>
-        </p:nvPicPr>
-        <p:blipFill>
-          <a:blip r:embed="rId5"/>
-          <a:srcRect l="-15" r="-15"/>
-          <a:stretch/>
-        </p:blipFill>
-        <p:spPr>
-          <a:xfrm>
-            <a:off x="7689452" y="5302342"/>
-            <a:ext cx="4012387" cy="1394612"/>
-          </a:xfrm>
-          <a:prstGeom prst="rect">
-            <a:avLst/>
-          </a:prstGeom>
-        </p:spPr>
-      </p:pic>
-      <p:sp>
-        <p:nvSpPr>
-          <p:cNvPr id="40" name="Shape 31"/>
-          <p:cNvSpPr/>
-          <p:nvPr/>
-        </p:nvSpPr>
-        <p:spPr>
-          <a:xfrm>
-            <a:off x="7792498" y="5580558"/>
-            <a:ext cx="457200" cy="457200"/>
-          </a:xfrm>
-          <a:prstGeom prst="ellipse">
-            <a:avLst/>
-          </a:prstGeom>
-          <a:solidFill>
-            <a:srgbClr val="EDE9FE"/>
-          </a:solidFill>
-          <a:ln w="12700">
-            <a:solidFill>
-              <a:srgbClr val="FFFFFF">
-                <a:alpha val="0"/>
-              </a:srgbClr>
-            </a:solidFill>
-            <a:prstDash val="solid"/>
-          </a:ln>
-        </p:spPr>
-        <p:txBody>
-          <a:bodyPr wrap="square"/>
-          <a:lstStyle/>
-          <a:p>
-            <a:endParaRPr lang="ja-JP" altLang="en-US" sz="3200"/>
-          </a:p>
-        </p:txBody>
-      </p:sp>
-      <p:pic>
-        <p:nvPicPr>
-          <p:cNvPr id="41" name="Image 7" descr="preencoded.png"/>
-          <p:cNvPicPr>
-            <a:picLocks noChangeAspect="1"/>
-          </p:cNvPicPr>
-          <p:nvPr/>
-        </p:nvPicPr>
-        <p:blipFill>
-          <a:blip r:embed="rId8"/>
-          <a:srcRect t="-45" b="-45"/>
-          <a:stretch/>
-        </p:blipFill>
-        <p:spPr>
-          <a:xfrm>
-            <a:off x="7892168" y="5694858"/>
-            <a:ext cx="256946" cy="228600"/>
-          </a:xfrm>
-          <a:prstGeom prst="rect">
-            <a:avLst/>
-          </a:prstGeom>
-        </p:spPr>
-      </p:pic>
-      <p:sp>
-        <p:nvSpPr>
-          <p:cNvPr id="42" name="Text 32"/>
-          <p:cNvSpPr txBox="1"/>
-          <p:nvPr/>
-        </p:nvSpPr>
-        <p:spPr>
-          <a:xfrm>
-            <a:off x="8439452" y="5404355"/>
-            <a:ext cx="1636138" cy="159106"/>
-          </a:xfrm>
-          <a:prstGeom prst="rect">
-            <a:avLst/>
-          </a:prstGeom>
-          <a:noFill/>
-          <a:ln/>
-        </p:spPr>
-        <p:txBody>
-          <a:bodyPr wrap="square" lIns="0" tIns="0" rIns="0" bIns="0" rtlCol="0" anchor="ctr"/>
-          <a:lstStyle/>
-          <a:p>
-            <a:pPr marL="0" indent="0" algn="l">
-              <a:buNone/>
-            </a:pPr>
-            <a:r>
-              <a:rPr lang="en-US" sz="1600" b="1" dirty="0">
-                <a:solidFill>
-                  <a:srgbClr val="1F2937"/>
-                </a:solidFill>
-                <a:latin typeface="Noto Sans JP" pitchFamily="34" charset="0"/>
-                <a:ea typeface="Noto Sans JP" pitchFamily="34" charset="-122"/>
-                <a:cs typeface="Noto Sans JP" pitchFamily="34" charset="-120"/>
-              </a:rPr>
-              <a:t>Condition</a:t>
-            </a:r>
-            <a:endParaRPr lang="en-US" sz="2000" dirty="0"/>
-          </a:p>
-        </p:txBody>
-      </p:sp>
-      <p:sp>
-        <p:nvSpPr>
-          <p:cNvPr id="43" name="Shape 33"/>
-          <p:cNvSpPr/>
-          <p:nvPr/>
-        </p:nvSpPr>
-        <p:spPr>
-          <a:xfrm>
-            <a:off x="10590711" y="5211715"/>
-            <a:ext cx="990295" cy="228600"/>
-          </a:xfrm>
-          <a:prstGeom prst="roundRect">
-            <a:avLst>
-              <a:gd name="adj" fmla="val 400000"/>
-            </a:avLst>
-          </a:prstGeom>
-          <a:solidFill>
-            <a:srgbClr val="EDE9FE"/>
-          </a:solidFill>
-          <a:ln w="12700">
-            <a:solidFill>
-              <a:srgbClr val="FFFFFF">
-                <a:alpha val="0"/>
-              </a:srgbClr>
-            </a:solidFill>
-            <a:prstDash val="solid"/>
-          </a:ln>
-        </p:spPr>
-        <p:txBody>
-          <a:bodyPr wrap="square"/>
-          <a:lstStyle/>
-          <a:p>
-            <a:endParaRPr lang="ja-JP" altLang="en-US" sz="3200"/>
-          </a:p>
-        </p:txBody>
-      </p:sp>
-      <p:sp>
-        <p:nvSpPr>
-          <p:cNvPr id="44" name="Text 34"/>
-          <p:cNvSpPr/>
-          <p:nvPr/>
-        </p:nvSpPr>
-        <p:spPr>
-          <a:xfrm>
-            <a:off x="10270960" y="5206187"/>
-            <a:ext cx="1406412" cy="251460"/>
-          </a:xfrm>
-          <a:prstGeom prst="rect">
-            <a:avLst/>
-          </a:prstGeom>
-          <a:solidFill>
-            <a:srgbClr val="FFFFFF">
-              <a:alpha val="0"/>
-            </a:srgbClr>
-          </a:solidFill>
-          <a:ln>
-            <a:solidFill>
-              <a:srgbClr val="FFFFFF">
-                <a:alpha val="0"/>
-              </a:srgbClr>
-            </a:solidFill>
-          </a:ln>
-        </p:spPr>
-        <p:txBody>
-          <a:bodyPr wrap="square" lIns="114300" tIns="38100" rIns="114300" bIns="38100" rtlCol="0" anchor="ctr"/>
-          <a:lstStyle/>
-          <a:p>
-            <a:pPr marL="0" indent="0" algn="ctr">
-              <a:buNone/>
-            </a:pPr>
-            <a:r>
-              <a:rPr lang="en-US" sz="2000" b="1" kern="0" spc="52" dirty="0">
-                <a:solidFill>
-                  <a:srgbClr val="6D28D9"/>
-                </a:solidFill>
-                <a:latin typeface="Noto Sans JP" pitchFamily="34" charset="0"/>
-                <a:ea typeface="Noto Sans JP" pitchFamily="34" charset="-122"/>
-                <a:cs typeface="Noto Sans JP" pitchFamily="34" charset="-120"/>
-              </a:rPr>
-              <a:t>分岐する</a:t>
-            </a:r>
-            <a:endParaRPr lang="en-US" sz="4000" dirty="0"/>
-          </a:p>
-        </p:txBody>
-      </p:sp>
-      <p:sp>
-        <p:nvSpPr>
-          <p:cNvPr id="45" name="Text 35"/>
-          <p:cNvSpPr txBox="1"/>
-          <p:nvPr/>
-        </p:nvSpPr>
-        <p:spPr>
-          <a:xfrm>
-            <a:off x="8472794" y="5635784"/>
-            <a:ext cx="3314700" cy="432000"/>
-          </a:xfrm>
-          <a:prstGeom prst="rect">
-            <a:avLst/>
-          </a:prstGeom>
-          <a:noFill/>
-          <a:ln/>
-        </p:spPr>
-        <p:txBody>
-          <a:bodyPr wrap="square" lIns="0" tIns="0" rIns="0" bIns="0" rtlCol="0" anchor="ctr"/>
-          <a:lstStyle/>
-          <a:p>
-            <a:pPr marL="0" indent="0" algn="l">
-              <a:buNone/>
-            </a:pPr>
-            <a:r>
-              <a:rPr lang="en-US" sz="1600" dirty="0">
-                <a:solidFill>
-                  <a:srgbClr val="6B7280"/>
-                </a:solidFill>
-                <a:latin typeface="Noto Sans JP" pitchFamily="34" charset="0"/>
-                <a:ea typeface="Noto Sans JP" pitchFamily="34" charset="-122"/>
-                <a:cs typeface="Noto Sans JP" pitchFamily="34" charset="-120"/>
-              </a:rPr>
-              <a:t>スコアが70以上かどうか判定</a:t>
-            </a:r>
-            <a:endParaRPr lang="en-US" sz="1600" dirty="0"/>
-          </a:p>
-        </p:txBody>
-      </p:sp>
-      <p:sp>
-        <p:nvSpPr>
-          <p:cNvPr id="11" name="Shape 8"/>
-          <p:cNvSpPr/>
-          <p:nvPr/>
-        </p:nvSpPr>
-        <p:spPr>
-          <a:xfrm>
-            <a:off x="331596" y="4079488"/>
-            <a:ext cx="4009644" cy="780898"/>
-          </a:xfrm>
-          <a:prstGeom prst="roundRect">
-            <a:avLst>
-              <a:gd name="adj" fmla="val 34272"/>
-            </a:avLst>
-          </a:prstGeom>
-          <a:solidFill>
-            <a:srgbClr val="EFF6FF"/>
-          </a:solidFill>
-          <a:ln/>
-        </p:spPr>
-        <p:txBody>
-          <a:bodyPr wrap="square"/>
-          <a:lstStyle/>
-          <a:p>
-            <a:endParaRPr lang="ja-JP" altLang="en-US" sz="2400"/>
-          </a:p>
-        </p:txBody>
-      </p:sp>
-      <p:sp>
-        <p:nvSpPr>
-          <p:cNvPr id="12" name="Shape 9"/>
-          <p:cNvSpPr/>
-          <p:nvPr/>
-        </p:nvSpPr>
-        <p:spPr>
-          <a:xfrm>
-            <a:off x="331596" y="4079488"/>
-            <a:ext cx="38405" cy="780898"/>
-          </a:xfrm>
-          <a:prstGeom prst="roundRect">
-            <a:avLst>
-              <a:gd name="adj" fmla="val 696860"/>
-            </a:avLst>
-          </a:prstGeom>
-          <a:solidFill>
-            <a:srgbClr val="3B82F6"/>
-          </a:solidFill>
-          <a:ln w="12700">
-            <a:solidFill>
-              <a:srgbClr val="3B82F6">
-                <a:alpha val="0"/>
-              </a:srgbClr>
-            </a:solidFill>
-            <a:prstDash val="solid"/>
-          </a:ln>
-        </p:spPr>
-        <p:txBody>
-          <a:bodyPr wrap="square"/>
-          <a:lstStyle/>
-          <a:p>
-            <a:endParaRPr lang="ja-JP" altLang="en-US" sz="2400"/>
-          </a:p>
-        </p:txBody>
-      </p:sp>
-      <p:sp>
-        <p:nvSpPr>
-          <p:cNvPr id="13" name="Text 10"/>
-          <p:cNvSpPr txBox="1"/>
-          <p:nvPr/>
-        </p:nvSpPr>
-        <p:spPr>
-          <a:xfrm>
-            <a:off x="855546" y="4232193"/>
-            <a:ext cx="3788189" cy="222199"/>
-          </a:xfrm>
-          <a:prstGeom prst="rect">
-            <a:avLst/>
-          </a:prstGeom>
-          <a:noFill/>
-          <a:ln/>
-        </p:spPr>
-        <p:txBody>
-          <a:bodyPr wrap="square" lIns="0" tIns="0" rIns="0" bIns="0" rtlCol="0" anchor="ctr"/>
-          <a:lstStyle/>
-          <a:p>
-            <a:pPr marL="0" indent="0" algn="l">
-              <a:buNone/>
-            </a:pPr>
-            <a:r>
-              <a:rPr lang="en-US" b="1" dirty="0">
-                <a:solidFill>
-                  <a:srgbClr val="1F2937"/>
-                </a:solidFill>
-                <a:latin typeface="Noto Sans JP" pitchFamily="34" charset="0"/>
-                <a:ea typeface="Noto Sans JP" pitchFamily="34" charset="-122"/>
-                <a:cs typeface="Noto Sans JP" pitchFamily="34" charset="-120"/>
-              </a:rPr>
-              <a:t>4つをつなぐと"自動集計フロー"が完成する</a:t>
-            </a:r>
-            <a:endParaRPr lang="en-US" dirty="0"/>
-          </a:p>
-        </p:txBody>
-      </p:sp>
-      <p:sp>
-        <p:nvSpPr>
-          <p:cNvPr id="14" name="Text 11"/>
-          <p:cNvSpPr txBox="1"/>
-          <p:nvPr/>
-        </p:nvSpPr>
-        <p:spPr>
-          <a:xfrm>
-            <a:off x="864691" y="4561979"/>
-            <a:ext cx="6171542" cy="360000"/>
-          </a:xfrm>
-          <a:prstGeom prst="rect">
-            <a:avLst/>
-          </a:prstGeom>
-          <a:noFill/>
-          <a:ln/>
-        </p:spPr>
-        <p:txBody>
-          <a:bodyPr wrap="square" lIns="0" tIns="0" rIns="0" bIns="0" rtlCol="0" anchor="ctr"/>
-          <a:lstStyle/>
-          <a:p>
-            <a:pPr marL="0" indent="0" algn="l">
-              <a:buNone/>
-            </a:pPr>
-            <a:r>
-              <a:rPr lang="en-US" sz="1600" dirty="0">
-                <a:solidFill>
-                  <a:srgbClr val="4B5563"/>
-                </a:solidFill>
-                <a:latin typeface="Noto Sans JP" pitchFamily="34" charset="0"/>
-                <a:ea typeface="Noto Sans JP" pitchFamily="34" charset="-122"/>
-                <a:cs typeface="Noto Sans JP" pitchFamily="34" charset="-120"/>
-              </a:rPr>
-              <a:t>今日作るフロー：スコアリストを処理して合格者数をカウントする</a:t>
-            </a:r>
-          </a:p>
-          <a:p>
-            <a:pPr marL="0" indent="0" algn="l">
-              <a:buNone/>
-            </a:pPr>
-            <a:endParaRPr lang="en-US" sz="1600" dirty="0"/>
-          </a:p>
-        </p:txBody>
-      </p:sp>
-      <p:sp>
-        <p:nvSpPr>
-          <p:cNvPr id="15" name="Shape 12"/>
-          <p:cNvSpPr/>
-          <p:nvPr/>
-        </p:nvSpPr>
-        <p:spPr>
-          <a:xfrm>
-            <a:off x="331596" y="4951825"/>
-            <a:ext cx="4009644" cy="780898"/>
-          </a:xfrm>
-          <a:prstGeom prst="roundRect">
-            <a:avLst>
-              <a:gd name="adj" fmla="val 34272"/>
-            </a:avLst>
-          </a:prstGeom>
-          <a:solidFill>
-            <a:srgbClr val="ECFDF5"/>
-          </a:solidFill>
-          <a:ln/>
-        </p:spPr>
-        <p:txBody>
-          <a:bodyPr wrap="square"/>
-          <a:lstStyle/>
-          <a:p>
-            <a:endParaRPr lang="ja-JP" altLang="en-US" sz="2400"/>
-          </a:p>
-        </p:txBody>
-      </p:sp>
-      <p:sp>
-        <p:nvSpPr>
-          <p:cNvPr id="16" name="Shape 13"/>
-          <p:cNvSpPr/>
-          <p:nvPr/>
-        </p:nvSpPr>
-        <p:spPr>
-          <a:xfrm>
-            <a:off x="331596" y="4951825"/>
-            <a:ext cx="38405" cy="780898"/>
-          </a:xfrm>
-          <a:prstGeom prst="roundRect">
-            <a:avLst>
-              <a:gd name="adj" fmla="val 696860"/>
-            </a:avLst>
-          </a:prstGeom>
-          <a:solidFill>
-            <a:srgbClr val="10B981"/>
-          </a:solidFill>
-          <a:ln w="12700">
-            <a:solidFill>
-              <a:srgbClr val="10B981">
-                <a:alpha val="0"/>
-              </a:srgbClr>
-            </a:solidFill>
-            <a:prstDash val="solid"/>
-          </a:ln>
-        </p:spPr>
-        <p:txBody>
-          <a:bodyPr wrap="square"/>
-          <a:lstStyle/>
-          <a:p>
-            <a:endParaRPr lang="ja-JP" altLang="en-US" sz="2400"/>
-          </a:p>
-        </p:txBody>
-      </p:sp>
-      <p:sp>
-        <p:nvSpPr>
-          <p:cNvPr id="17" name="Text 14"/>
-          <p:cNvSpPr txBox="1"/>
-          <p:nvPr/>
-        </p:nvSpPr>
-        <p:spPr>
-          <a:xfrm>
-            <a:off x="855547" y="5103616"/>
-            <a:ext cx="3380664" cy="238658"/>
-          </a:xfrm>
-          <a:prstGeom prst="rect">
-            <a:avLst/>
-          </a:prstGeom>
-          <a:noFill/>
-          <a:ln/>
-        </p:spPr>
-        <p:txBody>
-          <a:bodyPr wrap="square" lIns="0" tIns="0" rIns="0" bIns="0" rtlCol="0" anchor="ctr"/>
-          <a:lstStyle/>
-          <a:p>
-            <a:pPr marL="0" indent="0" algn="l">
-              <a:buNone/>
-            </a:pPr>
-            <a:r>
-              <a:rPr lang="en-US" b="1" dirty="0">
-                <a:solidFill>
-                  <a:srgbClr val="1F2937"/>
-                </a:solidFill>
-                <a:latin typeface="Noto Sans JP" pitchFamily="34" charset="0"/>
-                <a:ea typeface="Noto Sans JP" pitchFamily="34" charset="-122"/>
-                <a:cs typeface="Noto Sans JP" pitchFamily="34" charset="-120"/>
-              </a:rPr>
-              <a:t>Set variable</a:t>
-            </a:r>
-            <a:endParaRPr lang="en-US" dirty="0"/>
-          </a:p>
-        </p:txBody>
-      </p:sp>
-      <p:sp>
-        <p:nvSpPr>
-          <p:cNvPr id="18" name="Text 15"/>
-          <p:cNvSpPr txBox="1"/>
-          <p:nvPr/>
-        </p:nvSpPr>
-        <p:spPr>
-          <a:xfrm>
-            <a:off x="864690" y="5434590"/>
-            <a:ext cx="5770105" cy="360000"/>
-          </a:xfrm>
-          <a:prstGeom prst="rect">
-            <a:avLst/>
-          </a:prstGeom>
-          <a:noFill/>
-          <a:ln/>
-        </p:spPr>
-        <p:txBody>
-          <a:bodyPr wrap="square" lIns="0" tIns="0" rIns="0" bIns="0" rtlCol="0" anchor="ctr"/>
-          <a:lstStyle/>
-          <a:p>
-            <a:pPr marL="0" indent="0" algn="l">
-              <a:buNone/>
-            </a:pPr>
-            <a:r>
-              <a:rPr lang="en-US" sz="1600" dirty="0">
-                <a:solidFill>
-                  <a:srgbClr val="4B5563"/>
-                </a:solidFill>
-                <a:latin typeface="Noto Sans JP" pitchFamily="34" charset="0"/>
-                <a:ea typeface="Noto Sans JP" pitchFamily="34" charset="-122"/>
-                <a:cs typeface="Noto Sans JP" pitchFamily="34" charset="-120"/>
-              </a:rPr>
-              <a:t>書き換える</a:t>
-            </a:r>
-            <a:endParaRPr lang="en-US" sz="1600" dirty="0"/>
-          </a:p>
-        </p:txBody>
-      </p:sp>
-      <p:sp>
-        <p:nvSpPr>
-          <p:cNvPr id="19" name="Shape 16"/>
-          <p:cNvSpPr/>
-          <p:nvPr/>
-        </p:nvSpPr>
-        <p:spPr>
-          <a:xfrm>
-            <a:off x="331596" y="5823249"/>
-            <a:ext cx="38405" cy="780898"/>
-          </a:xfrm>
-          <a:prstGeom prst="roundRect">
-            <a:avLst>
-              <a:gd name="adj" fmla="val 696860"/>
-            </a:avLst>
-          </a:prstGeom>
-          <a:solidFill>
-            <a:srgbClr val="E5E7EB"/>
-          </a:solidFill>
-          <a:ln w="12700">
-            <a:solidFill>
-              <a:srgbClr val="E5E7EB">
-                <a:alpha val="0"/>
-              </a:srgbClr>
-            </a:solidFill>
-            <a:prstDash val="solid"/>
-          </a:ln>
-        </p:spPr>
-        <p:txBody>
-          <a:bodyPr wrap="square"/>
-          <a:lstStyle/>
-          <a:p>
-            <a:endParaRPr lang="ja-JP" altLang="en-US" sz="2400"/>
-          </a:p>
-        </p:txBody>
-      </p:sp>
-      <p:pic>
-        <p:nvPicPr>
-          <p:cNvPr id="46" name="Image 8" descr="preencoded.png"/>
-          <p:cNvPicPr>
-            <a:picLocks noChangeAspect="1"/>
-          </p:cNvPicPr>
-          <p:nvPr/>
-        </p:nvPicPr>
-        <p:blipFill>
-          <a:blip r:embed="rId9"/>
-          <a:srcRect l="-1064" r="-1064"/>
-          <a:stretch/>
-        </p:blipFill>
-        <p:spPr>
-          <a:xfrm>
-            <a:off x="521791" y="4282485"/>
-            <a:ext cx="219456" cy="171907"/>
-          </a:xfrm>
-          <a:prstGeom prst="rect">
-            <a:avLst/>
-          </a:prstGeom>
-        </p:spPr>
-      </p:pic>
-      <p:pic>
-        <p:nvPicPr>
-          <p:cNvPr id="47" name="Image 9" descr="preencoded.png"/>
-          <p:cNvPicPr>
-            <a:picLocks noChangeAspect="1"/>
-          </p:cNvPicPr>
-          <p:nvPr/>
-        </p:nvPicPr>
-        <p:blipFill>
-          <a:blip r:embed="rId10"/>
-          <a:srcRect l="-1064" r="-1064"/>
-          <a:stretch/>
-        </p:blipFill>
-        <p:spPr>
-          <a:xfrm>
-            <a:off x="521791" y="5153908"/>
-            <a:ext cx="219456" cy="171907"/>
-          </a:xfrm>
-          <a:prstGeom prst="rect">
-            <a:avLst/>
-          </a:prstGeom>
-        </p:spPr>
-      </p:pic>
-      <p:pic>
-        <p:nvPicPr>
-          <p:cNvPr id="48" name="Image 10" descr="preencoded.png"/>
-          <p:cNvPicPr>
-            <a:picLocks noChangeAspect="1"/>
-          </p:cNvPicPr>
-          <p:nvPr/>
-        </p:nvPicPr>
-        <p:blipFill>
-          <a:blip r:embed="rId11"/>
-          <a:srcRect/>
-          <a:stretch/>
-        </p:blipFill>
-        <p:spPr>
-          <a:xfrm>
-            <a:off x="521791" y="6025331"/>
-            <a:ext cx="171907" cy="171907"/>
-          </a:xfrm>
-          <a:prstGeom prst="rect">
-            <a:avLst/>
-          </a:prstGeom>
-        </p:spPr>
-      </p:pic>
-      <p:sp>
-        <p:nvSpPr>
-          <p:cNvPr id="49" name="Shape 36"/>
-          <p:cNvSpPr/>
-          <p:nvPr/>
-        </p:nvSpPr>
-        <p:spPr>
-          <a:xfrm>
-            <a:off x="8352884" y="2984808"/>
-            <a:ext cx="1742846" cy="295351"/>
-          </a:xfrm>
-          <a:prstGeom prst="roundRect">
-            <a:avLst>
-              <a:gd name="adj" fmla="val 79896"/>
-            </a:avLst>
-          </a:prstGeom>
-          <a:solidFill>
-            <a:srgbClr val="F9FAFB"/>
-          </a:solidFill>
-          <a:ln w="12700">
-            <a:solidFill>
-              <a:srgbClr val="E5E7EB"/>
-            </a:solidFill>
-            <a:prstDash val="solid"/>
-          </a:ln>
-        </p:spPr>
-        <p:txBody>
-          <a:bodyPr wrap="square"/>
-          <a:lstStyle/>
-          <a:p>
-            <a:endParaRPr lang="ja-JP" altLang="en-US" sz="3200"/>
-          </a:p>
-        </p:txBody>
-      </p:sp>
-      <p:sp>
-        <p:nvSpPr>
-          <p:cNvPr id="50" name="Text 37"/>
-          <p:cNvSpPr txBox="1"/>
-          <p:nvPr/>
-        </p:nvSpPr>
-        <p:spPr>
-          <a:xfrm>
-            <a:off x="8566731" y="2930413"/>
-            <a:ext cx="2494942" cy="286162"/>
-          </a:xfrm>
-          <a:prstGeom prst="rect">
-            <a:avLst/>
-          </a:prstGeom>
-          <a:solidFill>
-            <a:srgbClr val="FFFFFF">
-              <a:alpha val="0"/>
-            </a:srgbClr>
-          </a:solidFill>
-          <a:ln>
-            <a:solidFill>
-              <a:srgbClr val="FFFFFF">
-                <a:alpha val="0"/>
-              </a:srgbClr>
-            </a:solidFill>
-          </a:ln>
-        </p:spPr>
-        <p:txBody>
-          <a:bodyPr wrap="square" lIns="76200" tIns="38100" rIns="76200" bIns="38100" rtlCol="0" anchor="t"/>
-          <a:lstStyle/>
-          <a:p>
-            <a:pPr marL="0" indent="0" algn="l">
-              <a:buNone/>
-            </a:pPr>
-            <a:r>
-              <a:rPr lang="en-US" sz="2000" dirty="0">
-                <a:solidFill>
-                  <a:srgbClr val="4B5563"/>
-                </a:solidFill>
-                <a:latin typeface="ui-monospace" pitchFamily="34" charset="0"/>
-                <a:ea typeface="ui-monospace" pitchFamily="34" charset="-122"/>
-                <a:cs typeface="ui-monospace" pitchFamily="34" charset="-120"/>
-              </a:rPr>
-              <a:t>合格ならカウンターを+1</a:t>
-            </a:r>
-            <a:endParaRPr lang="en-US" sz="2000" dirty="0"/>
-          </a:p>
-        </p:txBody>
-      </p:sp>
-      <p:sp>
-        <p:nvSpPr>
-          <p:cNvPr id="51" name="Shape 38"/>
-          <p:cNvSpPr/>
-          <p:nvPr/>
-        </p:nvSpPr>
-        <p:spPr>
-          <a:xfrm>
-            <a:off x="8454990" y="4484637"/>
-            <a:ext cx="1057046" cy="295351"/>
-          </a:xfrm>
-          <a:prstGeom prst="roundRect">
-            <a:avLst>
-              <a:gd name="adj" fmla="val 79896"/>
-            </a:avLst>
-          </a:prstGeom>
-          <a:solidFill>
-            <a:srgbClr val="F9FAFB"/>
-          </a:solidFill>
-          <a:ln w="12700">
-            <a:solidFill>
-              <a:srgbClr val="E5E7EB"/>
-            </a:solidFill>
-            <a:prstDash val="solid"/>
-          </a:ln>
-        </p:spPr>
-        <p:txBody>
-          <a:bodyPr wrap="square"/>
-          <a:lstStyle/>
-          <a:p>
-            <a:endParaRPr lang="ja-JP" altLang="en-US" sz="3200"/>
-          </a:p>
-        </p:txBody>
-      </p:sp>
-      <p:sp>
-        <p:nvSpPr>
-          <p:cNvPr id="52" name="Text 39"/>
-          <p:cNvSpPr txBox="1"/>
-          <p:nvPr/>
-        </p:nvSpPr>
-        <p:spPr>
-          <a:xfrm>
-            <a:off x="8476596" y="4349876"/>
-            <a:ext cx="1873780" cy="338730"/>
-          </a:xfrm>
-          <a:prstGeom prst="rect">
-            <a:avLst/>
-          </a:prstGeom>
-          <a:solidFill>
-            <a:srgbClr val="FFFFFF">
-              <a:alpha val="0"/>
-            </a:srgbClr>
-          </a:solidFill>
-          <a:ln>
-            <a:solidFill>
-              <a:srgbClr val="FFFFFF">
-                <a:alpha val="0"/>
-              </a:srgbClr>
-            </a:solidFill>
-          </a:ln>
-        </p:spPr>
-        <p:txBody>
-          <a:bodyPr wrap="square" lIns="76200" tIns="38100" rIns="76200" bIns="38100" rtlCol="0" anchor="t"/>
-          <a:lstStyle/>
-          <a:p>
-            <a:pPr marL="0" indent="0" algn="l">
-              <a:buNone/>
-            </a:pPr>
-            <a:endParaRPr lang="en-US" sz="2400" dirty="0"/>
-          </a:p>
-        </p:txBody>
-      </p:sp>
-      <p:sp>
-        <p:nvSpPr>
-          <p:cNvPr id="53" name="Shape 40"/>
-          <p:cNvSpPr/>
-          <p:nvPr/>
-        </p:nvSpPr>
-        <p:spPr>
-          <a:xfrm>
-            <a:off x="8459601" y="6191705"/>
-            <a:ext cx="1133856" cy="295351"/>
-          </a:xfrm>
-          <a:prstGeom prst="roundRect">
-            <a:avLst>
-              <a:gd name="adj" fmla="val 79896"/>
-            </a:avLst>
-          </a:prstGeom>
-          <a:solidFill>
-            <a:srgbClr val="F9FAFB"/>
-          </a:solidFill>
-          <a:ln w="12700">
-            <a:solidFill>
-              <a:srgbClr val="E5E7EB"/>
-            </a:solidFill>
-            <a:prstDash val="solid"/>
-          </a:ln>
-        </p:spPr>
-        <p:txBody>
-          <a:bodyPr wrap="square"/>
-          <a:lstStyle/>
-          <a:p>
-            <a:endParaRPr lang="ja-JP" altLang="en-US" sz="3200"/>
-          </a:p>
-        </p:txBody>
-      </p:sp>
-      <p:sp>
-        <p:nvSpPr>
-          <p:cNvPr id="54" name="Text 41"/>
-          <p:cNvSpPr txBox="1"/>
-          <p:nvPr/>
-        </p:nvSpPr>
-        <p:spPr>
-          <a:xfrm>
-            <a:off x="8543060" y="6107103"/>
-            <a:ext cx="1191463" cy="295351"/>
-          </a:xfrm>
-          <a:prstGeom prst="rect">
-            <a:avLst/>
-          </a:prstGeom>
-          <a:solidFill>
-            <a:srgbClr val="FFFFFF">
-              <a:alpha val="0"/>
-            </a:srgbClr>
-          </a:solidFill>
-          <a:ln>
-            <a:solidFill>
-              <a:srgbClr val="FFFFFF">
-                <a:alpha val="0"/>
-              </a:srgbClr>
-            </a:solidFill>
-          </a:ln>
-        </p:spPr>
-        <p:txBody>
-          <a:bodyPr wrap="square" lIns="76200" tIns="38100" rIns="76200" bIns="38100" rtlCol="0" anchor="t"/>
-          <a:lstStyle/>
-          <a:p>
-            <a:pPr marL="0" indent="0" algn="l">
-              <a:buNone/>
-            </a:pPr>
-            <a:endParaRPr lang="en-US" sz="2400" dirty="0"/>
-          </a:p>
-        </p:txBody>
-      </p:sp>
-      <p:pic>
-        <p:nvPicPr>
-          <p:cNvPr id="55" name="Image 11" descr="preencoded.png"/>
-          <p:cNvPicPr>
-            <a:picLocks noChangeAspect="1"/>
-          </p:cNvPicPr>
-          <p:nvPr/>
-        </p:nvPicPr>
-        <p:blipFill>
-          <a:blip r:embed="rId12"/>
-          <a:srcRect l="-6" r="-6"/>
-          <a:stretch/>
-        </p:blipFill>
-        <p:spPr>
-          <a:xfrm>
-            <a:off x="437847" y="2131466"/>
-            <a:ext cx="4060543" cy="1693628"/>
-          </a:xfrm>
-          <a:prstGeom prst="rect">
-            <a:avLst/>
-          </a:prstGeom>
-        </p:spPr>
-      </p:pic>
-      <p:sp>
-        <p:nvSpPr>
-          <p:cNvPr id="56" name="Shape 42"/>
-          <p:cNvSpPr/>
-          <p:nvPr/>
-        </p:nvSpPr>
-        <p:spPr>
-          <a:xfrm>
-            <a:off x="2413889" y="1901786"/>
-            <a:ext cx="1417320" cy="114300"/>
-          </a:xfrm>
-          <a:prstGeom prst="roundRect">
-            <a:avLst>
-              <a:gd name="adj" fmla="val 533333"/>
-            </a:avLst>
-          </a:prstGeom>
-          <a:solidFill>
-            <a:srgbClr val="005A9E"/>
-          </a:solidFill>
-          <a:ln w="12700">
-            <a:solidFill>
-              <a:srgbClr val="FFFFFF">
-                <a:alpha val="0"/>
-              </a:srgbClr>
-            </a:solidFill>
-            <a:prstDash val="solid"/>
-          </a:ln>
-        </p:spPr>
-        <p:txBody>
-          <a:bodyPr wrap="square"/>
-          <a:lstStyle/>
-          <a:p>
-            <a:endParaRPr lang="ja-JP" altLang="en-US"/>
-          </a:p>
-        </p:txBody>
-      </p:sp>
-      <p:pic>
-        <p:nvPicPr>
-          <p:cNvPr id="57" name="Image 12" descr="preencoded.png"/>
-          <p:cNvPicPr>
-            <a:picLocks noChangeAspect="1"/>
-          </p:cNvPicPr>
-          <p:nvPr/>
-        </p:nvPicPr>
-        <p:blipFill>
-          <a:blip r:embed="rId13"/>
-          <a:srcRect l="-272" r="-272"/>
-          <a:stretch/>
-        </p:blipFill>
-        <p:spPr>
-          <a:xfrm>
-            <a:off x="341811" y="1694612"/>
-            <a:ext cx="4330286" cy="495775"/>
-          </a:xfrm>
-          <a:prstGeom prst="rect">
-            <a:avLst/>
-          </a:prstGeom>
-        </p:spPr>
-      </p:pic>
-      <p:sp>
-        <p:nvSpPr>
-          <p:cNvPr id="58" name="Text 43"/>
-          <p:cNvSpPr txBox="1"/>
-          <p:nvPr/>
-        </p:nvSpPr>
-        <p:spPr>
-          <a:xfrm>
-            <a:off x="457200" y="1815084"/>
-            <a:ext cx="2685593" cy="323850"/>
-          </a:xfrm>
-          <a:prstGeom prst="rect">
-            <a:avLst/>
-          </a:prstGeom>
-          <a:noFill/>
-          <a:ln/>
-        </p:spPr>
-        <p:txBody>
-          <a:bodyPr wrap="square" lIns="0" tIns="0" rIns="0" bIns="0" rtlCol="0" anchor="t"/>
-          <a:lstStyle/>
-          <a:p>
-            <a:pPr marL="0" indent="0" algn="l">
-              <a:buNone/>
-            </a:pPr>
-            <a:endParaRPr lang="en-US" sz="2000" dirty="0"/>
-          </a:p>
-        </p:txBody>
-      </p:sp>
-      <p:sp>
-        <p:nvSpPr>
-          <p:cNvPr id="59" name="Text 44"/>
-          <p:cNvSpPr txBox="1"/>
-          <p:nvPr/>
-        </p:nvSpPr>
-        <p:spPr>
-          <a:xfrm>
-            <a:off x="1078078" y="2312518"/>
-            <a:ext cx="2304288" cy="152705"/>
-          </a:xfrm>
-          <a:prstGeom prst="rect">
-            <a:avLst/>
-          </a:prstGeom>
-          <a:noFill/>
-          <a:ln/>
-        </p:spPr>
-        <p:txBody>
-          <a:bodyPr wrap="square" lIns="0" tIns="0" rIns="0" bIns="0" rtlCol="0" anchor="ctr"/>
-          <a:lstStyle/>
-          <a:p>
-            <a:pPr marL="0" indent="0" algn="ctr">
-              <a:buNone/>
-            </a:pPr>
-            <a:endParaRPr lang="en-US" sz="2400" dirty="0"/>
-          </a:p>
-        </p:txBody>
-      </p:sp>
-      <p:grpSp>
-        <p:nvGrpSpPr>
-          <p:cNvPr id="95" name="グループ化 94">
-            <a:extLst>
-              <a:ext uri="{FF2B5EF4-FFF2-40B4-BE49-F238E27FC236}">
-                <a16:creationId xmlns:a16="http://schemas.microsoft.com/office/drawing/2014/main" id="{AC9D6A09-CDC7-7A9A-2157-83B23DB879BC}"/>
-              </a:ext>
-            </a:extLst>
-          </p:cNvPr>
-          <p:cNvGrpSpPr/>
-          <p:nvPr/>
-        </p:nvGrpSpPr>
-        <p:grpSpPr>
-          <a:xfrm>
-            <a:off x="688973" y="2593140"/>
-            <a:ext cx="3547239" cy="1000353"/>
-            <a:chOff x="1152505" y="2502713"/>
-            <a:chExt cx="2489210" cy="819302"/>
-          </a:xfrm>
-        </p:grpSpPr>
-        <p:pic>
-          <p:nvPicPr>
-            <p:cNvPr id="60" name="Image 13" descr="preencoded.png"/>
-            <p:cNvPicPr>
-              <a:picLocks noChangeAspect="1"/>
-            </p:cNvPicPr>
-            <p:nvPr/>
-          </p:nvPicPr>
-          <p:blipFill>
-            <a:blip r:embed="rId14"/>
-            <a:srcRect t="-38" b="-38"/>
-            <a:stretch/>
-          </p:blipFill>
-          <p:spPr>
-            <a:xfrm>
-              <a:off x="1163117" y="2502713"/>
-              <a:ext cx="2133295" cy="247802"/>
-            </a:xfrm>
-            <a:prstGeom prst="rect">
-              <a:avLst/>
-            </a:prstGeom>
-          </p:spPr>
-        </p:pic>
-        <p:sp>
-          <p:nvSpPr>
-            <p:cNvPr id="61" name="Text 45"/>
-            <p:cNvSpPr txBox="1"/>
-            <p:nvPr/>
-          </p:nvSpPr>
-          <p:spPr>
-            <a:xfrm>
-              <a:off x="1210666" y="2550262"/>
-              <a:ext cx="1116628" cy="152705"/>
-            </a:xfrm>
-            <a:prstGeom prst="rect">
-              <a:avLst/>
-            </a:prstGeom>
-            <a:noFill/>
-            <a:ln/>
-          </p:spPr>
-          <p:txBody>
-            <a:bodyPr wrap="square" lIns="0" tIns="0" rIns="0" bIns="0" rtlCol="0" anchor="ctr"/>
-            <a:lstStyle/>
-            <a:p>
-              <a:pPr marL="0" indent="0" algn="ctr">
-                <a:buNone/>
-              </a:pPr>
-              <a:r>
-                <a:rPr lang="en-US" sz="2000" dirty="0">
-                  <a:solidFill>
-                    <a:srgbClr val="1E40AF"/>
-                  </a:solidFill>
-                  <a:latin typeface="ui-monospace" pitchFamily="34" charset="0"/>
-                  <a:ea typeface="ui-monospace" pitchFamily="34" charset="-122"/>
-                  <a:cs typeface="ui-monospace" pitchFamily="34" charset="-120"/>
-                </a:rPr>
-                <a:t>Array（配列）</a:t>
-              </a:r>
-              <a:endParaRPr lang="en-US" sz="2000" dirty="0"/>
-            </a:p>
-          </p:txBody>
-        </p:sp>
-        <p:sp>
-          <p:nvSpPr>
-            <p:cNvPr id="62" name="Text 46"/>
-            <p:cNvSpPr txBox="1"/>
-            <p:nvPr/>
-          </p:nvSpPr>
-          <p:spPr>
-            <a:xfrm>
-              <a:off x="2327294" y="2577898"/>
-              <a:ext cx="1314421" cy="94876"/>
-            </a:xfrm>
-            <a:prstGeom prst="rect">
-              <a:avLst/>
-            </a:prstGeom>
-            <a:noFill/>
-            <a:ln/>
-          </p:spPr>
-          <p:txBody>
-            <a:bodyPr wrap="square" lIns="0" tIns="0" rIns="0" bIns="0" rtlCol="0" anchor="ctr"/>
-            <a:lstStyle/>
-            <a:p>
-              <a:pPr marL="0" indent="0" algn="ctr">
-                <a:buNone/>
-              </a:pPr>
-              <a:r>
-                <a:rPr lang="en-US" sz="2000" b="1" dirty="0">
-                  <a:solidFill>
-                    <a:srgbClr val="1E40AF"/>
-                  </a:solidFill>
-                  <a:latin typeface="ui-monospace" pitchFamily="34" charset="0"/>
-                  <a:ea typeface="ui-monospace" pitchFamily="34" charset="-122"/>
-                  <a:cs typeface="ui-monospace" pitchFamily="34" charset="-120"/>
-                </a:rPr>
-                <a:t>emailList</a:t>
-              </a:r>
-              <a:endParaRPr lang="en-US" sz="2000" dirty="0"/>
-            </a:p>
-          </p:txBody>
-        </p:sp>
-        <p:pic>
-          <p:nvPicPr>
-            <p:cNvPr id="63" name="Image 14" descr="preencoded.png"/>
-            <p:cNvPicPr>
-              <a:picLocks noChangeAspect="1"/>
-            </p:cNvPicPr>
-            <p:nvPr/>
-          </p:nvPicPr>
-          <p:blipFill>
-            <a:blip r:embed="rId15"/>
-            <a:srcRect t="-38" b="-38"/>
-            <a:stretch/>
-          </p:blipFill>
-          <p:spPr>
-            <a:xfrm>
-              <a:off x="1163117" y="2788006"/>
-              <a:ext cx="2133295" cy="247802"/>
-            </a:xfrm>
-            <a:prstGeom prst="rect">
-              <a:avLst/>
-            </a:prstGeom>
-          </p:spPr>
-        </p:pic>
-        <p:sp>
-          <p:nvSpPr>
-            <p:cNvPr id="64" name="Text 47"/>
-            <p:cNvSpPr txBox="1"/>
-            <p:nvPr/>
-          </p:nvSpPr>
-          <p:spPr>
-            <a:xfrm>
-              <a:off x="1210666" y="2836469"/>
-              <a:ext cx="1074167" cy="181618"/>
-            </a:xfrm>
-            <a:prstGeom prst="rect">
-              <a:avLst/>
-            </a:prstGeom>
-            <a:noFill/>
-            <a:ln/>
-          </p:spPr>
-          <p:txBody>
-            <a:bodyPr wrap="square" lIns="0" tIns="0" rIns="0" bIns="0" rtlCol="0" anchor="ctr"/>
-            <a:lstStyle/>
-            <a:p>
-              <a:pPr marL="0" indent="0" algn="ctr">
-                <a:buNone/>
-              </a:pPr>
-              <a:r>
-                <a:rPr lang="en-US" sz="2000" dirty="0">
-                  <a:solidFill>
-                    <a:srgbClr val="065F46"/>
-                  </a:solidFill>
-                  <a:latin typeface="ui-monospace" pitchFamily="34" charset="0"/>
-                  <a:ea typeface="ui-monospace" pitchFamily="34" charset="-122"/>
-                  <a:cs typeface="ui-monospace" pitchFamily="34" charset="-120"/>
-                </a:rPr>
-                <a:t>Current item</a:t>
-              </a:r>
-              <a:endParaRPr lang="en-US" sz="2000" dirty="0"/>
-            </a:p>
-          </p:txBody>
-        </p:sp>
-        <p:sp>
-          <p:nvSpPr>
-            <p:cNvPr id="65" name="Text 48"/>
-            <p:cNvSpPr txBox="1"/>
-            <p:nvPr/>
-          </p:nvSpPr>
-          <p:spPr>
-            <a:xfrm>
-              <a:off x="2347638" y="2853156"/>
-              <a:ext cx="1007323" cy="178161"/>
-            </a:xfrm>
-            <a:prstGeom prst="rect">
-              <a:avLst/>
-            </a:prstGeom>
-            <a:noFill/>
-            <a:ln/>
-          </p:spPr>
-          <p:txBody>
-            <a:bodyPr wrap="square" lIns="0" tIns="0" rIns="0" bIns="0" rtlCol="0" anchor="ctr"/>
-            <a:lstStyle/>
-            <a:p>
-              <a:pPr marL="0" indent="0" algn="ctr">
-                <a:buNone/>
-              </a:pPr>
-              <a:r>
-                <a:rPr lang="en-US" sz="2000" b="1" dirty="0">
-                  <a:solidFill>
-                    <a:srgbClr val="065F46"/>
-                  </a:solidFill>
-                  <a:latin typeface="ui-monospace" pitchFamily="34" charset="0"/>
-                  <a:ea typeface="ui-monospace" pitchFamily="34" charset="-122"/>
-                  <a:cs typeface="ui-monospace" pitchFamily="34" charset="-120"/>
-                </a:rPr>
-                <a:t>（各アイテム）</a:t>
-              </a:r>
-              <a:endParaRPr lang="en-US" sz="2000" dirty="0"/>
-            </a:p>
-          </p:txBody>
-        </p:sp>
-        <p:pic>
-          <p:nvPicPr>
-            <p:cNvPr id="66" name="Image 15" descr="preencoded.png"/>
-            <p:cNvPicPr>
-              <a:picLocks noChangeAspect="1"/>
-            </p:cNvPicPr>
-            <p:nvPr/>
-          </p:nvPicPr>
-          <p:blipFill>
-            <a:blip r:embed="rId16"/>
-            <a:srcRect t="-38" b="-38"/>
-            <a:stretch/>
-          </p:blipFill>
-          <p:spPr>
-            <a:xfrm>
-              <a:off x="1163117" y="3074213"/>
-              <a:ext cx="2133295" cy="247802"/>
-            </a:xfrm>
-            <a:prstGeom prst="rect">
-              <a:avLst/>
-            </a:prstGeom>
-          </p:spPr>
-        </p:pic>
-        <p:sp>
-          <p:nvSpPr>
-            <p:cNvPr id="67" name="Text 49"/>
-            <p:cNvSpPr txBox="1"/>
-            <p:nvPr/>
-          </p:nvSpPr>
-          <p:spPr>
-            <a:xfrm>
-              <a:off x="1152505" y="3080961"/>
-              <a:ext cx="1307254" cy="223470"/>
-            </a:xfrm>
-            <a:prstGeom prst="rect">
-              <a:avLst/>
-            </a:prstGeom>
-            <a:noFill/>
-            <a:ln/>
-          </p:spPr>
-          <p:txBody>
-            <a:bodyPr wrap="square" lIns="0" tIns="0" rIns="0" bIns="0" rtlCol="0" anchor="ctr"/>
-            <a:lstStyle/>
-            <a:p>
-              <a:pPr marL="0" indent="0" algn="ctr">
-                <a:buNone/>
-              </a:pPr>
-              <a:r>
-                <a:rPr lang="en-US" sz="2000" dirty="0">
-                  <a:solidFill>
-                    <a:srgbClr val="5B21B6"/>
-                  </a:solidFill>
-                  <a:latin typeface="ui-monospace" pitchFamily="34" charset="0"/>
-                  <a:ea typeface="ui-monospace" pitchFamily="34" charset="-122"/>
-                  <a:cs typeface="ui-monospace" pitchFamily="34" charset="-120"/>
-                </a:rPr>
-                <a:t>処理内容</a:t>
-              </a:r>
-              <a:endParaRPr lang="en-US" sz="2000" dirty="0"/>
-            </a:p>
-          </p:txBody>
-        </p:sp>
-        <p:sp>
-          <p:nvSpPr>
-            <p:cNvPr id="68" name="Text 50"/>
-            <p:cNvSpPr txBox="1"/>
-            <p:nvPr/>
-          </p:nvSpPr>
-          <p:spPr>
-            <a:xfrm>
-              <a:off x="2536083" y="3116068"/>
-              <a:ext cx="715523" cy="158399"/>
-            </a:xfrm>
-            <a:prstGeom prst="rect">
-              <a:avLst/>
-            </a:prstGeom>
-            <a:noFill/>
-            <a:ln/>
-          </p:spPr>
-          <p:txBody>
-            <a:bodyPr wrap="square" lIns="0" tIns="0" rIns="0" bIns="0" rtlCol="0" anchor="ctr"/>
-            <a:lstStyle/>
-            <a:p>
-              <a:pPr marL="0" indent="0" algn="ctr">
-                <a:buNone/>
-              </a:pPr>
-              <a:r>
-                <a:rPr lang="en-US" sz="2000" b="1" dirty="0">
-                  <a:solidFill>
-                    <a:srgbClr val="5B21B6"/>
-                  </a:solidFill>
-                  <a:latin typeface="ui-monospace" pitchFamily="34" charset="0"/>
-                  <a:ea typeface="ui-monospace" pitchFamily="34" charset="-122"/>
-                  <a:cs typeface="ui-monospace" pitchFamily="34" charset="-120"/>
-                </a:rPr>
-                <a:t>（各行）</a:t>
-              </a:r>
-              <a:endParaRPr lang="en-US" sz="2000" dirty="0"/>
-            </a:p>
-          </p:txBody>
-        </p:sp>
-      </p:grpSp>
-      <p:pic>
-        <p:nvPicPr>
-          <p:cNvPr id="69" name="Image 16" descr="preencoded.png"/>
-          <p:cNvPicPr>
-            <a:picLocks noChangeAspect="1"/>
-          </p:cNvPicPr>
-          <p:nvPr/>
-        </p:nvPicPr>
-        <p:blipFill>
-          <a:blip r:embed="rId17"/>
-          <a:srcRect t="-530" b="-530"/>
-          <a:stretch/>
-        </p:blipFill>
-        <p:spPr>
-          <a:xfrm>
-            <a:off x="4687523" y="2639460"/>
-            <a:ext cx="247802" cy="286207"/>
-          </a:xfrm>
-          <a:prstGeom prst="rect">
-            <a:avLst/>
-          </a:prstGeom>
-        </p:spPr>
-      </p:pic>
-      <p:sp>
-        <p:nvSpPr>
-          <p:cNvPr id="70" name="Shape 51"/>
-          <p:cNvSpPr/>
-          <p:nvPr/>
-        </p:nvSpPr>
-        <p:spPr>
-          <a:xfrm>
-            <a:off x="391607" y="5809158"/>
-            <a:ext cx="4716733" cy="834012"/>
-          </a:xfrm>
-          <a:prstGeom prst="roundRect">
-            <a:avLst>
-              <a:gd name="adj" fmla="val 19731"/>
-            </a:avLst>
-          </a:prstGeom>
-          <a:solidFill>
-            <a:srgbClr val="F3F4F6"/>
-          </a:solidFill>
-          <a:ln w="12700">
-            <a:solidFill>
-              <a:srgbClr val="E5E7EB"/>
-            </a:solidFill>
-            <a:prstDash val="solid"/>
-          </a:ln>
-        </p:spPr>
-        <p:txBody>
-          <a:bodyPr wrap="square"/>
-          <a:lstStyle/>
-          <a:p>
-            <a:endParaRPr lang="ja-JP" altLang="en-US"/>
-          </a:p>
-        </p:txBody>
-      </p:sp>
-      <p:sp>
-        <p:nvSpPr>
           <p:cNvPr id="73" name="Shape 54"/>
           <p:cNvSpPr/>
           <p:nvPr/>
@@ -17792,7 +15681,7 @@
                 <a:ea typeface="Noto Sans JP" pitchFamily="34" charset="-122"/>
                 <a:cs typeface="Noto Sans JP" pitchFamily="34" charset="-120"/>
               </a:rPr>
-              <a:t>4つのアクション　おさらいと組み合わせ方</a:t>
+              <a:t>4つのアクション　各アクションのポイント</a:t>
             </a:r>
             <a:endParaRPr lang="en-US" sz="4400" dirty="0"/>
           </a:p>
@@ -17871,40 +15760,6 @@
           </a:p>
         </p:txBody>
       </p:sp>
-      <p:sp>
-        <p:nvSpPr>
-          <p:cNvPr id="82" name="Shape 62"/>
-          <p:cNvSpPr/>
-          <p:nvPr/>
-        </p:nvSpPr>
-        <p:spPr>
-          <a:xfrm>
-            <a:off x="8939174" y="1028700"/>
-            <a:ext cx="3258007" cy="9144"/>
-          </a:xfrm>
-          <a:prstGeom prst="rect">
-            <a:avLst/>
-          </a:prstGeom>
-          <a:solidFill>
-            <a:srgbClr val="E5E7EB"/>
-          </a:solidFill>
-          <a:ln w="12700">
-            <a:solidFill>
-              <a:srgbClr val="E5E7EB">
-                <a:alpha val="0"/>
-              </a:srgbClr>
-            </a:solidFill>
-            <a:prstDash val="solid"/>
-          </a:ln>
-        </p:spPr>
-        <p:txBody>
-          <a:bodyPr wrap="square"/>
-          <a:lstStyle/>
-          <a:p>
-            <a:endParaRPr lang="ja-JP" altLang="en-US"/>
-          </a:p>
-        </p:txBody>
-      </p:sp>
       <p:pic>
         <p:nvPicPr>
           <p:cNvPr id="85" name="Image 18" descr="preencoded.png"/>
@@ -17930,153 +15785,1161 @@
       </p:pic>
       <p:sp>
         <p:nvSpPr>
-          <p:cNvPr id="20" name="Text 17"/>
-          <p:cNvSpPr txBox="1"/>
-          <p:nvPr/>
-        </p:nvSpPr>
-        <p:spPr>
-          <a:xfrm>
-            <a:off x="839467" y="5937857"/>
-            <a:ext cx="3835737" cy="313193"/>
-          </a:xfrm>
-          <a:prstGeom prst="rect">
-            <a:avLst/>
-          </a:prstGeom>
-          <a:noFill/>
-          <a:ln/>
-        </p:spPr>
-        <p:txBody>
-          <a:bodyPr wrap="square" lIns="0" tIns="0" rIns="0" bIns="0" rtlCol="0" anchor="ctr"/>
-          <a:lstStyle/>
-          <a:p>
-            <a:pPr marL="0" indent="0" algn="l">
-              <a:buNone/>
-            </a:pPr>
-            <a:endParaRPr lang="en-US" dirty="0"/>
-          </a:p>
-        </p:txBody>
-      </p:sp>
-      <p:sp>
-        <p:nvSpPr>
-          <p:cNvPr id="21" name="Text 18"/>
-          <p:cNvSpPr txBox="1"/>
-          <p:nvPr/>
-        </p:nvSpPr>
-        <p:spPr>
-          <a:xfrm>
-            <a:off x="741247" y="6358907"/>
-            <a:ext cx="5808510" cy="234462"/>
-          </a:xfrm>
-          <a:prstGeom prst="rect">
-            <a:avLst/>
-          </a:prstGeom>
-          <a:noFill/>
-          <a:ln/>
-        </p:spPr>
-        <p:txBody>
-          <a:bodyPr wrap="square" lIns="0" tIns="0" rIns="0" bIns="0" rtlCol="0" anchor="ctr"/>
-          <a:lstStyle/>
-          <a:p>
-            <a:pPr marL="0" indent="0" algn="l">
-              <a:buNone/>
-            </a:pPr>
-            <a:endParaRPr lang="en-US" sz="1600" dirty="0"/>
-          </a:p>
-        </p:txBody>
-      </p:sp>
-      <p:sp>
-        <p:nvSpPr>
-          <p:cNvPr id="97" name="Shape 51">
-            <a:extLst>
-              <a:ext uri="{FF2B5EF4-FFF2-40B4-BE49-F238E27FC236}">
-                <a16:creationId xmlns:a16="http://schemas.microsoft.com/office/drawing/2014/main" id="{108AA644-6CFF-C00A-847F-C38BBC6EEE54}"/>
-              </a:ext>
-            </a:extLst>
-          </p:cNvPr>
+          <p:cNvPr id="86" name="Rectangle 85"/>
           <p:cNvSpPr/>
           <p:nvPr/>
         </p:nvSpPr>
         <p:spPr>
           <a:xfrm>
-            <a:off x="5128355" y="2190387"/>
-            <a:ext cx="2080136" cy="1496001"/>
+            <a:off x="201168" y="1115568"/>
+            <a:ext cx="5792724" cy="2656332"/>
           </a:xfrm>
           <a:prstGeom prst="roundRect">
             <a:avLst>
-              <a:gd name="adj" fmla="val 19731"/>
+              <a:gd name="adj" fmla="val 15000"/>
             </a:avLst>
           </a:prstGeom>
           <a:solidFill>
-            <a:srgbClr val="F3F4F6"/>
+            <a:srgbClr val="F8F9FF"/>
           </a:solidFill>
           <a:ln w="12700">
             <a:solidFill>
-              <a:srgbClr val="E5E7EB"/>
+              <a:srgbClr val="CCCCDD"/>
             </a:solidFill>
-            <a:prstDash val="solid"/>
           </a:ln>
         </p:spPr>
-        <p:txBody>
-          <a:bodyPr wrap="square"/>
-          <a:lstStyle/>
-          <a:p>
-            <a:endParaRPr lang="ja-JP" altLang="en-US"/>
-          </a:p>
-        </p:txBody>
-      </p:sp>
-      <p:sp>
-        <p:nvSpPr>
-          <p:cNvPr id="72" name="Text 53"/>
+        <p:style>
+          <a:lnRef idx="1">
+            <a:schemeClr val="accent1"/>
+          </a:lnRef>
+          <a:fillRef idx="3">
+            <a:schemeClr val="accent1"/>
+          </a:fillRef>
+          <a:effectRef idx="2">
+            <a:schemeClr val="accent1"/>
+          </a:effectRef>
+          <a:fontRef idx="minor">
+            <a:schemeClr val="lt1"/>
+          </a:fontRef>
+        </p:style>
+        <p:txBody>
+          <a:bodyPr rtlCol="0" anchor="ctr"/>
+          <a:lstStyle/>
+          <a:p>
+            <a:pPr algn="ctr"/>
+          </a:p>
+        </p:txBody>
+      </p:sp>
+      <p:sp>
+        <p:nvSpPr>
+          <p:cNvPr id="87" name="Rectangle 86"/>
+          <p:cNvSpPr/>
+          <p:nvPr/>
+        </p:nvSpPr>
+        <p:spPr>
+          <a:xfrm>
+            <a:off x="201168" y="1115568"/>
+            <a:ext cx="5792724" cy="566928"/>
+          </a:xfrm>
+          <a:prstGeom prst="roundRect">
+            <a:avLst>
+              <a:gd name="adj" fmla="val 15000"/>
+            </a:avLst>
+          </a:prstGeom>
+          <a:solidFill>
+            <a:srgbClr val="1A73E8"/>
+          </a:solidFill>
+          <a:ln>
+            <a:noFill/>
+          </a:ln>
+        </p:spPr>
+        <p:style>
+          <a:lnRef idx="1">
+            <a:schemeClr val="accent1"/>
+          </a:lnRef>
+          <a:fillRef idx="3">
+            <a:schemeClr val="accent1"/>
+          </a:fillRef>
+          <a:effectRef idx="2">
+            <a:schemeClr val="accent1"/>
+          </a:effectRef>
+          <a:fontRef idx="minor">
+            <a:schemeClr val="lt1"/>
+          </a:fontRef>
+        </p:style>
+        <p:txBody>
+          <a:bodyPr rtlCol="0" anchor="ctr"/>
+          <a:lstStyle/>
+          <a:p>
+            <a:pPr algn="ctr"/>
+          </a:p>
+        </p:txBody>
+      </p:sp>
+      <p:sp>
+        <p:nvSpPr>
+          <p:cNvPr id="88" name="Rectangle 87"/>
+          <p:cNvSpPr/>
+          <p:nvPr/>
+        </p:nvSpPr>
+        <p:spPr>
+          <a:xfrm>
+            <a:off x="201168" y="1370685"/>
+            <a:ext cx="5792724" cy="311810"/>
+          </a:xfrm>
+          <a:prstGeom prst="rect">
+            <a:avLst/>
+          </a:prstGeom>
+          <a:solidFill>
+            <a:srgbClr val="1A73E8"/>
+          </a:solidFill>
+          <a:ln>
+            <a:noFill/>
+          </a:ln>
+        </p:spPr>
+        <p:style>
+          <a:lnRef idx="1">
+            <a:schemeClr val="accent1"/>
+          </a:lnRef>
+          <a:fillRef idx="3">
+            <a:schemeClr val="accent1"/>
+          </a:fillRef>
+          <a:effectRef idx="2">
+            <a:schemeClr val="accent1"/>
+          </a:effectRef>
+          <a:fontRef idx="minor">
+            <a:schemeClr val="lt1"/>
+          </a:fontRef>
+        </p:style>
+        <p:txBody>
+          <a:bodyPr rtlCol="0" anchor="ctr"/>
+          <a:lstStyle/>
+          <a:p>
+            <a:pPr algn="ctr"/>
+          </a:p>
+        </p:txBody>
+      </p:sp>
+      <p:sp>
+        <p:nvSpPr>
+          <p:cNvPr id="89" name="TextBox 88"/>
           <p:cNvSpPr txBox="1"/>
           <p:nvPr/>
         </p:nvSpPr>
         <p:spPr>
           <a:xfrm>
-            <a:off x="5219247" y="2377028"/>
-            <a:ext cx="1713130" cy="548639"/>
+            <a:off x="384048" y="1188720"/>
+            <a:ext cx="5426964" cy="292608"/>
           </a:xfrm>
           <a:prstGeom prst="rect">
             <a:avLst/>
           </a:prstGeom>
           <a:noFill/>
-          <a:ln/>
-        </p:spPr>
-        <p:txBody>
-          <a:bodyPr wrap="square" lIns="0" tIns="0" rIns="0" bIns="0" rtlCol="0" anchor="t"/>
-          <a:lstStyle/>
-          <a:p>
-            <a:pPr marL="0" indent="0" algn="ctr">
-              <a:buNone/>
+        </p:spPr>
+        <p:txBody>
+          <a:bodyPr wrap="none">
+            <a:spAutoFit/>
+          </a:bodyPr>
+          <a:lstStyle/>
+          <a:p>
+            <a:r>
+              <a:rPr sz="1800" b="1">
+                <a:solidFill>
+                  <a:srgbClr val="FFFFFF"/>
+                </a:solidFill>
+                <a:latin typeface="Segoe UI"/>
+              </a:rPr>
+              <a:t>Initialize variable</a:t>
+            </a:r>
+          </a:p>
+        </p:txBody>
+      </p:sp>
+      <p:sp>
+        <p:nvSpPr>
+          <p:cNvPr id="90" name="TextBox 89"/>
+          <p:cNvSpPr txBox="1"/>
+          <p:nvPr/>
+        </p:nvSpPr>
+        <p:spPr>
+          <a:xfrm>
+            <a:off x="384048" y="1444752"/>
+            <a:ext cx="5426964" cy="219456"/>
+          </a:xfrm>
+          <a:prstGeom prst="rect">
+            <a:avLst/>
+          </a:prstGeom>
+          <a:noFill/>
+        </p:spPr>
+        <p:txBody>
+          <a:bodyPr wrap="none">
+            <a:spAutoFit/>
+          </a:bodyPr>
+          <a:lstStyle/>
+          <a:p>
+            <a:r>
+              <a:rPr sz="1150">
+                <a:solidFill>
+                  <a:srgbClr val="FFFFCC"/>
+                </a:solidFill>
+                <a:latin typeface="Yu Gothic"/>
+              </a:rPr>
+              <a:t>変数の初期化</a:t>
+            </a:r>
+          </a:p>
+        </p:txBody>
+      </p:sp>
+      <p:sp>
+        <p:nvSpPr>
+          <p:cNvPr id="91" name="TextBox 90"/>
+          <p:cNvSpPr txBox="1"/>
+          <p:nvPr/>
+        </p:nvSpPr>
+        <p:spPr>
+          <a:xfrm>
+            <a:off x="384048" y="1773936"/>
+            <a:ext cx="5426964" cy="1979676"/>
+          </a:xfrm>
+          <a:prstGeom prst="rect">
+            <a:avLst/>
+          </a:prstGeom>
+          <a:noFill/>
+        </p:spPr>
+        <p:txBody>
+          <a:bodyPr wrap="square">
+            <a:spAutoFit/>
+          </a:bodyPr>
+          <a:lstStyle/>
+          <a:p>
+            <a:pPr algn="l">
+              <a:spcAft>
+                <a:spcPts val="120"/>
+              </a:spcAft>
             </a:pPr>
-            <a:endParaRPr lang="en-US" sz="2800" dirty="0"/>
-          </a:p>
-        </p:txBody>
-      </p:sp>
-      <p:sp>
-        <p:nvSpPr>
-          <p:cNvPr id="71" name="Text 52"/>
+            <a:r>
+              <a:rPr sz="1350">
+                <a:solidFill>
+                  <a:srgbClr val="222233"/>
+                </a:solidFill>
+                <a:latin typeface="Yu Gothic"/>
+              </a:rPr>
+              <a:t>▸  変数を使う前に必ず最初に宣言する</a:t>
+            </a:r>
+          </a:p>
+          <a:p>
+            <a:pPr algn="l">
+              <a:spcAft>
+                <a:spcPts val="120"/>
+              </a:spcAft>
+            </a:pPr>
+            <a:r>
+              <a:rPr sz="1350">
+                <a:solidFill>
+                  <a:srgbClr val="222233"/>
+                </a:solidFill>
+                <a:latin typeface="Yu Gothic"/>
+              </a:rPr>
+              <a:t>▸  型（Type）と初期値（Value）を設定</a:t>
+            </a:r>
+          </a:p>
+          <a:p>
+            <a:pPr algn="l">
+              <a:spcAft>
+                <a:spcPts val="120"/>
+              </a:spcAft>
+            </a:pPr>
+            <a:r>
+              <a:rPr sz="1350">
+                <a:solidFill>
+                  <a:srgbClr val="222233"/>
+                </a:solidFill>
+                <a:latin typeface="Yu Gothic"/>
+              </a:rPr>
+              <a:t>▸  ループの外で宣言 → フロー全体で参照可能</a:t>
+            </a:r>
+          </a:p>
+          <a:p>
+            <a:pPr algn="l">
+              <a:spcAft>
+                <a:spcPts val="120"/>
+              </a:spcAft>
+            </a:pPr>
+            <a:r>
+              <a:rPr sz="1350">
+                <a:solidFill>
+                  <a:srgbClr val="222233"/>
+                </a:solidFill>
+                <a:latin typeface="Yu Gothic"/>
+              </a:rPr>
+              <a:t>▸  よく使う型：Integer / String / Boolean</a:t>
+            </a:r>
+          </a:p>
+        </p:txBody>
+      </p:sp>
+      <p:sp>
+        <p:nvSpPr>
+          <p:cNvPr id="92" name="Rectangle 91"/>
+          <p:cNvSpPr/>
+          <p:nvPr/>
+        </p:nvSpPr>
+        <p:spPr>
+          <a:xfrm>
+            <a:off x="6195059" y="1115568"/>
+            <a:ext cx="5792724" cy="2656332"/>
+          </a:xfrm>
+          <a:prstGeom prst="roundRect">
+            <a:avLst>
+              <a:gd name="adj" fmla="val 15000"/>
+            </a:avLst>
+          </a:prstGeom>
+          <a:solidFill>
+            <a:srgbClr val="F8F9FF"/>
+          </a:solidFill>
+          <a:ln w="12700">
+            <a:solidFill>
+              <a:srgbClr val="CCCCDD"/>
+            </a:solidFill>
+          </a:ln>
+        </p:spPr>
+        <p:style>
+          <a:lnRef idx="1">
+            <a:schemeClr val="accent1"/>
+          </a:lnRef>
+          <a:fillRef idx="3">
+            <a:schemeClr val="accent1"/>
+          </a:fillRef>
+          <a:effectRef idx="2">
+            <a:schemeClr val="accent1"/>
+          </a:effectRef>
+          <a:fontRef idx="minor">
+            <a:schemeClr val="lt1"/>
+          </a:fontRef>
+        </p:style>
+        <p:txBody>
+          <a:bodyPr rtlCol="0" anchor="ctr"/>
+          <a:lstStyle/>
+          <a:p>
+            <a:pPr algn="ctr"/>
+          </a:p>
+        </p:txBody>
+      </p:sp>
+      <p:sp>
+        <p:nvSpPr>
+          <p:cNvPr id="93" name="Rectangle 92"/>
+          <p:cNvSpPr/>
+          <p:nvPr/>
+        </p:nvSpPr>
+        <p:spPr>
+          <a:xfrm>
+            <a:off x="6195059" y="1115568"/>
+            <a:ext cx="5792724" cy="566928"/>
+          </a:xfrm>
+          <a:prstGeom prst="roundRect">
+            <a:avLst>
+              <a:gd name="adj" fmla="val 15000"/>
+            </a:avLst>
+          </a:prstGeom>
+          <a:solidFill>
+            <a:srgbClr val="E67E00"/>
+          </a:solidFill>
+          <a:ln>
+            <a:noFill/>
+          </a:ln>
+        </p:spPr>
+        <p:style>
+          <a:lnRef idx="1">
+            <a:schemeClr val="accent1"/>
+          </a:lnRef>
+          <a:fillRef idx="3">
+            <a:schemeClr val="accent1"/>
+          </a:fillRef>
+          <a:effectRef idx="2">
+            <a:schemeClr val="accent1"/>
+          </a:effectRef>
+          <a:fontRef idx="minor">
+            <a:schemeClr val="lt1"/>
+          </a:fontRef>
+        </p:style>
+        <p:txBody>
+          <a:bodyPr rtlCol="0" anchor="ctr"/>
+          <a:lstStyle/>
+          <a:p>
+            <a:pPr algn="ctr"/>
+          </a:p>
+        </p:txBody>
+      </p:sp>
+      <p:sp>
+        <p:nvSpPr>
+          <p:cNvPr id="94" name="Rectangle 93"/>
+          <p:cNvSpPr/>
+          <p:nvPr/>
+        </p:nvSpPr>
+        <p:spPr>
+          <a:xfrm>
+            <a:off x="6195059" y="1370685"/>
+            <a:ext cx="5792724" cy="311810"/>
+          </a:xfrm>
+          <a:prstGeom prst="rect">
+            <a:avLst/>
+          </a:prstGeom>
+          <a:solidFill>
+            <a:srgbClr val="E67E00"/>
+          </a:solidFill>
+          <a:ln>
+            <a:noFill/>
+          </a:ln>
+        </p:spPr>
+        <p:style>
+          <a:lnRef idx="1">
+            <a:schemeClr val="accent1"/>
+          </a:lnRef>
+          <a:fillRef idx="3">
+            <a:schemeClr val="accent1"/>
+          </a:fillRef>
+          <a:effectRef idx="2">
+            <a:schemeClr val="accent1"/>
+          </a:effectRef>
+          <a:fontRef idx="minor">
+            <a:schemeClr val="lt1"/>
+          </a:fontRef>
+        </p:style>
+        <p:txBody>
+          <a:bodyPr rtlCol="0" anchor="ctr"/>
+          <a:lstStyle/>
+          <a:p>
+            <a:pPr algn="ctr"/>
+          </a:p>
+        </p:txBody>
+      </p:sp>
+      <p:sp>
+        <p:nvSpPr>
+          <p:cNvPr id="95" name="TextBox 94"/>
           <p:cNvSpPr txBox="1"/>
           <p:nvPr/>
         </p:nvSpPr>
         <p:spPr>
           <a:xfrm>
-            <a:off x="5208481" y="3084420"/>
-            <a:ext cx="1774731" cy="183246"/>
+            <a:off x="6377940" y="1188720"/>
+            <a:ext cx="5426964" cy="292608"/>
           </a:xfrm>
           <a:prstGeom prst="rect">
             <a:avLst/>
           </a:prstGeom>
           <a:noFill/>
-          <a:ln/>
-        </p:spPr>
-        <p:txBody>
-          <a:bodyPr wrap="square" lIns="0" tIns="0" rIns="0" bIns="0" rtlCol="0" anchor="ctr"/>
-          <a:lstStyle/>
-          <a:p>
-            <a:pPr marL="0" indent="0" algn="ctr">
-              <a:buNone/>
+        </p:spPr>
+        <p:txBody>
+          <a:bodyPr wrap="none">
+            <a:spAutoFit/>
+          </a:bodyPr>
+          <a:lstStyle/>
+          <a:p>
+            <a:r>
+              <a:rPr sz="1800" b="1">
+                <a:solidFill>
+                  <a:srgbClr val="FFFFFF"/>
+                </a:solidFill>
+                <a:latin typeface="Segoe UI"/>
+              </a:rPr>
+              <a:t>Compose</a:t>
+            </a:r>
+          </a:p>
+        </p:txBody>
+      </p:sp>
+      <p:sp>
+        <p:nvSpPr>
+          <p:cNvPr id="96" name="TextBox 95"/>
+          <p:cNvSpPr txBox="1"/>
+          <p:nvPr/>
+        </p:nvSpPr>
+        <p:spPr>
+          <a:xfrm>
+            <a:off x="6377940" y="1444752"/>
+            <a:ext cx="5426964" cy="219456"/>
+          </a:xfrm>
+          <a:prstGeom prst="rect">
+            <a:avLst/>
+          </a:prstGeom>
+          <a:noFill/>
+        </p:spPr>
+        <p:txBody>
+          <a:bodyPr wrap="none">
+            <a:spAutoFit/>
+          </a:bodyPr>
+          <a:lstStyle/>
+          <a:p>
+            <a:r>
+              <a:rPr sz="1150">
+                <a:solidFill>
+                  <a:srgbClr val="FFFFCC"/>
+                </a:solidFill>
+                <a:latin typeface="Yu Gothic"/>
+              </a:rPr>
+              <a:t>作成（値の組み立て）</a:t>
+            </a:r>
+          </a:p>
+        </p:txBody>
+      </p:sp>
+      <p:sp>
+        <p:nvSpPr>
+          <p:cNvPr id="97" name="TextBox 96"/>
+          <p:cNvSpPr txBox="1"/>
+          <p:nvPr/>
+        </p:nvSpPr>
+        <p:spPr>
+          <a:xfrm>
+            <a:off x="6377940" y="1773936"/>
+            <a:ext cx="5426964" cy="1979676"/>
+          </a:xfrm>
+          <a:prstGeom prst="rect">
+            <a:avLst/>
+          </a:prstGeom>
+          <a:noFill/>
+        </p:spPr>
+        <p:txBody>
+          <a:bodyPr wrap="square">
+            <a:spAutoFit/>
+          </a:bodyPr>
+          <a:lstStyle/>
+          <a:p>
+            <a:pPr algn="l">
+              <a:spcAft>
+                <a:spcPts val="120"/>
+              </a:spcAft>
             </a:pPr>
-            <a:endParaRPr lang="en-US" sz="2400" dirty="0"/>
+            <a:r>
+              <a:rPr sz="1350">
+                <a:solidFill>
+                  <a:srgbClr val="222233"/>
+                </a:solidFill>
+                <a:latin typeface="Yu Gothic"/>
+              </a:rPr>
+              <a:t>▸  式や値を「その場で組み立てる」アクション</a:t>
+            </a:r>
+          </a:p>
+          <a:p>
+            <a:pPr algn="l">
+              <a:spcAft>
+                <a:spcPts val="120"/>
+              </a:spcAft>
+            </a:pPr>
+            <a:r>
+              <a:rPr sz="1350">
+                <a:solidFill>
+                  <a:srgbClr val="222233"/>
+                </a:solidFill>
+                <a:latin typeface="Yu Gothic"/>
+              </a:rPr>
+              <a:t>▸  変数を作らずに式の結果を一時保持できる</a:t>
+            </a:r>
+          </a:p>
+          <a:p>
+            <a:pPr algn="l">
+              <a:spcAft>
+                <a:spcPts val="120"/>
+              </a:spcAft>
+            </a:pPr>
+            <a:r>
+              <a:rPr sz="1350">
+                <a:solidFill>
+                  <a:srgbClr val="222233"/>
+                </a:solidFill>
+                <a:latin typeface="Yu Gothic"/>
+              </a:rPr>
+              <a:t>▸  後から outputs('Compose') で参照可能</a:t>
+            </a:r>
+          </a:p>
+          <a:p>
+            <a:pPr algn="l">
+              <a:spcAft>
+                <a:spcPts val="120"/>
+              </a:spcAft>
+            </a:pPr>
+            <a:r>
+              <a:rPr sz="1350">
+                <a:solidFill>
+                  <a:srgbClr val="222233"/>
+                </a:solidFill>
+                <a:latin typeface="Yu Gothic"/>
+              </a:rPr>
+              <a:t>▸  複雑な式を分解・整理するときに便利</a:t>
+            </a:r>
+          </a:p>
+        </p:txBody>
+      </p:sp>
+      <p:sp>
+        <p:nvSpPr>
+          <p:cNvPr id="98" name="Rectangle 97"/>
+          <p:cNvSpPr/>
+          <p:nvPr/>
+        </p:nvSpPr>
+        <p:spPr>
+          <a:xfrm>
+            <a:off x="201168" y="3973068"/>
+            <a:ext cx="5792724" cy="2656332"/>
+          </a:xfrm>
+          <a:prstGeom prst="roundRect">
+            <a:avLst>
+              <a:gd name="adj" fmla="val 15000"/>
+            </a:avLst>
+          </a:prstGeom>
+          <a:solidFill>
+            <a:srgbClr val="F8F9FF"/>
+          </a:solidFill>
+          <a:ln w="12700">
+            <a:solidFill>
+              <a:srgbClr val="CCCCDD"/>
+            </a:solidFill>
+          </a:ln>
+        </p:spPr>
+        <p:style>
+          <a:lnRef idx="1">
+            <a:schemeClr val="accent1"/>
+          </a:lnRef>
+          <a:fillRef idx="3">
+            <a:schemeClr val="accent1"/>
+          </a:fillRef>
+          <a:effectRef idx="2">
+            <a:schemeClr val="accent1"/>
+          </a:effectRef>
+          <a:fontRef idx="minor">
+            <a:schemeClr val="lt1"/>
+          </a:fontRef>
+        </p:style>
+        <p:txBody>
+          <a:bodyPr rtlCol="0" anchor="ctr"/>
+          <a:lstStyle/>
+          <a:p>
+            <a:pPr algn="ctr"/>
+          </a:p>
+        </p:txBody>
+      </p:sp>
+      <p:sp>
+        <p:nvSpPr>
+          <p:cNvPr id="99" name="Rectangle 98"/>
+          <p:cNvSpPr/>
+          <p:nvPr/>
+        </p:nvSpPr>
+        <p:spPr>
+          <a:xfrm>
+            <a:off x="201168" y="3973068"/>
+            <a:ext cx="5792724" cy="566928"/>
+          </a:xfrm>
+          <a:prstGeom prst="roundRect">
+            <a:avLst>
+              <a:gd name="adj" fmla="val 15000"/>
+            </a:avLst>
+          </a:prstGeom>
+          <a:solidFill>
+            <a:srgbClr val="00897B"/>
+          </a:solidFill>
+          <a:ln>
+            <a:noFill/>
+          </a:ln>
+        </p:spPr>
+        <p:style>
+          <a:lnRef idx="1">
+            <a:schemeClr val="accent1"/>
+          </a:lnRef>
+          <a:fillRef idx="3">
+            <a:schemeClr val="accent1"/>
+          </a:fillRef>
+          <a:effectRef idx="2">
+            <a:schemeClr val="accent1"/>
+          </a:effectRef>
+          <a:fontRef idx="minor">
+            <a:schemeClr val="lt1"/>
+          </a:fontRef>
+        </p:style>
+        <p:txBody>
+          <a:bodyPr rtlCol="0" anchor="ctr"/>
+          <a:lstStyle/>
+          <a:p>
+            <a:pPr algn="ctr"/>
+          </a:p>
+        </p:txBody>
+      </p:sp>
+      <p:sp>
+        <p:nvSpPr>
+          <p:cNvPr id="100" name="Rectangle 99"/>
+          <p:cNvSpPr/>
+          <p:nvPr/>
+        </p:nvSpPr>
+        <p:spPr>
+          <a:xfrm>
+            <a:off x="201168" y="4228185"/>
+            <a:ext cx="5792724" cy="311810"/>
+          </a:xfrm>
+          <a:prstGeom prst="rect">
+            <a:avLst/>
+          </a:prstGeom>
+          <a:solidFill>
+            <a:srgbClr val="00897B"/>
+          </a:solidFill>
+          <a:ln>
+            <a:noFill/>
+          </a:ln>
+        </p:spPr>
+        <p:style>
+          <a:lnRef idx="1">
+            <a:schemeClr val="accent1"/>
+          </a:lnRef>
+          <a:fillRef idx="3">
+            <a:schemeClr val="accent1"/>
+          </a:fillRef>
+          <a:effectRef idx="2">
+            <a:schemeClr val="accent1"/>
+          </a:effectRef>
+          <a:fontRef idx="minor">
+            <a:schemeClr val="lt1"/>
+          </a:fontRef>
+        </p:style>
+        <p:txBody>
+          <a:bodyPr rtlCol="0" anchor="ctr"/>
+          <a:lstStyle/>
+          <a:p>
+            <a:pPr algn="ctr"/>
+          </a:p>
+        </p:txBody>
+      </p:sp>
+      <p:sp>
+        <p:nvSpPr>
+          <p:cNvPr id="101" name="TextBox 100"/>
+          <p:cNvSpPr txBox="1"/>
+          <p:nvPr/>
+        </p:nvSpPr>
+        <p:spPr>
+          <a:xfrm>
+            <a:off x="384048" y="4046220"/>
+            <a:ext cx="5426964" cy="292608"/>
+          </a:xfrm>
+          <a:prstGeom prst="rect">
+            <a:avLst/>
+          </a:prstGeom>
+          <a:noFill/>
+        </p:spPr>
+        <p:txBody>
+          <a:bodyPr wrap="none">
+            <a:spAutoFit/>
+          </a:bodyPr>
+          <a:lstStyle/>
+          <a:p>
+            <a:r>
+              <a:rPr sz="1800" b="1">
+                <a:solidFill>
+                  <a:srgbClr val="FFFFFF"/>
+                </a:solidFill>
+                <a:latin typeface="Segoe UI"/>
+              </a:rPr>
+              <a:t>Apply to each</a:t>
+            </a:r>
+          </a:p>
+        </p:txBody>
+      </p:sp>
+      <p:sp>
+        <p:nvSpPr>
+          <p:cNvPr id="102" name="TextBox 101"/>
+          <p:cNvSpPr txBox="1"/>
+          <p:nvPr/>
+        </p:nvSpPr>
+        <p:spPr>
+          <a:xfrm>
+            <a:off x="384048" y="4302252"/>
+            <a:ext cx="5426964" cy="219456"/>
+          </a:xfrm>
+          <a:prstGeom prst="rect">
+            <a:avLst/>
+          </a:prstGeom>
+          <a:noFill/>
+        </p:spPr>
+        <p:txBody>
+          <a:bodyPr wrap="none">
+            <a:spAutoFit/>
+          </a:bodyPr>
+          <a:lstStyle/>
+          <a:p>
+            <a:r>
+              <a:rPr sz="1150">
+                <a:solidFill>
+                  <a:srgbClr val="FFFFCC"/>
+                </a:solidFill>
+                <a:latin typeface="Yu Gothic"/>
+              </a:rPr>
+              <a:t>繰り返し処理</a:t>
+            </a:r>
+          </a:p>
+        </p:txBody>
+      </p:sp>
+      <p:sp>
+        <p:nvSpPr>
+          <p:cNvPr id="103" name="TextBox 102"/>
+          <p:cNvSpPr txBox="1"/>
+          <p:nvPr/>
+        </p:nvSpPr>
+        <p:spPr>
+          <a:xfrm>
+            <a:off x="384048" y="4631436"/>
+            <a:ext cx="5426964" cy="1979676"/>
+          </a:xfrm>
+          <a:prstGeom prst="rect">
+            <a:avLst/>
+          </a:prstGeom>
+          <a:noFill/>
+        </p:spPr>
+        <p:txBody>
+          <a:bodyPr wrap="square">
+            <a:spAutoFit/>
+          </a:bodyPr>
+          <a:lstStyle/>
+          <a:p>
+            <a:pPr algn="l">
+              <a:spcAft>
+                <a:spcPts val="120"/>
+              </a:spcAft>
+            </a:pPr>
+            <a:r>
+              <a:rPr sz="1350">
+                <a:solidFill>
+                  <a:srgbClr val="222233"/>
+                </a:solidFill>
+                <a:latin typeface="Yu Gothic"/>
+              </a:rPr>
+              <a:t>▸  配列の中身を1件ずつ繰り返し処理するループ</a:t>
+            </a:r>
+          </a:p>
+          <a:p>
+            <a:pPr algn="l">
+              <a:spcAft>
+                <a:spcPts val="120"/>
+              </a:spcAft>
+            </a:pPr>
+            <a:r>
+              <a:rPr sz="1350">
+                <a:solidFill>
+                  <a:srgbClr val="222233"/>
+                </a:solidFill>
+                <a:latin typeface="Yu Gothic"/>
+              </a:rPr>
+              <a:t>▸  Current item で「今処理中の1件」を参照</a:t>
+            </a:r>
+          </a:p>
+          <a:p>
+            <a:pPr algn="l">
+              <a:spcAft>
+                <a:spcPts val="120"/>
+              </a:spcAft>
+            </a:pPr>
+            <a:r>
+              <a:rPr sz="1350">
+                <a:solidFill>
+                  <a:srgbClr val="222233"/>
+                </a:solidFill>
+                <a:latin typeface="Yu Gothic"/>
+              </a:rPr>
+              <a:t>▸  Condition と組み合わせて絞り込みができる</a:t>
+            </a:r>
+          </a:p>
+          <a:p>
+            <a:pPr algn="l">
+              <a:spcAft>
+                <a:spcPts val="120"/>
+              </a:spcAft>
+            </a:pPr>
+            <a:r>
+              <a:rPr sz="1350">
+                <a:solidFill>
+                  <a:srgbClr val="222233"/>
+                </a:solidFill>
+                <a:latin typeface="Yu Gothic"/>
+              </a:rPr>
+              <a:t>▸  変数はループの外（前）で初期化しておく</a:t>
+            </a:r>
+          </a:p>
+        </p:txBody>
+      </p:sp>
+      <p:sp>
+        <p:nvSpPr>
+          <p:cNvPr id="104" name="Rectangle 103"/>
+          <p:cNvSpPr/>
+          <p:nvPr/>
+        </p:nvSpPr>
+        <p:spPr>
+          <a:xfrm>
+            <a:off x="6195059" y="3973068"/>
+            <a:ext cx="5792724" cy="2656332"/>
+          </a:xfrm>
+          <a:prstGeom prst="roundRect">
+            <a:avLst>
+              <a:gd name="adj" fmla="val 15000"/>
+            </a:avLst>
+          </a:prstGeom>
+          <a:solidFill>
+            <a:srgbClr val="F8F9FF"/>
+          </a:solidFill>
+          <a:ln w="12700">
+            <a:solidFill>
+              <a:srgbClr val="CCCCDD"/>
+            </a:solidFill>
+          </a:ln>
+        </p:spPr>
+        <p:style>
+          <a:lnRef idx="1">
+            <a:schemeClr val="accent1"/>
+          </a:lnRef>
+          <a:fillRef idx="3">
+            <a:schemeClr val="accent1"/>
+          </a:fillRef>
+          <a:effectRef idx="2">
+            <a:schemeClr val="accent1"/>
+          </a:effectRef>
+          <a:fontRef idx="minor">
+            <a:schemeClr val="lt1"/>
+          </a:fontRef>
+        </p:style>
+        <p:txBody>
+          <a:bodyPr rtlCol="0" anchor="ctr"/>
+          <a:lstStyle/>
+          <a:p>
+            <a:pPr algn="ctr"/>
+          </a:p>
+        </p:txBody>
+      </p:sp>
+      <p:sp>
+        <p:nvSpPr>
+          <p:cNvPr id="105" name="Rectangle 104"/>
+          <p:cNvSpPr/>
+          <p:nvPr/>
+        </p:nvSpPr>
+        <p:spPr>
+          <a:xfrm>
+            <a:off x="6195059" y="3973068"/>
+            <a:ext cx="5792724" cy="566928"/>
+          </a:xfrm>
+          <a:prstGeom prst="roundRect">
+            <a:avLst>
+              <a:gd name="adj" fmla="val 15000"/>
+            </a:avLst>
+          </a:prstGeom>
+          <a:solidFill>
+            <a:srgbClr val="8E24AA"/>
+          </a:solidFill>
+          <a:ln>
+            <a:noFill/>
+          </a:ln>
+        </p:spPr>
+        <p:style>
+          <a:lnRef idx="1">
+            <a:schemeClr val="accent1"/>
+          </a:lnRef>
+          <a:fillRef idx="3">
+            <a:schemeClr val="accent1"/>
+          </a:fillRef>
+          <a:effectRef idx="2">
+            <a:schemeClr val="accent1"/>
+          </a:effectRef>
+          <a:fontRef idx="minor">
+            <a:schemeClr val="lt1"/>
+          </a:fontRef>
+        </p:style>
+        <p:txBody>
+          <a:bodyPr rtlCol="0" anchor="ctr"/>
+          <a:lstStyle/>
+          <a:p>
+            <a:pPr algn="ctr"/>
+          </a:p>
+        </p:txBody>
+      </p:sp>
+      <p:sp>
+        <p:nvSpPr>
+          <p:cNvPr id="106" name="Rectangle 105"/>
+          <p:cNvSpPr/>
+          <p:nvPr/>
+        </p:nvSpPr>
+        <p:spPr>
+          <a:xfrm>
+            <a:off x="6195059" y="4228185"/>
+            <a:ext cx="5792724" cy="311810"/>
+          </a:xfrm>
+          <a:prstGeom prst="rect">
+            <a:avLst/>
+          </a:prstGeom>
+          <a:solidFill>
+            <a:srgbClr val="8E24AA"/>
+          </a:solidFill>
+          <a:ln>
+            <a:noFill/>
+          </a:ln>
+        </p:spPr>
+        <p:style>
+          <a:lnRef idx="1">
+            <a:schemeClr val="accent1"/>
+          </a:lnRef>
+          <a:fillRef idx="3">
+            <a:schemeClr val="accent1"/>
+          </a:fillRef>
+          <a:effectRef idx="2">
+            <a:schemeClr val="accent1"/>
+          </a:effectRef>
+          <a:fontRef idx="minor">
+            <a:schemeClr val="lt1"/>
+          </a:fontRef>
+        </p:style>
+        <p:txBody>
+          <a:bodyPr rtlCol="0" anchor="ctr"/>
+          <a:lstStyle/>
+          <a:p>
+            <a:pPr algn="ctr"/>
+          </a:p>
+        </p:txBody>
+      </p:sp>
+      <p:sp>
+        <p:nvSpPr>
+          <p:cNvPr id="107" name="TextBox 106"/>
+          <p:cNvSpPr txBox="1"/>
+          <p:nvPr/>
+        </p:nvSpPr>
+        <p:spPr>
+          <a:xfrm>
+            <a:off x="6377940" y="4046220"/>
+            <a:ext cx="5426964" cy="292608"/>
+          </a:xfrm>
+          <a:prstGeom prst="rect">
+            <a:avLst/>
+          </a:prstGeom>
+          <a:noFill/>
+        </p:spPr>
+        <p:txBody>
+          <a:bodyPr wrap="none">
+            <a:spAutoFit/>
+          </a:bodyPr>
+          <a:lstStyle/>
+          <a:p>
+            <a:r>
+              <a:rPr sz="1800" b="1">
+                <a:solidFill>
+                  <a:srgbClr val="FFFFFF"/>
+                </a:solidFill>
+                <a:latin typeface="Segoe UI"/>
+              </a:rPr>
+              <a:t>Condition</a:t>
+            </a:r>
+          </a:p>
+        </p:txBody>
+      </p:sp>
+      <p:sp>
+        <p:nvSpPr>
+          <p:cNvPr id="108" name="TextBox 107"/>
+          <p:cNvSpPr txBox="1"/>
+          <p:nvPr/>
+        </p:nvSpPr>
+        <p:spPr>
+          <a:xfrm>
+            <a:off x="6377940" y="4302252"/>
+            <a:ext cx="5426964" cy="219456"/>
+          </a:xfrm>
+          <a:prstGeom prst="rect">
+            <a:avLst/>
+          </a:prstGeom>
+          <a:noFill/>
+        </p:spPr>
+        <p:txBody>
+          <a:bodyPr wrap="none">
+            <a:spAutoFit/>
+          </a:bodyPr>
+          <a:lstStyle/>
+          <a:p>
+            <a:r>
+              <a:rPr sz="1150">
+                <a:solidFill>
+                  <a:srgbClr val="FFFFCC"/>
+                </a:solidFill>
+                <a:latin typeface="Yu Gothic"/>
+              </a:rPr>
+              <a:t>条件分岐</a:t>
+            </a:r>
+          </a:p>
+        </p:txBody>
+      </p:sp>
+      <p:sp>
+        <p:nvSpPr>
+          <p:cNvPr id="109" name="TextBox 108"/>
+          <p:cNvSpPr txBox="1"/>
+          <p:nvPr/>
+        </p:nvSpPr>
+        <p:spPr>
+          <a:xfrm>
+            <a:off x="6377940" y="4631436"/>
+            <a:ext cx="5426964" cy="1979676"/>
+          </a:xfrm>
+          <a:prstGeom prst="rect">
+            <a:avLst/>
+          </a:prstGeom>
+          <a:noFill/>
+        </p:spPr>
+        <p:txBody>
+          <a:bodyPr wrap="square">
+            <a:spAutoFit/>
+          </a:bodyPr>
+          <a:lstStyle/>
+          <a:p>
+            <a:pPr algn="l">
+              <a:spcAft>
+                <a:spcPts val="120"/>
+              </a:spcAft>
+            </a:pPr>
+            <a:r>
+              <a:rPr sz="1350">
+                <a:solidFill>
+                  <a:srgbClr val="222233"/>
+                </a:solidFill>
+                <a:latin typeface="Yu Gothic"/>
+              </a:rPr>
+              <a:t>▸  条件に応じて「はい／いいえ」で処理を分岐</a:t>
+            </a:r>
+          </a:p>
+          <a:p>
+            <a:pPr algn="l">
+              <a:spcAft>
+                <a:spcPts val="120"/>
+              </a:spcAft>
+            </a:pPr>
+            <a:r>
+              <a:rPr sz="1350">
+                <a:solidFill>
+                  <a:srgbClr val="222233"/>
+                </a:solidFill>
+                <a:latin typeface="Yu Gothic"/>
+              </a:rPr>
+              <a:t>▸  比較演算子：equal to / greater than / contains</a:t>
+            </a:r>
+          </a:p>
+          <a:p>
+            <a:pPr algn="l">
+              <a:spcAft>
+                <a:spcPts val="120"/>
+              </a:spcAft>
+            </a:pPr>
+            <a:r>
+              <a:rPr sz="1350">
+                <a:solidFill>
+                  <a:srgbClr val="222233"/>
+                </a:solidFill>
+                <a:latin typeface="Yu Gothic"/>
+              </a:rPr>
+              <a:t>▸  複数条件は AND / OR で結合できる</a:t>
+            </a:r>
+          </a:p>
+          <a:p>
+            <a:pPr algn="l">
+              <a:spcAft>
+                <a:spcPts val="120"/>
+              </a:spcAft>
+            </a:pPr>
+            <a:r>
+              <a:rPr sz="1350">
+                <a:solidFill>
+                  <a:srgbClr val="222233"/>
+                </a:solidFill>
+                <a:latin typeface="Yu Gothic"/>
+              </a:rPr>
+              <a:t>▸  入れ子（ネスト）にして多段階分岐も可能</a:t>
+            </a:r>
           </a:p>
         </p:txBody>
       </p:sp>

</xml_diff>

<commit_message>
style: update overview slide - light bg, pastel cards, larger fonts
White background, light pastel card colors, font sizes enlarged
for better readability. Matches existing PA45 slide color style.

Co-Authored-By: Claude Sonnet 4.6 <noreply@anthropic.com>
</commit_message>
<xml_diff>
--- a/assets/pa45/P005_PA45_MatomeFuro_20260409.pptx
+++ b/assets/pa45/P005_PA45_MatomeFuro_20260409.pptx
@@ -8373,7 +8373,7 @@
             <a:avLst/>
           </a:prstGeom>
           <a:solidFill>
-            <a:srgbClr val="0D1B4B"/>
+            <a:srgbClr val="FFFFFF"/>
           </a:solidFill>
           <a:ln>
             <a:noFill/>
@@ -8416,7 +8416,7 @@
             <a:avLst/>
           </a:prstGeom>
           <a:solidFill>
-            <a:srgbClr val="1A3A8F"/>
+            <a:srgbClr val="1A2A6C"/>
           </a:solidFill>
           <a:ln>
             <a:noFill/>
@@ -8459,7 +8459,7 @@
             <a:avLst/>
           </a:prstGeom>
           <a:solidFill>
-            <a:srgbClr val="4C9BFF"/>
+            <a:srgbClr val="5BA3F5"/>
           </a:solidFill>
           <a:ln>
             <a:noFill/>
@@ -8496,7 +8496,7 @@
         <p:spPr>
           <a:xfrm>
             <a:off x="411480" y="91440"/>
-            <a:ext cx="5486400" cy="256032"/>
+            <a:ext cx="5486400" cy="237744"/>
           </a:xfrm>
           <a:prstGeom prst="rect">
             <a:avLst/>
@@ -8511,7 +8511,7 @@
           <a:p>
             <a:pPr algn="l"/>
             <a:r>
-              <a:rPr sz="1200" b="0" i="0">
+              <a:rPr sz="1300" b="0">
                 <a:solidFill>
                   <a:srgbClr val="AACCFF"/>
                 </a:solidFill>
@@ -8530,8 +8530,8 @@
         </p:nvSpPr>
         <p:spPr>
           <a:xfrm>
-            <a:off x="411480" y="329184"/>
-            <a:ext cx="8229600" cy="548640"/>
+            <a:off x="411480" y="274320"/>
+            <a:ext cx="8686800" cy="640080"/>
           </a:xfrm>
           <a:prstGeom prst="rect">
             <a:avLst/>
@@ -8546,7 +8546,7 @@
           <a:p>
             <a:pPr algn="l"/>
             <a:r>
-              <a:rPr sz="2600" b="1" i="0">
+              <a:rPr sz="3100" b="1">
                 <a:solidFill>
                   <a:srgbClr val="FFFFFF"/>
                 </a:solidFill>
@@ -8565,8 +8565,8 @@
         </p:nvSpPr>
         <p:spPr>
           <a:xfrm>
-            <a:off x="10927080" y="438912"/>
-            <a:ext cx="1005840" cy="256032"/>
+            <a:off x="10881360" y="402336"/>
+            <a:ext cx="1078992" cy="274320"/>
           </a:xfrm>
           <a:prstGeom prst="roundRect">
             <a:avLst>
@@ -8574,7 +8574,7 @@
             </a:avLst>
           </a:prstGeom>
           <a:solidFill>
-            <a:srgbClr val="4C9BFF"/>
+            <a:srgbClr val="5BA3F5"/>
           </a:solidFill>
           <a:ln>
             <a:noFill/>
@@ -8610,8 +8610,8 @@
         </p:nvSpPr>
         <p:spPr>
           <a:xfrm>
-            <a:off x="10954512" y="448056"/>
-            <a:ext cx="969264" cy="237744"/>
+            <a:off x="10899648" y="411480"/>
+            <a:ext cx="1042415" cy="256032"/>
           </a:xfrm>
           <a:prstGeom prst="rect">
             <a:avLst/>
@@ -8626,7 +8626,7 @@
           <a:p>
             <a:pPr algn="ctr"/>
             <a:r>
-              <a:rPr sz="1100" b="1" i="0">
+              <a:rPr sz="1100" b="1">
                 <a:solidFill>
                   <a:srgbClr val="FFFFFF"/>
                 </a:solidFill>
@@ -8645,8 +8645,8 @@
         </p:nvSpPr>
         <p:spPr>
           <a:xfrm>
-            <a:off x="411480" y="1097280"/>
-            <a:ext cx="11430000" cy="640080"/>
+            <a:off x="365760" y="1078992"/>
+            <a:ext cx="11521440" cy="548640"/>
           </a:xfrm>
           <a:prstGeom prst="rect">
             <a:avLst/>
@@ -8661,9 +8661,9 @@
           <a:p>
             <a:pPr algn="ctr"/>
             <a:r>
-              <a:rPr sz="1700" b="0" i="0">
+              <a:rPr sz="1700" b="0">
                 <a:solidFill>
-                  <a:srgbClr val="CCDDFF"/>
+                  <a:srgbClr val="2C3E80"/>
                 </a:solidFill>
                 <a:latin typeface="Yu Gothic"/>
               </a:rPr>
@@ -8680,8 +8680,8 @@
         </p:nvSpPr>
         <p:spPr>
           <a:xfrm>
-            <a:off x="274320" y="1783080"/>
-            <a:ext cx="1962302" cy="2560320"/>
+            <a:off x="274320" y="1691640"/>
+            <a:ext cx="1976932" cy="2743200"/>
           </a:xfrm>
           <a:prstGeom prst="roundRect">
             <a:avLst>
@@ -8689,11 +8689,11 @@
             </a:avLst>
           </a:prstGeom>
           <a:solidFill>
-            <a:srgbClr val="163D28"/>
+            <a:srgbClr val="EAF7F0"/>
           </a:solidFill>
-          <a:ln w="19050">
+          <a:ln w="15875">
             <a:solidFill>
-              <a:srgbClr val="1D6F42"/>
+              <a:srgbClr val="1D7A4A"/>
             </a:solidFill>
           </a:ln>
         </p:spPr>
@@ -8727,8 +8727,8 @@
         </p:nvSpPr>
         <p:spPr>
           <a:xfrm>
-            <a:off x="274320" y="1783080"/>
-            <a:ext cx="1962302" cy="685800"/>
+            <a:off x="274320" y="1691640"/>
+            <a:ext cx="1976932" cy="640080"/>
           </a:xfrm>
           <a:prstGeom prst="roundRect">
             <a:avLst>
@@ -8736,7 +8736,7 @@
             </a:avLst>
           </a:prstGeom>
           <a:solidFill>
-            <a:srgbClr val="1D6F42"/>
+            <a:srgbClr val="1D7A4A"/>
           </a:solidFill>
           <a:ln>
             <a:noFill/>
@@ -8772,14 +8772,14 @@
         </p:nvSpPr>
         <p:spPr>
           <a:xfrm>
-            <a:off x="274320" y="2091690"/>
-            <a:ext cx="1962302" cy="377190"/>
+            <a:off x="274320" y="1979676"/>
+            <a:ext cx="1976932" cy="352044"/>
           </a:xfrm>
           <a:prstGeom prst="rect">
             <a:avLst/>
           </a:prstGeom>
           <a:solidFill>
-            <a:srgbClr val="1D6F42"/>
+            <a:srgbClr val="1D7A4A"/>
           </a:solidFill>
           <a:ln>
             <a:noFill/>
@@ -8815,8 +8815,8 @@
         </p:nvSpPr>
         <p:spPr>
           <a:xfrm>
-            <a:off x="384048" y="1856231"/>
-            <a:ext cx="1815998" cy="329184"/>
+            <a:off x="402336" y="1755648"/>
+            <a:ext cx="1720900" cy="329184"/>
           </a:xfrm>
           <a:prstGeom prst="rect">
             <a:avLst/>
@@ -8831,7 +8831,7 @@
           <a:p>
             <a:pPr algn="l"/>
             <a:r>
-              <a:rPr sz="1450" b="1" i="0">
+              <a:rPr sz="1600" b="1">
                 <a:solidFill>
                   <a:srgbClr val="FFFFFF"/>
                 </a:solidFill>
@@ -8850,8 +8850,8 @@
         </p:nvSpPr>
         <p:spPr>
           <a:xfrm>
-            <a:off x="384048" y="2185416"/>
-            <a:ext cx="1815998" cy="256032"/>
+            <a:off x="402336" y="2093976"/>
+            <a:ext cx="1720900" cy="237744"/>
           </a:xfrm>
           <a:prstGeom prst="rect">
             <a:avLst/>
@@ -8866,9 +8866,9 @@
           <a:p>
             <a:pPr algn="l"/>
             <a:r>
-              <a:rPr sz="1100" b="0" i="0">
+              <a:rPr sz="1200" b="0">
                 <a:solidFill>
-                  <a:srgbClr val="FFFFAA"/>
+                  <a:srgbClr val="FFFFCC"/>
                 </a:solidFill>
                 <a:latin typeface="Yu Gothic"/>
               </a:rPr>
@@ -8885,8 +8885,8 @@
         </p:nvSpPr>
         <p:spPr>
           <a:xfrm>
-            <a:off x="411479" y="2606040"/>
-            <a:ext cx="1779422" cy="1691639"/>
+            <a:off x="402336" y="2478024"/>
+            <a:ext cx="1720900" cy="1920239"/>
           </a:xfrm>
           <a:prstGeom prst="rect">
             <a:avLst/>
@@ -8901,9 +8901,9 @@
           <a:p>
             <a:pPr algn="l"/>
             <a:r>
-              <a:rPr sz="1400" b="0" i="0">
+              <a:rPr sz="1600" b="1">
                 <a:solidFill>
-                  <a:srgbClr val="E8EEFF"/>
+                  <a:srgbClr val="0D3D25"/>
                 </a:solidFill>
                 <a:latin typeface="Yu Gothic"/>
               </a:rPr>
@@ -8921,14 +8921,14 @@
         </p:nvSpPr>
         <p:spPr>
           <a:xfrm>
-            <a:off x="2282342" y="2999231"/>
-            <a:ext cx="292608" cy="128016"/>
+            <a:off x="2287828" y="3003804"/>
+            <a:ext cx="292607" cy="118872"/>
           </a:xfrm>
           <a:prstGeom prst="rect">
             <a:avLst/>
           </a:prstGeom>
           <a:solidFill>
-            <a:srgbClr val="4C9BFF"/>
+            <a:srgbClr val="5BA3F5"/>
           </a:solidFill>
           <a:ln>
             <a:noFill/>
@@ -8964,14 +8964,14 @@
         </p:nvSpPr>
         <p:spPr>
           <a:xfrm>
-            <a:off x="2538374" y="2935223"/>
-            <a:ext cx="201168" cy="256032"/>
+            <a:off x="2543860" y="2944368"/>
+            <a:ext cx="182880" cy="237744"/>
           </a:xfrm>
           <a:prstGeom prst="rightArrow">
             <a:avLst/>
           </a:prstGeom>
           <a:solidFill>
-            <a:srgbClr val="4C9BFF"/>
+            <a:srgbClr val="5BA3F5"/>
           </a:solidFill>
           <a:ln>
             <a:noFill/>
@@ -9007,8 +9007,8 @@
         </p:nvSpPr>
         <p:spPr>
           <a:xfrm>
-            <a:off x="2693822" y="1783080"/>
-            <a:ext cx="1962302" cy="2560320"/>
+            <a:off x="2690164" y="1691640"/>
+            <a:ext cx="1976932" cy="2743200"/>
           </a:xfrm>
           <a:prstGeom prst="roundRect">
             <a:avLst>
@@ -9016,11 +9016,11 @@
             </a:avLst>
           </a:prstGeom>
           <a:solidFill>
-            <a:srgbClr val="0D3570"/>
+            <a:srgbClr val="E8F2FF"/>
           </a:solidFill>
-          <a:ln w="19050">
+          <a:ln w="15875">
             <a:solidFill>
-              <a:srgbClr val="1565C0"/>
+              <a:srgbClr val="1A6BC8"/>
             </a:solidFill>
           </a:ln>
         </p:spPr>
@@ -9054,8 +9054,8 @@
         </p:nvSpPr>
         <p:spPr>
           <a:xfrm>
-            <a:off x="2693822" y="1783080"/>
-            <a:ext cx="1962302" cy="685800"/>
+            <a:off x="2690164" y="1691640"/>
+            <a:ext cx="1976932" cy="640080"/>
           </a:xfrm>
           <a:prstGeom prst="roundRect">
             <a:avLst>
@@ -9063,7 +9063,7 @@
             </a:avLst>
           </a:prstGeom>
           <a:solidFill>
-            <a:srgbClr val="1565C0"/>
+            <a:srgbClr val="1A6BC8"/>
           </a:solidFill>
           <a:ln>
             <a:noFill/>
@@ -9099,14 +9099,14 @@
         </p:nvSpPr>
         <p:spPr>
           <a:xfrm>
-            <a:off x="2693822" y="2091690"/>
-            <a:ext cx="1962302" cy="377190"/>
+            <a:off x="2690164" y="1979676"/>
+            <a:ext cx="1976932" cy="352044"/>
           </a:xfrm>
           <a:prstGeom prst="rect">
             <a:avLst/>
           </a:prstGeom>
           <a:solidFill>
-            <a:srgbClr val="1565C0"/>
+            <a:srgbClr val="1A6BC8"/>
           </a:solidFill>
           <a:ln>
             <a:noFill/>
@@ -9142,8 +9142,8 @@
         </p:nvSpPr>
         <p:spPr>
           <a:xfrm>
-            <a:off x="2803550" y="1856231"/>
-            <a:ext cx="1815998" cy="329184"/>
+            <a:off x="2818180" y="1755648"/>
+            <a:ext cx="1720900" cy="329184"/>
           </a:xfrm>
           <a:prstGeom prst="rect">
             <a:avLst/>
@@ -9158,7 +9158,7 @@
           <a:p>
             <a:pPr algn="l"/>
             <a:r>
-              <a:rPr sz="1450" b="1" i="0">
+              <a:rPr sz="1600" b="1">
                 <a:solidFill>
                   <a:srgbClr val="FFFFFF"/>
                 </a:solidFill>
@@ -9177,8 +9177,8 @@
         </p:nvSpPr>
         <p:spPr>
           <a:xfrm>
-            <a:off x="2803550" y="2185416"/>
-            <a:ext cx="1815998" cy="256032"/>
+            <a:off x="2818180" y="2093976"/>
+            <a:ext cx="1720900" cy="237744"/>
           </a:xfrm>
           <a:prstGeom prst="rect">
             <a:avLst/>
@@ -9193,9 +9193,9 @@
           <a:p>
             <a:pPr algn="l"/>
             <a:r>
-              <a:rPr sz="1100" b="0" i="0">
+              <a:rPr sz="1200" b="0">
                 <a:solidFill>
-                  <a:srgbClr val="FFFFAA"/>
+                  <a:srgbClr val="FFFFCC"/>
                 </a:solidFill>
                 <a:latin typeface="Yu Gothic"/>
               </a:rPr>
@@ -9212,8 +9212,8 @@
         </p:nvSpPr>
         <p:spPr>
           <a:xfrm>
-            <a:off x="2830982" y="2606040"/>
-            <a:ext cx="1779422" cy="1691639"/>
+            <a:off x="2818180" y="2478024"/>
+            <a:ext cx="1720900" cy="1920239"/>
           </a:xfrm>
           <a:prstGeom prst="rect">
             <a:avLst/>
@@ -9228,9 +9228,9 @@
           <a:p>
             <a:pPr algn="l"/>
             <a:r>
-              <a:rPr sz="1400" b="0" i="0">
+              <a:rPr sz="1600" b="1">
                 <a:solidFill>
-                  <a:srgbClr val="E8EEFF"/>
+                  <a:srgbClr val="0D3065"/>
                 </a:solidFill>
                 <a:latin typeface="Yu Gothic"/>
               </a:rPr>
@@ -9249,14 +9249,14 @@
         </p:nvSpPr>
         <p:spPr>
           <a:xfrm>
-            <a:off x="4701844" y="2999231"/>
-            <a:ext cx="292608" cy="128016"/>
+            <a:off x="4703673" y="3003804"/>
+            <a:ext cx="292607" cy="118872"/>
           </a:xfrm>
           <a:prstGeom prst="rect">
             <a:avLst/>
           </a:prstGeom>
           <a:solidFill>
-            <a:srgbClr val="4C9BFF"/>
+            <a:srgbClr val="5BA3F5"/>
           </a:solidFill>
           <a:ln>
             <a:noFill/>
@@ -9292,14 +9292,14 @@
         </p:nvSpPr>
         <p:spPr>
           <a:xfrm>
-            <a:off x="4957876" y="2935223"/>
-            <a:ext cx="201168" cy="256032"/>
+            <a:off x="4959705" y="2944368"/>
+            <a:ext cx="182880" cy="237744"/>
           </a:xfrm>
           <a:prstGeom prst="rightArrow">
             <a:avLst/>
           </a:prstGeom>
           <a:solidFill>
-            <a:srgbClr val="4C9BFF"/>
+            <a:srgbClr val="5BA3F5"/>
           </a:solidFill>
           <a:ln>
             <a:noFill/>
@@ -9335,8 +9335,8 @@
         </p:nvSpPr>
         <p:spPr>
           <a:xfrm>
-            <a:off x="5113324" y="1783080"/>
-            <a:ext cx="1962302" cy="2560320"/>
+            <a:off x="5106009" y="1691640"/>
+            <a:ext cx="1976932" cy="2743200"/>
           </a:xfrm>
           <a:prstGeom prst="roundRect">
             <a:avLst>
@@ -9344,11 +9344,11 @@
             </a:avLst>
           </a:prstGeom>
           <a:solidFill>
-            <a:srgbClr val="6B1E07"/>
+            <a:srgbClr val="FFEDE8"/>
           </a:solidFill>
-          <a:ln w="19050">
+          <a:ln w="15875">
             <a:solidFill>
-              <a:srgbClr val="BF360C"/>
+              <a:srgbClr val="C03910"/>
             </a:solidFill>
           </a:ln>
         </p:spPr>
@@ -9382,8 +9382,8 @@
         </p:nvSpPr>
         <p:spPr>
           <a:xfrm>
-            <a:off x="5113324" y="1783080"/>
-            <a:ext cx="1962302" cy="685800"/>
+            <a:off x="5106009" y="1691640"/>
+            <a:ext cx="1976932" cy="640080"/>
           </a:xfrm>
           <a:prstGeom prst="roundRect">
             <a:avLst>
@@ -9391,7 +9391,7 @@
             </a:avLst>
           </a:prstGeom>
           <a:solidFill>
-            <a:srgbClr val="BF360C"/>
+            <a:srgbClr val="C03910"/>
           </a:solidFill>
           <a:ln>
             <a:noFill/>
@@ -9427,14 +9427,14 @@
         </p:nvSpPr>
         <p:spPr>
           <a:xfrm>
-            <a:off x="5113324" y="2091690"/>
-            <a:ext cx="1962302" cy="377190"/>
+            <a:off x="5106009" y="1979676"/>
+            <a:ext cx="1976932" cy="352044"/>
           </a:xfrm>
           <a:prstGeom prst="rect">
             <a:avLst/>
           </a:prstGeom>
           <a:solidFill>
-            <a:srgbClr val="BF360C"/>
+            <a:srgbClr val="C03910"/>
           </a:solidFill>
           <a:ln>
             <a:noFill/>
@@ -9470,8 +9470,8 @@
         </p:nvSpPr>
         <p:spPr>
           <a:xfrm>
-            <a:off x="5223052" y="1856231"/>
-            <a:ext cx="1815998" cy="329184"/>
+            <a:off x="5234025" y="1755648"/>
+            <a:ext cx="1720900" cy="329184"/>
           </a:xfrm>
           <a:prstGeom prst="rect">
             <a:avLst/>
@@ -9486,7 +9486,7 @@
           <a:p>
             <a:pPr algn="l"/>
             <a:r>
-              <a:rPr sz="1450" b="1" i="0">
+              <a:rPr sz="1600" b="1">
                 <a:solidFill>
                   <a:srgbClr val="FFFFFF"/>
                 </a:solidFill>
@@ -9505,8 +9505,8 @@
         </p:nvSpPr>
         <p:spPr>
           <a:xfrm>
-            <a:off x="5223052" y="2185416"/>
-            <a:ext cx="1815998" cy="256032"/>
+            <a:off x="5234025" y="2093976"/>
+            <a:ext cx="1720900" cy="237744"/>
           </a:xfrm>
           <a:prstGeom prst="rect">
             <a:avLst/>
@@ -9521,9 +9521,9 @@
           <a:p>
             <a:pPr algn="l"/>
             <a:r>
-              <a:rPr sz="1100" b="0" i="0">
+              <a:rPr sz="1200" b="0">
                 <a:solidFill>
-                  <a:srgbClr val="FFFFAA"/>
+                  <a:srgbClr val="FFFFCC"/>
                 </a:solidFill>
                 <a:latin typeface="Yu Gothic"/>
               </a:rPr>
@@ -9540,8 +9540,8 @@
         </p:nvSpPr>
         <p:spPr>
           <a:xfrm>
-            <a:off x="5250484" y="2606040"/>
-            <a:ext cx="1779422" cy="1691639"/>
+            <a:off x="5234025" y="2478024"/>
+            <a:ext cx="1720900" cy="1920239"/>
           </a:xfrm>
           <a:prstGeom prst="rect">
             <a:avLst/>
@@ -9556,9 +9556,9 @@
           <a:p>
             <a:pPr algn="l"/>
             <a:r>
-              <a:rPr sz="1400" b="0" i="0">
+              <a:rPr sz="1600" b="1">
                 <a:solidFill>
-                  <a:srgbClr val="E8EEFF"/>
+                  <a:srgbClr val="5C1805"/>
                 </a:solidFill>
                 <a:latin typeface="Yu Gothic"/>
               </a:rPr>
@@ -9577,14 +9577,14 @@
         </p:nvSpPr>
         <p:spPr>
           <a:xfrm>
-            <a:off x="7121347" y="2999231"/>
-            <a:ext cx="292608" cy="128016"/>
+            <a:off x="7119518" y="3003804"/>
+            <a:ext cx="292607" cy="118872"/>
           </a:xfrm>
           <a:prstGeom prst="rect">
             <a:avLst/>
           </a:prstGeom>
           <a:solidFill>
-            <a:srgbClr val="4C9BFF"/>
+            <a:srgbClr val="5BA3F5"/>
           </a:solidFill>
           <a:ln>
             <a:noFill/>
@@ -9620,14 +9620,14 @@
         </p:nvSpPr>
         <p:spPr>
           <a:xfrm>
-            <a:off x="7377379" y="2935223"/>
-            <a:ext cx="201168" cy="256032"/>
+            <a:off x="7375550" y="2944368"/>
+            <a:ext cx="182880" cy="237744"/>
           </a:xfrm>
           <a:prstGeom prst="rightArrow">
             <a:avLst/>
           </a:prstGeom>
           <a:solidFill>
-            <a:srgbClr val="4C9BFF"/>
+            <a:srgbClr val="5BA3F5"/>
           </a:solidFill>
           <a:ln>
             <a:noFill/>
@@ -9663,8 +9663,8 @@
         </p:nvSpPr>
         <p:spPr>
           <a:xfrm>
-            <a:off x="7532827" y="1783080"/>
-            <a:ext cx="1962302" cy="2560320"/>
+            <a:off x="7521854" y="1691640"/>
+            <a:ext cx="1976932" cy="2743200"/>
           </a:xfrm>
           <a:prstGeom prst="roundRect">
             <a:avLst>
@@ -9672,11 +9672,11 @@
             </a:avLst>
           </a:prstGeom>
           <a:solidFill>
-            <a:srgbClr val="7A3500"/>
+            <a:srgbClr val="FFF3DC"/>
           </a:solidFill>
-          <a:ln w="19050">
+          <a:ln w="15875">
             <a:solidFill>
-              <a:srgbClr val="E65C00"/>
+              <a:srgbClr val="D46D00"/>
             </a:solidFill>
           </a:ln>
         </p:spPr>
@@ -9710,8 +9710,8 @@
         </p:nvSpPr>
         <p:spPr>
           <a:xfrm>
-            <a:off x="7532827" y="1783080"/>
-            <a:ext cx="1962302" cy="685800"/>
+            <a:off x="7521854" y="1691640"/>
+            <a:ext cx="1976932" cy="640080"/>
           </a:xfrm>
           <a:prstGeom prst="roundRect">
             <a:avLst>
@@ -9719,7 +9719,7 @@
             </a:avLst>
           </a:prstGeom>
           <a:solidFill>
-            <a:srgbClr val="E65C00"/>
+            <a:srgbClr val="D46D00"/>
           </a:solidFill>
           <a:ln>
             <a:noFill/>
@@ -9755,14 +9755,14 @@
         </p:nvSpPr>
         <p:spPr>
           <a:xfrm>
-            <a:off x="7532827" y="2091690"/>
-            <a:ext cx="1962302" cy="377190"/>
+            <a:off x="7521854" y="1979676"/>
+            <a:ext cx="1976932" cy="352044"/>
           </a:xfrm>
           <a:prstGeom prst="rect">
             <a:avLst/>
           </a:prstGeom>
           <a:solidFill>
-            <a:srgbClr val="E65C00"/>
+            <a:srgbClr val="D46D00"/>
           </a:solidFill>
           <a:ln>
             <a:noFill/>
@@ -9798,8 +9798,8 @@
         </p:nvSpPr>
         <p:spPr>
           <a:xfrm>
-            <a:off x="7642555" y="1856231"/>
-            <a:ext cx="1815998" cy="329184"/>
+            <a:off x="7649870" y="1755648"/>
+            <a:ext cx="1720900" cy="329184"/>
           </a:xfrm>
           <a:prstGeom prst="rect">
             <a:avLst/>
@@ -9814,7 +9814,7 @@
           <a:p>
             <a:pPr algn="l"/>
             <a:r>
-              <a:rPr sz="1450" b="1" i="0">
+              <a:rPr sz="1600" b="1">
                 <a:solidFill>
                   <a:srgbClr val="FFFFFF"/>
                 </a:solidFill>
@@ -9833,8 +9833,8 @@
         </p:nvSpPr>
         <p:spPr>
           <a:xfrm>
-            <a:off x="7642555" y="2185416"/>
-            <a:ext cx="1815998" cy="256032"/>
+            <a:off x="7649870" y="2093976"/>
+            <a:ext cx="1720900" cy="237744"/>
           </a:xfrm>
           <a:prstGeom prst="rect">
             <a:avLst/>
@@ -9849,9 +9849,9 @@
           <a:p>
             <a:pPr algn="l"/>
             <a:r>
-              <a:rPr sz="1100" b="0" i="0">
+              <a:rPr sz="1200" b="0">
                 <a:solidFill>
-                  <a:srgbClr val="FFFFAA"/>
+                  <a:srgbClr val="FFFFCC"/>
                 </a:solidFill>
                 <a:latin typeface="Yu Gothic"/>
               </a:rPr>
@@ -9868,8 +9868,8 @@
         </p:nvSpPr>
         <p:spPr>
           <a:xfrm>
-            <a:off x="7669987" y="2606040"/>
-            <a:ext cx="1779422" cy="1691639"/>
+            <a:off x="7649870" y="2478024"/>
+            <a:ext cx="1720900" cy="1920239"/>
           </a:xfrm>
           <a:prstGeom prst="rect">
             <a:avLst/>
@@ -9884,9 +9884,9 @@
           <a:p>
             <a:pPr algn="l"/>
             <a:r>
-              <a:rPr sz="1400" b="0" i="0">
+              <a:rPr sz="1600" b="1">
                 <a:solidFill>
-                  <a:srgbClr val="E8EEFF"/>
+                  <a:srgbClr val="5A2D00"/>
                 </a:solidFill>
                 <a:latin typeface="Yu Gothic"/>
               </a:rPr>
@@ -9905,14 +9905,14 @@
         </p:nvSpPr>
         <p:spPr>
           <a:xfrm>
-            <a:off x="9540849" y="2999231"/>
-            <a:ext cx="292608" cy="128016"/>
+            <a:off x="9535363" y="3003804"/>
+            <a:ext cx="292607" cy="118872"/>
           </a:xfrm>
           <a:prstGeom prst="rect">
             <a:avLst/>
           </a:prstGeom>
           <a:solidFill>
-            <a:srgbClr val="4C9BFF"/>
+            <a:srgbClr val="5BA3F5"/>
           </a:solidFill>
           <a:ln>
             <a:noFill/>
@@ -9948,14 +9948,14 @@
         </p:nvSpPr>
         <p:spPr>
           <a:xfrm>
-            <a:off x="9796881" y="2935223"/>
-            <a:ext cx="201168" cy="256032"/>
+            <a:off x="9791395" y="2944368"/>
+            <a:ext cx="182880" cy="237744"/>
           </a:xfrm>
           <a:prstGeom prst="rightArrow">
             <a:avLst/>
           </a:prstGeom>
           <a:solidFill>
-            <a:srgbClr val="4C9BFF"/>
+            <a:srgbClr val="5BA3F5"/>
           </a:solidFill>
           <a:ln>
             <a:noFill/>
@@ -9991,8 +9991,8 @@
         </p:nvSpPr>
         <p:spPr>
           <a:xfrm>
-            <a:off x="9952329" y="1783080"/>
-            <a:ext cx="1962302" cy="2560320"/>
+            <a:off x="9937699" y="1691640"/>
+            <a:ext cx="1976932" cy="2743200"/>
           </a:xfrm>
           <a:prstGeom prst="roundRect">
             <a:avLst>
@@ -10000,11 +10000,11 @@
             </a:avLst>
           </a:prstGeom>
           <a:solidFill>
-            <a:srgbClr val="380D52"/>
+            <a:srgbClr val="F3E8FF"/>
           </a:solidFill>
-          <a:ln w="19050">
+          <a:ln w="15875">
             <a:solidFill>
-              <a:srgbClr val="6A1B9A"/>
+              <a:srgbClr val="7220A8"/>
             </a:solidFill>
           </a:ln>
         </p:spPr>
@@ -10038,8 +10038,8 @@
         </p:nvSpPr>
         <p:spPr>
           <a:xfrm>
-            <a:off x="9952329" y="1783080"/>
-            <a:ext cx="1962302" cy="685800"/>
+            <a:off x="9937699" y="1691640"/>
+            <a:ext cx="1976932" cy="640080"/>
           </a:xfrm>
           <a:prstGeom prst="roundRect">
             <a:avLst>
@@ -10047,7 +10047,7 @@
             </a:avLst>
           </a:prstGeom>
           <a:solidFill>
-            <a:srgbClr val="6A1B9A"/>
+            <a:srgbClr val="7220A8"/>
           </a:solidFill>
           <a:ln>
             <a:noFill/>
@@ -10083,14 +10083,14 @@
         </p:nvSpPr>
         <p:spPr>
           <a:xfrm>
-            <a:off x="9952329" y="2091690"/>
-            <a:ext cx="1962302" cy="377190"/>
+            <a:off x="9937699" y="1979676"/>
+            <a:ext cx="1976932" cy="352044"/>
           </a:xfrm>
           <a:prstGeom prst="rect">
             <a:avLst/>
           </a:prstGeom>
           <a:solidFill>
-            <a:srgbClr val="6A1B9A"/>
+            <a:srgbClr val="7220A8"/>
           </a:solidFill>
           <a:ln>
             <a:noFill/>
@@ -10126,8 +10126,8 @@
         </p:nvSpPr>
         <p:spPr>
           <a:xfrm>
-            <a:off x="10062057" y="1856231"/>
-            <a:ext cx="1815998" cy="329184"/>
+            <a:off x="10065715" y="1755648"/>
+            <a:ext cx="1720900" cy="329184"/>
           </a:xfrm>
           <a:prstGeom prst="rect">
             <a:avLst/>
@@ -10142,7 +10142,7 @@
           <a:p>
             <a:pPr algn="l"/>
             <a:r>
-              <a:rPr sz="1450" b="1" i="0">
+              <a:rPr sz="1600" b="1">
                 <a:solidFill>
                   <a:srgbClr val="FFFFFF"/>
                 </a:solidFill>
@@ -10161,8 +10161,8 @@
         </p:nvSpPr>
         <p:spPr>
           <a:xfrm>
-            <a:off x="10062057" y="2185416"/>
-            <a:ext cx="1815998" cy="256032"/>
+            <a:off x="10065715" y="2093976"/>
+            <a:ext cx="1720900" cy="237744"/>
           </a:xfrm>
           <a:prstGeom prst="rect">
             <a:avLst/>
@@ -10177,9 +10177,9 @@
           <a:p>
             <a:pPr algn="l"/>
             <a:r>
-              <a:rPr sz="1100" b="0" i="0">
+              <a:rPr sz="1200" b="0">
                 <a:solidFill>
-                  <a:srgbClr val="FFFFAA"/>
+                  <a:srgbClr val="FFFFCC"/>
                 </a:solidFill>
                 <a:latin typeface="Yu Gothic"/>
               </a:rPr>
@@ -10196,8 +10196,8 @@
         </p:nvSpPr>
         <p:spPr>
           <a:xfrm>
-            <a:off x="10089489" y="2606040"/>
-            <a:ext cx="1779422" cy="1691639"/>
+            <a:off x="10065715" y="2478024"/>
+            <a:ext cx="1720900" cy="1920239"/>
           </a:xfrm>
           <a:prstGeom prst="rect">
             <a:avLst/>
@@ -10212,30 +10212,64 @@
           <a:p>
             <a:pPr algn="l"/>
             <a:r>
-              <a:rPr sz="1400" b="0" i="0">
+              <a:rPr sz="1600" b="1">
                 <a:solidFill>
-                  <a:srgbClr val="E8EEFF"/>
+                  <a:srgbClr val="370A58"/>
                 </a:solidFill>
                 <a:latin typeface="Yu Gothic"/>
               </a:rPr>
-              <a:t>件数が0なら
-OK
-件数 &gt; 0なら
-注意！</a:t>
-            </a:r>
-          </a:p>
-        </p:txBody>
-      </p:sp>
-      <p:sp>
-        <p:nvSpPr>
-          <p:cNvPr id="48" name="Rectangle 47"/>
+              <a:t>件数0 → OK
+件数 &gt; 0
+→ 注意！</a:t>
+            </a:r>
+          </a:p>
+        </p:txBody>
+      </p:sp>
+      <p:sp>
+        <p:nvSpPr>
+          <p:cNvPr id="48" name="TextBox 47"/>
+          <p:cNvSpPr txBox="1"/>
+          <p:nvPr/>
+        </p:nvSpPr>
+        <p:spPr>
+          <a:xfrm>
+            <a:off x="571500" y="4389120"/>
+            <a:ext cx="2286000" cy="256032"/>
+          </a:xfrm>
+          <a:prstGeom prst="rect">
+            <a:avLst/>
+          </a:prstGeom>
+          <a:noFill/>
+        </p:spPr>
+        <p:txBody>
+          <a:bodyPr wrap="square">
+            <a:spAutoFit/>
+          </a:bodyPr>
+          <a:lstStyle/>
+          <a:p>
+            <a:pPr algn="l"/>
+            <a:r>
+              <a:rPr sz="1100" b="0">
+                <a:solidFill>
+                  <a:srgbClr val="556699"/>
+                </a:solidFill>
+                <a:latin typeface="Yu Gothic"/>
+              </a:rPr>
+              <a:t>🔑  キーワード</a:t>
+            </a:r>
+          </a:p>
+        </p:txBody>
+      </p:sp>
+      <p:sp>
+        <p:nvSpPr>
+          <p:cNvPr id="49" name="Rectangle 48"/>
           <p:cNvSpPr/>
           <p:nvPr/>
         </p:nvSpPr>
         <p:spPr>
           <a:xfrm>
-            <a:off x="507491" y="4572000"/>
-            <a:ext cx="2103120" cy="347472"/>
+            <a:off x="571500" y="4663440"/>
+            <a:ext cx="2084831" cy="365760"/>
           </a:xfrm>
           <a:prstGeom prst="roundRect">
             <a:avLst>
@@ -10243,11 +10277,11 @@
             </a:avLst>
           </a:prstGeom>
           <a:solidFill>
-            <a:srgbClr val="163D28"/>
+            <a:srgbClr val="EAF7F0"/>
           </a:solidFill>
-          <a:ln w="12700">
+          <a:ln w="19050">
             <a:solidFill>
-              <a:srgbClr val="1D6F42"/>
+              <a:srgbClr val="1D7A4A"/>
             </a:solidFill>
           </a:ln>
         </p:spPr>
@@ -10275,14 +10309,14 @@
       </p:sp>
       <p:sp>
         <p:nvSpPr>
-          <p:cNvPr id="49" name="TextBox 48"/>
+          <p:cNvPr id="50" name="TextBox 49"/>
           <p:cNvSpPr txBox="1"/>
           <p:nvPr/>
         </p:nvSpPr>
         <p:spPr>
           <a:xfrm>
-            <a:off x="598931" y="4608576"/>
-            <a:ext cx="1920239" cy="274320"/>
+            <a:off x="662940" y="4709159"/>
+            <a:ext cx="1901951" cy="274320"/>
           </a:xfrm>
           <a:prstGeom prst="rect">
             <a:avLst/>
@@ -10297,9 +10331,9 @@
           <a:p>
             <a:pPr algn="ctr"/>
             <a:r>
-              <a:rPr sz="1150" b="1" i="0">
+              <a:rPr sz="1250" b="1">
                 <a:solidFill>
-                  <a:srgbClr val="FFFFFF"/>
+                  <a:srgbClr val="0D3D25"/>
                 </a:solidFill>
                 <a:latin typeface="Yu Gothic"/>
               </a:rPr>
@@ -10310,14 +10344,14 @@
       </p:sp>
       <p:sp>
         <p:nvSpPr>
-          <p:cNvPr id="50" name="Rectangle 49"/>
+          <p:cNvPr id="51" name="Rectangle 50"/>
           <p:cNvSpPr/>
           <p:nvPr/>
         </p:nvSpPr>
         <p:spPr>
           <a:xfrm>
-            <a:off x="2775203" y="4572000"/>
-            <a:ext cx="2103120" cy="347472"/>
+            <a:off x="2811780" y="4663440"/>
+            <a:ext cx="2084831" cy="365760"/>
           </a:xfrm>
           <a:prstGeom prst="roundRect">
             <a:avLst>
@@ -10325,11 +10359,11 @@
             </a:avLst>
           </a:prstGeom>
           <a:solidFill>
-            <a:srgbClr val="0D3570"/>
+            <a:srgbClr val="E8F2FF"/>
           </a:solidFill>
-          <a:ln w="12700">
+          <a:ln w="19050">
             <a:solidFill>
-              <a:srgbClr val="1565C0"/>
+              <a:srgbClr val="1A6BC8"/>
             </a:solidFill>
           </a:ln>
         </p:spPr>
@@ -10357,14 +10391,14 @@
       </p:sp>
       <p:sp>
         <p:nvSpPr>
-          <p:cNvPr id="51" name="TextBox 50"/>
+          <p:cNvPr id="52" name="TextBox 51"/>
           <p:cNvSpPr txBox="1"/>
           <p:nvPr/>
         </p:nvSpPr>
         <p:spPr>
           <a:xfrm>
-            <a:off x="2866644" y="4608576"/>
-            <a:ext cx="1920239" cy="274320"/>
+            <a:off x="2903220" y="4709159"/>
+            <a:ext cx="1901951" cy="274320"/>
           </a:xfrm>
           <a:prstGeom prst="rect">
             <a:avLst/>
@@ -10379,9 +10413,9 @@
           <a:p>
             <a:pPr algn="ctr"/>
             <a:r>
-              <a:rPr sz="1150" b="1" i="0">
+              <a:rPr sz="1250" b="1">
                 <a:solidFill>
-                  <a:srgbClr val="FFFFFF"/>
+                  <a:srgbClr val="0D3065"/>
                 </a:solidFill>
                 <a:latin typeface="Yu Gothic"/>
               </a:rPr>
@@ -10392,14 +10426,14 @@
       </p:sp>
       <p:sp>
         <p:nvSpPr>
-          <p:cNvPr id="52" name="Rectangle 51"/>
+          <p:cNvPr id="53" name="Rectangle 52"/>
           <p:cNvSpPr/>
           <p:nvPr/>
         </p:nvSpPr>
         <p:spPr>
           <a:xfrm>
-            <a:off x="5042916" y="4572000"/>
-            <a:ext cx="2103120" cy="347472"/>
+            <a:off x="5052060" y="4663440"/>
+            <a:ext cx="2084831" cy="365760"/>
           </a:xfrm>
           <a:prstGeom prst="roundRect">
             <a:avLst>
@@ -10407,11 +10441,11 @@
             </a:avLst>
           </a:prstGeom>
           <a:solidFill>
-            <a:srgbClr val="6B1E07"/>
+            <a:srgbClr val="FFEDE8"/>
           </a:solidFill>
-          <a:ln w="12700">
+          <a:ln w="19050">
             <a:solidFill>
-              <a:srgbClr val="BF360C"/>
+              <a:srgbClr val="C03910"/>
             </a:solidFill>
           </a:ln>
         </p:spPr>
@@ -10439,14 +10473,14 @@
       </p:sp>
       <p:sp>
         <p:nvSpPr>
-          <p:cNvPr id="53" name="TextBox 52"/>
+          <p:cNvPr id="54" name="TextBox 53"/>
           <p:cNvSpPr txBox="1"/>
           <p:nvPr/>
         </p:nvSpPr>
         <p:spPr>
           <a:xfrm>
-            <a:off x="5134355" y="4608576"/>
-            <a:ext cx="1920239" cy="274320"/>
+            <a:off x="5143500" y="4709159"/>
+            <a:ext cx="1901951" cy="274320"/>
           </a:xfrm>
           <a:prstGeom prst="rect">
             <a:avLst/>
@@ -10461,9 +10495,9 @@
           <a:p>
             <a:pPr algn="ctr"/>
             <a:r>
-              <a:rPr sz="1150" b="1" i="0">
+              <a:rPr sz="1250" b="1">
                 <a:solidFill>
-                  <a:srgbClr val="FFFFFF"/>
+                  <a:srgbClr val="5C1805"/>
                 </a:solidFill>
                 <a:latin typeface="Yu Gothic"/>
               </a:rPr>
@@ -10474,14 +10508,14 @@
       </p:sp>
       <p:sp>
         <p:nvSpPr>
-          <p:cNvPr id="54" name="Rectangle 53"/>
+          <p:cNvPr id="55" name="Rectangle 54"/>
           <p:cNvSpPr/>
           <p:nvPr/>
         </p:nvSpPr>
         <p:spPr>
           <a:xfrm>
-            <a:off x="7310627" y="4572000"/>
-            <a:ext cx="2103120" cy="347472"/>
+            <a:off x="7292340" y="4663440"/>
+            <a:ext cx="2084831" cy="365760"/>
           </a:xfrm>
           <a:prstGeom prst="roundRect">
             <a:avLst>
@@ -10489,11 +10523,11 @@
             </a:avLst>
           </a:prstGeom>
           <a:solidFill>
-            <a:srgbClr val="7A3500"/>
+            <a:srgbClr val="FFF3DC"/>
           </a:solidFill>
-          <a:ln w="12700">
+          <a:ln w="19050">
             <a:solidFill>
-              <a:srgbClr val="E65C00"/>
+              <a:srgbClr val="D46D00"/>
             </a:solidFill>
           </a:ln>
         </p:spPr>
@@ -10521,14 +10555,14 @@
       </p:sp>
       <p:sp>
         <p:nvSpPr>
-          <p:cNvPr id="55" name="TextBox 54"/>
+          <p:cNvPr id="56" name="TextBox 55"/>
           <p:cNvSpPr txBox="1"/>
           <p:nvPr/>
         </p:nvSpPr>
         <p:spPr>
           <a:xfrm>
-            <a:off x="7402067" y="4608576"/>
-            <a:ext cx="1920239" cy="274320"/>
+            <a:off x="7383780" y="4709159"/>
+            <a:ext cx="1901951" cy="274320"/>
           </a:xfrm>
           <a:prstGeom prst="rect">
             <a:avLst/>
@@ -10543,9 +10577,9 @@
           <a:p>
             <a:pPr algn="ctr"/>
             <a:r>
-              <a:rPr sz="1150" b="1" i="0">
+              <a:rPr sz="1250" b="1">
                 <a:solidFill>
-                  <a:srgbClr val="FFFFFF"/>
+                  <a:srgbClr val="5A2D00"/>
                 </a:solidFill>
                 <a:latin typeface="Yu Gothic"/>
               </a:rPr>
@@ -10556,14 +10590,14 @@
       </p:sp>
       <p:sp>
         <p:nvSpPr>
-          <p:cNvPr id="56" name="Rectangle 55"/>
+          <p:cNvPr id="57" name="Rectangle 56"/>
           <p:cNvSpPr/>
           <p:nvPr/>
         </p:nvSpPr>
         <p:spPr>
           <a:xfrm>
-            <a:off x="9578340" y="4572000"/>
-            <a:ext cx="2103120" cy="347472"/>
+            <a:off x="9532620" y="4663440"/>
+            <a:ext cx="2084831" cy="365760"/>
           </a:xfrm>
           <a:prstGeom prst="roundRect">
             <a:avLst>
@@ -10571,11 +10605,11 @@
             </a:avLst>
           </a:prstGeom>
           <a:solidFill>
-            <a:srgbClr val="380D52"/>
+            <a:srgbClr val="F3E8FF"/>
           </a:solidFill>
-          <a:ln w="12700">
+          <a:ln w="19050">
             <a:solidFill>
-              <a:srgbClr val="6A1B9A"/>
+              <a:srgbClr val="7220A8"/>
             </a:solidFill>
           </a:ln>
         </p:spPr>
@@ -10603,14 +10637,14 @@
       </p:sp>
       <p:sp>
         <p:nvSpPr>
-          <p:cNvPr id="57" name="TextBox 56"/>
+          <p:cNvPr id="58" name="TextBox 57"/>
           <p:cNvSpPr txBox="1"/>
           <p:nvPr/>
         </p:nvSpPr>
         <p:spPr>
           <a:xfrm>
-            <a:off x="9669780" y="4608576"/>
-            <a:ext cx="1920239" cy="274320"/>
+            <a:off x="9624060" y="4709159"/>
+            <a:ext cx="1901951" cy="274320"/>
           </a:xfrm>
           <a:prstGeom prst="rect">
             <a:avLst/>
@@ -10625,9 +10659,9 @@
           <a:p>
             <a:pPr algn="ctr"/>
             <a:r>
-              <a:rPr sz="1150" b="1" i="0">
+              <a:rPr sz="1250" b="1">
                 <a:solidFill>
-                  <a:srgbClr val="FFFFFF"/>
+                  <a:srgbClr val="370A58"/>
                 </a:solidFill>
                 <a:latin typeface="Yu Gothic"/>
               </a:rPr>
@@ -10638,41 +10672,6 @@
       </p:sp>
       <p:sp>
         <p:nvSpPr>
-          <p:cNvPr id="58" name="TextBox 57"/>
-          <p:cNvSpPr txBox="1"/>
-          <p:nvPr/>
-        </p:nvSpPr>
-        <p:spPr>
-          <a:xfrm>
-            <a:off x="347472" y="4443984"/>
-            <a:ext cx="2286000" cy="274320"/>
-          </a:xfrm>
-          <a:prstGeom prst="rect">
-            <a:avLst/>
-          </a:prstGeom>
-          <a:noFill/>
-        </p:spPr>
-        <p:txBody>
-          <a:bodyPr wrap="square">
-            <a:spAutoFit/>
-          </a:bodyPr>
-          <a:lstStyle/>
-          <a:p>
-            <a:pPr algn="l"/>
-            <a:r>
-              <a:rPr sz="1100" b="0" i="0">
-                <a:solidFill>
-                  <a:srgbClr val="88AAFF"/>
-                </a:solidFill>
-                <a:latin typeface="Yu Gothic"/>
-              </a:rPr>
-              <a:t>🔑  キーワード</a:t>
-            </a:r>
-          </a:p>
-        </p:txBody>
-      </p:sp>
-      <p:sp>
-        <p:nvSpPr>
           <p:cNvPr id="59" name="Rectangle 58"/>
           <p:cNvSpPr/>
           <p:nvPr/>
@@ -10686,7 +10685,7 @@
             <a:avLst/>
           </a:prstGeom>
           <a:solidFill>
-            <a:srgbClr val="4C9BFF"/>
+            <a:srgbClr val="5BA3F5"/>
           </a:solidFill>
           <a:ln>
             <a:noFill/>

</xml_diff>

<commit_message>
feat: add overview slide to P005 (slide 12)
Beginner-friendly flow overview slide with light bg, pastel cards,
large fonts - white bg with pastel action cards and keyword pills

Co-Authored-By: Claude Sonnet 4.6 <noreply@anthropic.com>
</commit_message>
<xml_diff>
--- a/assets/pa45/P005_PA45_MatomeFuro_20260409.pptx
+++ b/assets/pa45/P005_PA45_MatomeFuro_20260409.pptx
@@ -19,6 +19,7 @@
     <p:sldId id="268" r:id="rId10"/>
     <p:sldId id="258" r:id="rId11"/>
     <p:sldId id="269" r:id="rId12"/>
+    <p:sldId id="273" r:id="rId20"/>
   </p:sldIdLst>
   <p:sldSz cx="12192000" cy="6858000"/>
   <p:notesSz cx="6858000" cy="12192000"/>
@@ -8347,6 +8348,2379 @@
 </p:sld>
 </file>
 
+<file path=ppt/slides/slide12.xml><?xml version="1.0" encoding="utf-8"?>
+<p:sld xmlns:a="http://schemas.openxmlformats.org/drawingml/2006/main" xmlns:p="http://schemas.openxmlformats.org/presentationml/2006/main" xmlns:r="http://schemas.openxmlformats.org/officeDocument/2006/relationships">
+  <p:cSld>
+    <p:spTree>
+      <p:nvGrpSpPr>
+        <p:cNvPr id="1" name=""/>
+        <p:cNvGrpSpPr/>
+        <p:nvPr/>
+      </p:nvGrpSpPr>
+      <p:grpSpPr/>
+      <p:sp>
+        <p:nvSpPr>
+          <p:cNvPr id="2" name="Rectangle 1"/>
+          <p:cNvSpPr/>
+          <p:nvPr/>
+        </p:nvSpPr>
+        <p:spPr>
+          <a:xfrm>
+            <a:off x="0" y="0"/>
+            <a:ext cx="12188952" cy="6858000"/>
+          </a:xfrm>
+          <a:prstGeom prst="rect">
+            <a:avLst/>
+          </a:prstGeom>
+          <a:solidFill>
+            <a:srgbClr val="FFFFFF"/>
+          </a:solidFill>
+          <a:ln>
+            <a:noFill/>
+          </a:ln>
+        </p:spPr>
+        <p:style>
+          <a:lnRef idx="1">
+            <a:schemeClr val="accent1"/>
+          </a:lnRef>
+          <a:fillRef idx="3">
+            <a:schemeClr val="accent1"/>
+          </a:fillRef>
+          <a:effectRef idx="2">
+            <a:schemeClr val="accent1"/>
+          </a:effectRef>
+          <a:fontRef idx="minor">
+            <a:schemeClr val="lt1"/>
+          </a:fontRef>
+        </p:style>
+        <p:txBody>
+          <a:bodyPr rtlCol="0" anchor="ctr"/>
+          <a:lstStyle/>
+          <a:p>
+            <a:pPr algn="ctr"/>
+          </a:p>
+        </p:txBody>
+      </p:sp>
+      <p:sp>
+        <p:nvSpPr>
+          <p:cNvPr id="3" name="Rectangle 2"/>
+          <p:cNvSpPr/>
+          <p:nvPr/>
+        </p:nvSpPr>
+        <p:spPr>
+          <a:xfrm>
+            <a:off x="0" y="0"/>
+            <a:ext cx="12188952" cy="1024128"/>
+          </a:xfrm>
+          <a:prstGeom prst="rect">
+            <a:avLst/>
+          </a:prstGeom>
+          <a:solidFill>
+            <a:srgbClr val="1A2A6C"/>
+          </a:solidFill>
+          <a:ln>
+            <a:noFill/>
+          </a:ln>
+        </p:spPr>
+        <p:style>
+          <a:lnRef idx="1">
+            <a:schemeClr val="accent1"/>
+          </a:lnRef>
+          <a:fillRef idx="3">
+            <a:schemeClr val="accent1"/>
+          </a:fillRef>
+          <a:effectRef idx="2">
+            <a:schemeClr val="accent1"/>
+          </a:effectRef>
+          <a:fontRef idx="minor">
+            <a:schemeClr val="lt1"/>
+          </a:fontRef>
+        </p:style>
+        <p:txBody>
+          <a:bodyPr rtlCol="0" anchor="ctr"/>
+          <a:lstStyle/>
+          <a:p>
+            <a:pPr algn="ctr"/>
+          </a:p>
+        </p:txBody>
+      </p:sp>
+      <p:sp>
+        <p:nvSpPr>
+          <p:cNvPr id="4" name="Rectangle 3"/>
+          <p:cNvSpPr/>
+          <p:nvPr/>
+        </p:nvSpPr>
+        <p:spPr>
+          <a:xfrm>
+            <a:off x="0" y="1005840"/>
+            <a:ext cx="12188952" cy="36576"/>
+          </a:xfrm>
+          <a:prstGeom prst="rect">
+            <a:avLst/>
+          </a:prstGeom>
+          <a:solidFill>
+            <a:srgbClr val="5BA3F5"/>
+          </a:solidFill>
+          <a:ln>
+            <a:noFill/>
+          </a:ln>
+        </p:spPr>
+        <p:style>
+          <a:lnRef idx="1">
+            <a:schemeClr val="accent1"/>
+          </a:lnRef>
+          <a:fillRef idx="3">
+            <a:schemeClr val="accent1"/>
+          </a:fillRef>
+          <a:effectRef idx="2">
+            <a:schemeClr val="accent1"/>
+          </a:effectRef>
+          <a:fontRef idx="minor">
+            <a:schemeClr val="lt1"/>
+          </a:fontRef>
+        </p:style>
+        <p:txBody>
+          <a:bodyPr rtlCol="0" anchor="ctr"/>
+          <a:lstStyle/>
+          <a:p>
+            <a:pPr algn="ctr"/>
+          </a:p>
+        </p:txBody>
+      </p:sp>
+      <p:sp>
+        <p:nvSpPr>
+          <p:cNvPr id="5" name="TextBox 4"/>
+          <p:cNvSpPr txBox="1"/>
+          <p:nvPr/>
+        </p:nvSpPr>
+        <p:spPr>
+          <a:xfrm>
+            <a:off x="411480" y="91440"/>
+            <a:ext cx="5486400" cy="237744"/>
+          </a:xfrm>
+          <a:prstGeom prst="rect">
+            <a:avLst/>
+          </a:prstGeom>
+          <a:noFill/>
+        </p:spPr>
+        <p:txBody>
+          <a:bodyPr wrap="square">
+            <a:spAutoFit/>
+          </a:bodyPr>
+          <a:lstStyle/>
+          <a:p>
+            <a:pPr algn="l"/>
+            <a:r>
+              <a:rPr sz="1300" b="0">
+                <a:solidFill>
+                  <a:srgbClr val="AACCFF"/>
+                </a:solidFill>
+                <a:latin typeface="Yu Gothic"/>
+              </a:rPr>
+              <a:t>PA45 ｜ 第5回</a:t>
+            </a:r>
+          </a:p>
+        </p:txBody>
+      </p:sp>
+      <p:sp>
+        <p:nvSpPr>
+          <p:cNvPr id="6" name="TextBox 5"/>
+          <p:cNvSpPr txBox="1"/>
+          <p:nvPr/>
+        </p:nvSpPr>
+        <p:spPr>
+          <a:xfrm>
+            <a:off x="411480" y="274320"/>
+            <a:ext cx="8686800" cy="640080"/>
+          </a:xfrm>
+          <a:prstGeom prst="rect">
+            <a:avLst/>
+          </a:prstGeom>
+          <a:noFill/>
+        </p:spPr>
+        <p:txBody>
+          <a:bodyPr wrap="square">
+            <a:spAutoFit/>
+          </a:bodyPr>
+          <a:lstStyle/>
+          <a:p>
+            <a:pPr algn="l"/>
+            <a:r>
+              <a:rPr sz="3100" b="1">
+                <a:solidFill>
+                  <a:srgbClr val="FFFFFF"/>
+                </a:solidFill>
+                <a:latin typeface="Yu Gothic"/>
+              </a:rPr>
+              <a:t>このフロー、何をしているの？</a:t>
+            </a:r>
+          </a:p>
+        </p:txBody>
+      </p:sp>
+      <p:sp>
+        <p:nvSpPr>
+          <p:cNvPr id="7" name="Rectangle 6"/>
+          <p:cNvSpPr/>
+          <p:nvPr/>
+        </p:nvSpPr>
+        <p:spPr>
+          <a:xfrm>
+            <a:off x="10881360" y="402336"/>
+            <a:ext cx="1078992" cy="274320"/>
+          </a:xfrm>
+          <a:prstGeom prst="roundRect">
+            <a:avLst>
+              <a:gd name="adj" fmla="val 20000"/>
+            </a:avLst>
+          </a:prstGeom>
+          <a:solidFill>
+            <a:srgbClr val="5BA3F5"/>
+          </a:solidFill>
+          <a:ln>
+            <a:noFill/>
+          </a:ln>
+        </p:spPr>
+        <p:style>
+          <a:lnRef idx="1">
+            <a:schemeClr val="accent1"/>
+          </a:lnRef>
+          <a:fillRef idx="3">
+            <a:schemeClr val="accent1"/>
+          </a:fillRef>
+          <a:effectRef idx="2">
+            <a:schemeClr val="accent1"/>
+          </a:effectRef>
+          <a:fontRef idx="minor">
+            <a:schemeClr val="lt1"/>
+          </a:fontRef>
+        </p:style>
+        <p:txBody>
+          <a:bodyPr rtlCol="0" anchor="ctr"/>
+          <a:lstStyle/>
+          <a:p>
+            <a:pPr algn="ctr"/>
+          </a:p>
+        </p:txBody>
+      </p:sp>
+      <p:sp>
+        <p:nvSpPr>
+          <p:cNvPr id="8" name="TextBox 7"/>
+          <p:cNvSpPr txBox="1"/>
+          <p:nvPr/>
+        </p:nvSpPr>
+        <p:spPr>
+          <a:xfrm>
+            <a:off x="10899648" y="411480"/>
+            <a:ext cx="1042415" cy="256032"/>
+          </a:xfrm>
+          <a:prstGeom prst="rect">
+            <a:avLst/>
+          </a:prstGeom>
+          <a:noFill/>
+        </p:spPr>
+        <p:txBody>
+          <a:bodyPr wrap="square">
+            <a:spAutoFit/>
+          </a:bodyPr>
+          <a:lstStyle/>
+          <a:p>
+            <a:pPr algn="ctr"/>
+            <a:r>
+              <a:rPr sz="1100" b="1">
+                <a:solidFill>
+                  <a:srgbClr val="FFFFFF"/>
+                </a:solidFill>
+                <a:latin typeface="Segoe UI"/>
+              </a:rPr>
+              <a:t>Overview</a:t>
+            </a:r>
+          </a:p>
+        </p:txBody>
+      </p:sp>
+      <p:sp>
+        <p:nvSpPr>
+          <p:cNvPr id="9" name="TextBox 8"/>
+          <p:cNvSpPr txBox="1"/>
+          <p:nvPr/>
+        </p:nvSpPr>
+        <p:spPr>
+          <a:xfrm>
+            <a:off x="365760" y="1078992"/>
+            <a:ext cx="11521440" cy="548640"/>
+          </a:xfrm>
+          <a:prstGeom prst="rect">
+            <a:avLst/>
+          </a:prstGeom>
+          <a:noFill/>
+        </p:spPr>
+        <p:txBody>
+          <a:bodyPr wrap="square">
+            <a:spAutoFit/>
+          </a:bodyPr>
+          <a:lstStyle/>
+          <a:p>
+            <a:pPr algn="ctr"/>
+            <a:r>
+              <a:rPr sz="1700" b="0">
+                <a:solidFill>
+                  <a:srgbClr val="2C3E80"/>
+                </a:solidFill>
+                <a:latin typeface="Yu Gothic"/>
+              </a:rPr>
+              <a:t>Excelの業務データを1行ずつチェックして「未対応がいくつあるか」で判断するフロー</a:t>
+            </a:r>
+          </a:p>
+        </p:txBody>
+      </p:sp>
+      <p:sp>
+        <p:nvSpPr>
+          <p:cNvPr id="10" name="Rectangle 9"/>
+          <p:cNvSpPr/>
+          <p:nvPr/>
+        </p:nvSpPr>
+        <p:spPr>
+          <a:xfrm>
+            <a:off x="274320" y="1691640"/>
+            <a:ext cx="1976932" cy="2743200"/>
+          </a:xfrm>
+          <a:prstGeom prst="roundRect">
+            <a:avLst>
+              <a:gd name="adj" fmla="val 8000"/>
+            </a:avLst>
+          </a:prstGeom>
+          <a:solidFill>
+            <a:srgbClr val="EAF7F0"/>
+          </a:solidFill>
+          <a:ln w="15875">
+            <a:solidFill>
+              <a:srgbClr val="1D7A4A"/>
+            </a:solidFill>
+          </a:ln>
+        </p:spPr>
+        <p:style>
+          <a:lnRef idx="1">
+            <a:schemeClr val="accent1"/>
+          </a:lnRef>
+          <a:fillRef idx="3">
+            <a:schemeClr val="accent1"/>
+          </a:fillRef>
+          <a:effectRef idx="2">
+            <a:schemeClr val="accent1"/>
+          </a:effectRef>
+          <a:fontRef idx="minor">
+            <a:schemeClr val="lt1"/>
+          </a:fontRef>
+        </p:style>
+        <p:txBody>
+          <a:bodyPr rtlCol="0" anchor="ctr"/>
+          <a:lstStyle/>
+          <a:p>
+            <a:pPr algn="ctr"/>
+          </a:p>
+        </p:txBody>
+      </p:sp>
+      <p:sp>
+        <p:nvSpPr>
+          <p:cNvPr id="11" name="Rectangle 10"/>
+          <p:cNvSpPr/>
+          <p:nvPr/>
+        </p:nvSpPr>
+        <p:spPr>
+          <a:xfrm>
+            <a:off x="274320" y="1691640"/>
+            <a:ext cx="1976932" cy="640080"/>
+          </a:xfrm>
+          <a:prstGeom prst="roundRect">
+            <a:avLst>
+              <a:gd name="adj" fmla="val 8000"/>
+            </a:avLst>
+          </a:prstGeom>
+          <a:solidFill>
+            <a:srgbClr val="1D7A4A"/>
+          </a:solidFill>
+          <a:ln>
+            <a:noFill/>
+          </a:ln>
+        </p:spPr>
+        <p:style>
+          <a:lnRef idx="1">
+            <a:schemeClr val="accent1"/>
+          </a:lnRef>
+          <a:fillRef idx="3">
+            <a:schemeClr val="accent1"/>
+          </a:fillRef>
+          <a:effectRef idx="2">
+            <a:schemeClr val="accent1"/>
+          </a:effectRef>
+          <a:fontRef idx="minor">
+            <a:schemeClr val="lt1"/>
+          </a:fontRef>
+        </p:style>
+        <p:txBody>
+          <a:bodyPr rtlCol="0" anchor="ctr"/>
+          <a:lstStyle/>
+          <a:p>
+            <a:pPr algn="ctr"/>
+          </a:p>
+        </p:txBody>
+      </p:sp>
+      <p:sp>
+        <p:nvSpPr>
+          <p:cNvPr id="12" name="Rectangle 11"/>
+          <p:cNvSpPr/>
+          <p:nvPr/>
+        </p:nvSpPr>
+        <p:spPr>
+          <a:xfrm>
+            <a:off x="274320" y="1979676"/>
+            <a:ext cx="1976932" cy="352044"/>
+          </a:xfrm>
+          <a:prstGeom prst="rect">
+            <a:avLst/>
+          </a:prstGeom>
+          <a:solidFill>
+            <a:srgbClr val="1D7A4A"/>
+          </a:solidFill>
+          <a:ln>
+            <a:noFill/>
+          </a:ln>
+        </p:spPr>
+        <p:style>
+          <a:lnRef idx="1">
+            <a:schemeClr val="accent1"/>
+          </a:lnRef>
+          <a:fillRef idx="3">
+            <a:schemeClr val="accent1"/>
+          </a:fillRef>
+          <a:effectRef idx="2">
+            <a:schemeClr val="accent1"/>
+          </a:effectRef>
+          <a:fontRef idx="minor">
+            <a:schemeClr val="lt1"/>
+          </a:fontRef>
+        </p:style>
+        <p:txBody>
+          <a:bodyPr rtlCol="0" anchor="ctr"/>
+          <a:lstStyle/>
+          <a:p>
+            <a:pPr algn="ctr"/>
+          </a:p>
+        </p:txBody>
+      </p:sp>
+      <p:sp>
+        <p:nvSpPr>
+          <p:cNvPr id="13" name="TextBox 12"/>
+          <p:cNvSpPr txBox="1"/>
+          <p:nvPr/>
+        </p:nvSpPr>
+        <p:spPr>
+          <a:xfrm>
+            <a:off x="402336" y="1755648"/>
+            <a:ext cx="1720900" cy="329184"/>
+          </a:xfrm>
+          <a:prstGeom prst="rect">
+            <a:avLst/>
+          </a:prstGeom>
+          <a:noFill/>
+        </p:spPr>
+        <p:txBody>
+          <a:bodyPr wrap="square">
+            <a:spAutoFit/>
+          </a:bodyPr>
+          <a:lstStyle/>
+          <a:p>
+            <a:pPr algn="l"/>
+            <a:r>
+              <a:rPr sz="1600" b="1">
+                <a:solidFill>
+                  <a:srgbClr val="FFFFFF"/>
+                </a:solidFill>
+                <a:latin typeface="Yu Gothic"/>
+              </a:rPr>
+              <a:t>①  Excelテーブル</a:t>
+            </a:r>
+          </a:p>
+        </p:txBody>
+      </p:sp>
+      <p:sp>
+        <p:nvSpPr>
+          <p:cNvPr id="14" name="TextBox 13"/>
+          <p:cNvSpPr txBox="1"/>
+          <p:nvPr/>
+        </p:nvSpPr>
+        <p:spPr>
+          <a:xfrm>
+            <a:off x="402336" y="2093976"/>
+            <a:ext cx="1720900" cy="237744"/>
+          </a:xfrm>
+          <a:prstGeom prst="rect">
+            <a:avLst/>
+          </a:prstGeom>
+          <a:noFill/>
+        </p:spPr>
+        <p:txBody>
+          <a:bodyPr wrap="square">
+            <a:spAutoFit/>
+          </a:bodyPr>
+          <a:lstStyle/>
+          <a:p>
+            <a:pPr algn="l"/>
+            <a:r>
+              <a:rPr sz="1200" b="0">
+                <a:solidFill>
+                  <a:srgbClr val="FFFFCC"/>
+                </a:solidFill>
+                <a:latin typeface="Yu Gothic"/>
+              </a:rPr>
+              <a:t>スタート地点</a:t>
+            </a:r>
+          </a:p>
+        </p:txBody>
+      </p:sp>
+      <p:sp>
+        <p:nvSpPr>
+          <p:cNvPr id="15" name="TextBox 14"/>
+          <p:cNvSpPr txBox="1"/>
+          <p:nvPr/>
+        </p:nvSpPr>
+        <p:spPr>
+          <a:xfrm>
+            <a:off x="402336" y="2478024"/>
+            <a:ext cx="1720900" cy="1920239"/>
+          </a:xfrm>
+          <a:prstGeom prst="rect">
+            <a:avLst/>
+          </a:prstGeom>
+          <a:noFill/>
+        </p:spPr>
+        <p:txBody>
+          <a:bodyPr wrap="square">
+            <a:spAutoFit/>
+          </a:bodyPr>
+          <a:lstStyle/>
+          <a:p>
+            <a:pPr algn="l"/>
+            <a:r>
+              <a:rPr sz="1600" b="1">
+                <a:solidFill>
+                  <a:srgbClr val="0D3D25"/>
+                </a:solidFill>
+                <a:latin typeface="Yu Gothic"/>
+              </a:rPr>
+              <a:t>業務データが
+入った表</a:t>
+            </a:r>
+          </a:p>
+        </p:txBody>
+      </p:sp>
+      <p:sp>
+        <p:nvSpPr>
+          <p:cNvPr id="16" name="Rectangle 15"/>
+          <p:cNvSpPr/>
+          <p:nvPr/>
+        </p:nvSpPr>
+        <p:spPr>
+          <a:xfrm>
+            <a:off x="2287828" y="3003804"/>
+            <a:ext cx="292607" cy="118872"/>
+          </a:xfrm>
+          <a:prstGeom prst="rect">
+            <a:avLst/>
+          </a:prstGeom>
+          <a:solidFill>
+            <a:srgbClr val="5BA3F5"/>
+          </a:solidFill>
+          <a:ln>
+            <a:noFill/>
+          </a:ln>
+        </p:spPr>
+        <p:style>
+          <a:lnRef idx="1">
+            <a:schemeClr val="accent1"/>
+          </a:lnRef>
+          <a:fillRef idx="3">
+            <a:schemeClr val="accent1"/>
+          </a:fillRef>
+          <a:effectRef idx="2">
+            <a:schemeClr val="accent1"/>
+          </a:effectRef>
+          <a:fontRef idx="minor">
+            <a:schemeClr val="lt1"/>
+          </a:fontRef>
+        </p:style>
+        <p:txBody>
+          <a:bodyPr rtlCol="0" anchor="ctr"/>
+          <a:lstStyle/>
+          <a:p>
+            <a:pPr algn="ctr"/>
+          </a:p>
+        </p:txBody>
+      </p:sp>
+      <p:sp>
+        <p:nvSpPr>
+          <p:cNvPr id="17" name="Rounded Rectangle 16"/>
+          <p:cNvSpPr/>
+          <p:nvPr/>
+        </p:nvSpPr>
+        <p:spPr>
+          <a:xfrm>
+            <a:off x="2543860" y="2944368"/>
+            <a:ext cx="182880" cy="237744"/>
+          </a:xfrm>
+          <a:prstGeom prst="rightArrow">
+            <a:avLst/>
+          </a:prstGeom>
+          <a:solidFill>
+            <a:srgbClr val="5BA3F5"/>
+          </a:solidFill>
+          <a:ln>
+            <a:noFill/>
+          </a:ln>
+        </p:spPr>
+        <p:style>
+          <a:lnRef idx="1">
+            <a:schemeClr val="accent1"/>
+          </a:lnRef>
+          <a:fillRef idx="3">
+            <a:schemeClr val="accent1"/>
+          </a:fillRef>
+          <a:effectRef idx="2">
+            <a:schemeClr val="accent1"/>
+          </a:effectRef>
+          <a:fontRef idx="minor">
+            <a:schemeClr val="lt1"/>
+          </a:fontRef>
+        </p:style>
+        <p:txBody>
+          <a:bodyPr rtlCol="0" anchor="ctr"/>
+          <a:lstStyle/>
+          <a:p>
+            <a:pPr algn="ctr"/>
+          </a:p>
+        </p:txBody>
+      </p:sp>
+      <p:sp>
+        <p:nvSpPr>
+          <p:cNvPr id="18" name="Rectangle 17"/>
+          <p:cNvSpPr/>
+          <p:nvPr/>
+        </p:nvSpPr>
+        <p:spPr>
+          <a:xfrm>
+            <a:off x="2690164" y="1691640"/>
+            <a:ext cx="1976932" cy="2743200"/>
+          </a:xfrm>
+          <a:prstGeom prst="roundRect">
+            <a:avLst>
+              <a:gd name="adj" fmla="val 8000"/>
+            </a:avLst>
+          </a:prstGeom>
+          <a:solidFill>
+            <a:srgbClr val="E8F2FF"/>
+          </a:solidFill>
+          <a:ln w="15875">
+            <a:solidFill>
+              <a:srgbClr val="1A6BC8"/>
+            </a:solidFill>
+          </a:ln>
+        </p:spPr>
+        <p:style>
+          <a:lnRef idx="1">
+            <a:schemeClr val="accent1"/>
+          </a:lnRef>
+          <a:fillRef idx="3">
+            <a:schemeClr val="accent1"/>
+          </a:fillRef>
+          <a:effectRef idx="2">
+            <a:schemeClr val="accent1"/>
+          </a:effectRef>
+          <a:fontRef idx="minor">
+            <a:schemeClr val="lt1"/>
+          </a:fontRef>
+        </p:style>
+        <p:txBody>
+          <a:bodyPr rtlCol="0" anchor="ctr"/>
+          <a:lstStyle/>
+          <a:p>
+            <a:pPr algn="ctr"/>
+          </a:p>
+        </p:txBody>
+      </p:sp>
+      <p:sp>
+        <p:nvSpPr>
+          <p:cNvPr id="19" name="Rectangle 18"/>
+          <p:cNvSpPr/>
+          <p:nvPr/>
+        </p:nvSpPr>
+        <p:spPr>
+          <a:xfrm>
+            <a:off x="2690164" y="1691640"/>
+            <a:ext cx="1976932" cy="640080"/>
+          </a:xfrm>
+          <a:prstGeom prst="roundRect">
+            <a:avLst>
+              <a:gd name="adj" fmla="val 8000"/>
+            </a:avLst>
+          </a:prstGeom>
+          <a:solidFill>
+            <a:srgbClr val="1A6BC8"/>
+          </a:solidFill>
+          <a:ln>
+            <a:noFill/>
+          </a:ln>
+        </p:spPr>
+        <p:style>
+          <a:lnRef idx="1">
+            <a:schemeClr val="accent1"/>
+          </a:lnRef>
+          <a:fillRef idx="3">
+            <a:schemeClr val="accent1"/>
+          </a:fillRef>
+          <a:effectRef idx="2">
+            <a:schemeClr val="accent1"/>
+          </a:effectRef>
+          <a:fontRef idx="minor">
+            <a:schemeClr val="lt1"/>
+          </a:fontRef>
+        </p:style>
+        <p:txBody>
+          <a:bodyPr rtlCol="0" anchor="ctr"/>
+          <a:lstStyle/>
+          <a:p>
+            <a:pPr algn="ctr"/>
+          </a:p>
+        </p:txBody>
+      </p:sp>
+      <p:sp>
+        <p:nvSpPr>
+          <p:cNvPr id="20" name="Rectangle 19"/>
+          <p:cNvSpPr/>
+          <p:nvPr/>
+        </p:nvSpPr>
+        <p:spPr>
+          <a:xfrm>
+            <a:off x="2690164" y="1979676"/>
+            <a:ext cx="1976932" cy="352044"/>
+          </a:xfrm>
+          <a:prstGeom prst="rect">
+            <a:avLst/>
+          </a:prstGeom>
+          <a:solidFill>
+            <a:srgbClr val="1A6BC8"/>
+          </a:solidFill>
+          <a:ln>
+            <a:noFill/>
+          </a:ln>
+        </p:spPr>
+        <p:style>
+          <a:lnRef idx="1">
+            <a:schemeClr val="accent1"/>
+          </a:lnRef>
+          <a:fillRef idx="3">
+            <a:schemeClr val="accent1"/>
+          </a:fillRef>
+          <a:effectRef idx="2">
+            <a:schemeClr val="accent1"/>
+          </a:effectRef>
+          <a:fontRef idx="minor">
+            <a:schemeClr val="lt1"/>
+          </a:fontRef>
+        </p:style>
+        <p:txBody>
+          <a:bodyPr rtlCol="0" anchor="ctr"/>
+          <a:lstStyle/>
+          <a:p>
+            <a:pPr algn="ctr"/>
+          </a:p>
+        </p:txBody>
+      </p:sp>
+      <p:sp>
+        <p:nvSpPr>
+          <p:cNvPr id="21" name="TextBox 20"/>
+          <p:cNvSpPr txBox="1"/>
+          <p:nvPr/>
+        </p:nvSpPr>
+        <p:spPr>
+          <a:xfrm>
+            <a:off x="2818180" y="1755648"/>
+            <a:ext cx="1720900" cy="329184"/>
+          </a:xfrm>
+          <a:prstGeom prst="rect">
+            <a:avLst/>
+          </a:prstGeom>
+          <a:noFill/>
+        </p:spPr>
+        <p:txBody>
+          <a:bodyPr wrap="square">
+            <a:spAutoFit/>
+          </a:bodyPr>
+          <a:lstStyle/>
+          <a:p>
+            <a:pPr algn="l"/>
+            <a:r>
+              <a:rPr sz="1600" b="1">
+                <a:solidFill>
+                  <a:srgbClr val="FFFFFF"/>
+                </a:solidFill>
+                <a:latin typeface="Yu Gothic"/>
+              </a:rPr>
+              <a:t>②  Apply to each</a:t>
+            </a:r>
+          </a:p>
+        </p:txBody>
+      </p:sp>
+      <p:sp>
+        <p:nvSpPr>
+          <p:cNvPr id="22" name="TextBox 21"/>
+          <p:cNvSpPr txBox="1"/>
+          <p:nvPr/>
+        </p:nvSpPr>
+        <p:spPr>
+          <a:xfrm>
+            <a:off x="2818180" y="2093976"/>
+            <a:ext cx="1720900" cy="237744"/>
+          </a:xfrm>
+          <a:prstGeom prst="rect">
+            <a:avLst/>
+          </a:prstGeom>
+          <a:noFill/>
+        </p:spPr>
+        <p:txBody>
+          <a:bodyPr wrap="square">
+            <a:spAutoFit/>
+          </a:bodyPr>
+          <a:lstStyle/>
+          <a:p>
+            <a:pPr algn="l"/>
+            <a:r>
+              <a:rPr sz="1200" b="0">
+                <a:solidFill>
+                  <a:srgbClr val="FFFFCC"/>
+                </a:solidFill>
+                <a:latin typeface="Yu Gothic"/>
+              </a:rPr>
+              <a:t>1行ずつ処理</a:t>
+            </a:r>
+          </a:p>
+        </p:txBody>
+      </p:sp>
+      <p:sp>
+        <p:nvSpPr>
+          <p:cNvPr id="23" name="TextBox 22"/>
+          <p:cNvSpPr txBox="1"/>
+          <p:nvPr/>
+        </p:nvSpPr>
+        <p:spPr>
+          <a:xfrm>
+            <a:off x="2818180" y="2478024"/>
+            <a:ext cx="1720900" cy="1920239"/>
+          </a:xfrm>
+          <a:prstGeom prst="rect">
+            <a:avLst/>
+          </a:prstGeom>
+          <a:noFill/>
+        </p:spPr>
+        <p:txBody>
+          <a:bodyPr wrap="square">
+            <a:spAutoFit/>
+          </a:bodyPr>
+          <a:lstStyle/>
+          <a:p>
+            <a:pPr algn="l"/>
+            <a:r>
+              <a:rPr sz="1600" b="1">
+                <a:solidFill>
+                  <a:srgbClr val="0D3065"/>
+                </a:solidFill>
+                <a:latin typeface="Yu Gothic"/>
+              </a:rPr>
+              <a:t>データを
+1行ずつ
+見ていく</a:t>
+            </a:r>
+          </a:p>
+        </p:txBody>
+      </p:sp>
+      <p:sp>
+        <p:nvSpPr>
+          <p:cNvPr id="24" name="Rectangle 23"/>
+          <p:cNvSpPr/>
+          <p:nvPr/>
+        </p:nvSpPr>
+        <p:spPr>
+          <a:xfrm>
+            <a:off x="4703673" y="3003804"/>
+            <a:ext cx="292607" cy="118872"/>
+          </a:xfrm>
+          <a:prstGeom prst="rect">
+            <a:avLst/>
+          </a:prstGeom>
+          <a:solidFill>
+            <a:srgbClr val="5BA3F5"/>
+          </a:solidFill>
+          <a:ln>
+            <a:noFill/>
+          </a:ln>
+        </p:spPr>
+        <p:style>
+          <a:lnRef idx="1">
+            <a:schemeClr val="accent1"/>
+          </a:lnRef>
+          <a:fillRef idx="3">
+            <a:schemeClr val="accent1"/>
+          </a:fillRef>
+          <a:effectRef idx="2">
+            <a:schemeClr val="accent1"/>
+          </a:effectRef>
+          <a:fontRef idx="minor">
+            <a:schemeClr val="lt1"/>
+          </a:fontRef>
+        </p:style>
+        <p:txBody>
+          <a:bodyPr rtlCol="0" anchor="ctr"/>
+          <a:lstStyle/>
+          <a:p>
+            <a:pPr algn="ctr"/>
+          </a:p>
+        </p:txBody>
+      </p:sp>
+      <p:sp>
+        <p:nvSpPr>
+          <p:cNvPr id="25" name="Rounded Rectangle 24"/>
+          <p:cNvSpPr/>
+          <p:nvPr/>
+        </p:nvSpPr>
+        <p:spPr>
+          <a:xfrm>
+            <a:off x="4959705" y="2944368"/>
+            <a:ext cx="182880" cy="237744"/>
+          </a:xfrm>
+          <a:prstGeom prst="rightArrow">
+            <a:avLst/>
+          </a:prstGeom>
+          <a:solidFill>
+            <a:srgbClr val="5BA3F5"/>
+          </a:solidFill>
+          <a:ln>
+            <a:noFill/>
+          </a:ln>
+        </p:spPr>
+        <p:style>
+          <a:lnRef idx="1">
+            <a:schemeClr val="accent1"/>
+          </a:lnRef>
+          <a:fillRef idx="3">
+            <a:schemeClr val="accent1"/>
+          </a:fillRef>
+          <a:effectRef idx="2">
+            <a:schemeClr val="accent1"/>
+          </a:effectRef>
+          <a:fontRef idx="minor">
+            <a:schemeClr val="lt1"/>
+          </a:fontRef>
+        </p:style>
+        <p:txBody>
+          <a:bodyPr rtlCol="0" anchor="ctr"/>
+          <a:lstStyle/>
+          <a:p>
+            <a:pPr algn="ctr"/>
+          </a:p>
+        </p:txBody>
+      </p:sp>
+      <p:sp>
+        <p:nvSpPr>
+          <p:cNvPr id="26" name="Rectangle 25"/>
+          <p:cNvSpPr/>
+          <p:nvPr/>
+        </p:nvSpPr>
+        <p:spPr>
+          <a:xfrm>
+            <a:off x="5106009" y="1691640"/>
+            <a:ext cx="1976932" cy="2743200"/>
+          </a:xfrm>
+          <a:prstGeom prst="roundRect">
+            <a:avLst>
+              <a:gd name="adj" fmla="val 8000"/>
+            </a:avLst>
+          </a:prstGeom>
+          <a:solidFill>
+            <a:srgbClr val="FFEDE8"/>
+          </a:solidFill>
+          <a:ln w="15875">
+            <a:solidFill>
+              <a:srgbClr val="C03910"/>
+            </a:solidFill>
+          </a:ln>
+        </p:spPr>
+        <p:style>
+          <a:lnRef idx="1">
+            <a:schemeClr val="accent1"/>
+          </a:lnRef>
+          <a:fillRef idx="3">
+            <a:schemeClr val="accent1"/>
+          </a:fillRef>
+          <a:effectRef idx="2">
+            <a:schemeClr val="accent1"/>
+          </a:effectRef>
+          <a:fontRef idx="minor">
+            <a:schemeClr val="lt1"/>
+          </a:fontRef>
+        </p:style>
+        <p:txBody>
+          <a:bodyPr rtlCol="0" anchor="ctr"/>
+          <a:lstStyle/>
+          <a:p>
+            <a:pPr algn="ctr"/>
+          </a:p>
+        </p:txBody>
+      </p:sp>
+      <p:sp>
+        <p:nvSpPr>
+          <p:cNvPr id="27" name="Rectangle 26"/>
+          <p:cNvSpPr/>
+          <p:nvPr/>
+        </p:nvSpPr>
+        <p:spPr>
+          <a:xfrm>
+            <a:off x="5106009" y="1691640"/>
+            <a:ext cx="1976932" cy="640080"/>
+          </a:xfrm>
+          <a:prstGeom prst="roundRect">
+            <a:avLst>
+              <a:gd name="adj" fmla="val 8000"/>
+            </a:avLst>
+          </a:prstGeom>
+          <a:solidFill>
+            <a:srgbClr val="C03910"/>
+          </a:solidFill>
+          <a:ln>
+            <a:noFill/>
+          </a:ln>
+        </p:spPr>
+        <p:style>
+          <a:lnRef idx="1">
+            <a:schemeClr val="accent1"/>
+          </a:lnRef>
+          <a:fillRef idx="3">
+            <a:schemeClr val="accent1"/>
+          </a:fillRef>
+          <a:effectRef idx="2">
+            <a:schemeClr val="accent1"/>
+          </a:effectRef>
+          <a:fontRef idx="minor">
+            <a:schemeClr val="lt1"/>
+          </a:fontRef>
+        </p:style>
+        <p:txBody>
+          <a:bodyPr rtlCol="0" anchor="ctr"/>
+          <a:lstStyle/>
+          <a:p>
+            <a:pPr algn="ctr"/>
+          </a:p>
+        </p:txBody>
+      </p:sp>
+      <p:sp>
+        <p:nvSpPr>
+          <p:cNvPr id="28" name="Rectangle 27"/>
+          <p:cNvSpPr/>
+          <p:nvPr/>
+        </p:nvSpPr>
+        <p:spPr>
+          <a:xfrm>
+            <a:off x="5106009" y="1979676"/>
+            <a:ext cx="1976932" cy="352044"/>
+          </a:xfrm>
+          <a:prstGeom prst="rect">
+            <a:avLst/>
+          </a:prstGeom>
+          <a:solidFill>
+            <a:srgbClr val="C03910"/>
+          </a:solidFill>
+          <a:ln>
+            <a:noFill/>
+          </a:ln>
+        </p:spPr>
+        <p:style>
+          <a:lnRef idx="1">
+            <a:schemeClr val="accent1"/>
+          </a:lnRef>
+          <a:fillRef idx="3">
+            <a:schemeClr val="accent1"/>
+          </a:fillRef>
+          <a:effectRef idx="2">
+            <a:schemeClr val="accent1"/>
+          </a:effectRef>
+          <a:fontRef idx="minor">
+            <a:schemeClr val="lt1"/>
+          </a:fontRef>
+        </p:style>
+        <p:txBody>
+          <a:bodyPr rtlCol="0" anchor="ctr"/>
+          <a:lstStyle/>
+          <a:p>
+            <a:pPr algn="ctr"/>
+          </a:p>
+        </p:txBody>
+      </p:sp>
+      <p:sp>
+        <p:nvSpPr>
+          <p:cNvPr id="29" name="TextBox 28"/>
+          <p:cNvSpPr txBox="1"/>
+          <p:nvPr/>
+        </p:nvSpPr>
+        <p:spPr>
+          <a:xfrm>
+            <a:off x="5234025" y="1755648"/>
+            <a:ext cx="1720900" cy="329184"/>
+          </a:xfrm>
+          <a:prstGeom prst="rect">
+            <a:avLst/>
+          </a:prstGeom>
+          <a:noFill/>
+        </p:spPr>
+        <p:txBody>
+          <a:bodyPr wrap="square">
+            <a:spAutoFit/>
+          </a:bodyPr>
+          <a:lstStyle/>
+          <a:p>
+            <a:pPr algn="l"/>
+            <a:r>
+              <a:rPr sz="1600" b="1">
+                <a:solidFill>
+                  <a:srgbClr val="FFFFFF"/>
+                </a:solidFill>
+                <a:latin typeface="Yu Gothic"/>
+              </a:rPr>
+              <a:t>③  Condition</a:t>
+            </a:r>
+          </a:p>
+        </p:txBody>
+      </p:sp>
+      <p:sp>
+        <p:nvSpPr>
+          <p:cNvPr id="30" name="TextBox 29"/>
+          <p:cNvSpPr txBox="1"/>
+          <p:nvPr/>
+        </p:nvSpPr>
+        <p:spPr>
+          <a:xfrm>
+            <a:off x="5234025" y="2093976"/>
+            <a:ext cx="1720900" cy="237744"/>
+          </a:xfrm>
+          <a:prstGeom prst="rect">
+            <a:avLst/>
+          </a:prstGeom>
+          <a:noFill/>
+        </p:spPr>
+        <p:txBody>
+          <a:bodyPr wrap="square">
+            <a:spAutoFit/>
+          </a:bodyPr>
+          <a:lstStyle/>
+          <a:p>
+            <a:pPr algn="l"/>
+            <a:r>
+              <a:rPr sz="1200" b="0">
+                <a:solidFill>
+                  <a:srgbClr val="FFFFCC"/>
+                </a:solidFill>
+                <a:latin typeface="Yu Gothic"/>
+              </a:rPr>
+              <a:t>未対応だけカウント</a:t>
+            </a:r>
+          </a:p>
+        </p:txBody>
+      </p:sp>
+      <p:sp>
+        <p:nvSpPr>
+          <p:cNvPr id="31" name="TextBox 30"/>
+          <p:cNvSpPr txBox="1"/>
+          <p:nvPr/>
+        </p:nvSpPr>
+        <p:spPr>
+          <a:xfrm>
+            <a:off x="5234025" y="2478024"/>
+            <a:ext cx="1720900" cy="1920239"/>
+          </a:xfrm>
+          <a:prstGeom prst="rect">
+            <a:avLst/>
+          </a:prstGeom>
+          <a:noFill/>
+        </p:spPr>
+        <p:txBody>
+          <a:bodyPr wrap="square">
+            <a:spAutoFit/>
+          </a:bodyPr>
+          <a:lstStyle/>
+          <a:p>
+            <a:pPr algn="l"/>
+            <a:r>
+              <a:rPr sz="1600" b="1">
+                <a:solidFill>
+                  <a:srgbClr val="5C1805"/>
+                </a:solidFill>
+                <a:latin typeface="Yu Gothic"/>
+              </a:rPr>
+              <a:t>未対応？
+→ 件数を
+   ＋1する</a:t>
+            </a:r>
+          </a:p>
+        </p:txBody>
+      </p:sp>
+      <p:sp>
+        <p:nvSpPr>
+          <p:cNvPr id="32" name="Rectangle 31"/>
+          <p:cNvSpPr/>
+          <p:nvPr/>
+        </p:nvSpPr>
+        <p:spPr>
+          <a:xfrm>
+            <a:off x="7119518" y="3003804"/>
+            <a:ext cx="292607" cy="118872"/>
+          </a:xfrm>
+          <a:prstGeom prst="rect">
+            <a:avLst/>
+          </a:prstGeom>
+          <a:solidFill>
+            <a:srgbClr val="5BA3F5"/>
+          </a:solidFill>
+          <a:ln>
+            <a:noFill/>
+          </a:ln>
+        </p:spPr>
+        <p:style>
+          <a:lnRef idx="1">
+            <a:schemeClr val="accent1"/>
+          </a:lnRef>
+          <a:fillRef idx="3">
+            <a:schemeClr val="accent1"/>
+          </a:fillRef>
+          <a:effectRef idx="2">
+            <a:schemeClr val="accent1"/>
+          </a:effectRef>
+          <a:fontRef idx="minor">
+            <a:schemeClr val="lt1"/>
+          </a:fontRef>
+        </p:style>
+        <p:txBody>
+          <a:bodyPr rtlCol="0" anchor="ctr"/>
+          <a:lstStyle/>
+          <a:p>
+            <a:pPr algn="ctr"/>
+          </a:p>
+        </p:txBody>
+      </p:sp>
+      <p:sp>
+        <p:nvSpPr>
+          <p:cNvPr id="33" name="Rounded Rectangle 32"/>
+          <p:cNvSpPr/>
+          <p:nvPr/>
+        </p:nvSpPr>
+        <p:spPr>
+          <a:xfrm>
+            <a:off x="7375550" y="2944368"/>
+            <a:ext cx="182880" cy="237744"/>
+          </a:xfrm>
+          <a:prstGeom prst="rightArrow">
+            <a:avLst/>
+          </a:prstGeom>
+          <a:solidFill>
+            <a:srgbClr val="5BA3F5"/>
+          </a:solidFill>
+          <a:ln>
+            <a:noFill/>
+          </a:ln>
+        </p:spPr>
+        <p:style>
+          <a:lnRef idx="1">
+            <a:schemeClr val="accent1"/>
+          </a:lnRef>
+          <a:fillRef idx="3">
+            <a:schemeClr val="accent1"/>
+          </a:fillRef>
+          <a:effectRef idx="2">
+            <a:schemeClr val="accent1"/>
+          </a:effectRef>
+          <a:fontRef idx="minor">
+            <a:schemeClr val="lt1"/>
+          </a:fontRef>
+        </p:style>
+        <p:txBody>
+          <a:bodyPr rtlCol="0" anchor="ctr"/>
+          <a:lstStyle/>
+          <a:p>
+            <a:pPr algn="ctr"/>
+          </a:p>
+        </p:txBody>
+      </p:sp>
+      <p:sp>
+        <p:nvSpPr>
+          <p:cNvPr id="34" name="Rectangle 33"/>
+          <p:cNvSpPr/>
+          <p:nvPr/>
+        </p:nvSpPr>
+        <p:spPr>
+          <a:xfrm>
+            <a:off x="7521854" y="1691640"/>
+            <a:ext cx="1976932" cy="2743200"/>
+          </a:xfrm>
+          <a:prstGeom prst="roundRect">
+            <a:avLst>
+              <a:gd name="adj" fmla="val 8000"/>
+            </a:avLst>
+          </a:prstGeom>
+          <a:solidFill>
+            <a:srgbClr val="FFF3DC"/>
+          </a:solidFill>
+          <a:ln w="15875">
+            <a:solidFill>
+              <a:srgbClr val="D46D00"/>
+            </a:solidFill>
+          </a:ln>
+        </p:spPr>
+        <p:style>
+          <a:lnRef idx="1">
+            <a:schemeClr val="accent1"/>
+          </a:lnRef>
+          <a:fillRef idx="3">
+            <a:schemeClr val="accent1"/>
+          </a:fillRef>
+          <a:effectRef idx="2">
+            <a:schemeClr val="accent1"/>
+          </a:effectRef>
+          <a:fontRef idx="minor">
+            <a:schemeClr val="lt1"/>
+          </a:fontRef>
+        </p:style>
+        <p:txBody>
+          <a:bodyPr rtlCol="0" anchor="ctr"/>
+          <a:lstStyle/>
+          <a:p>
+            <a:pPr algn="ctr"/>
+          </a:p>
+        </p:txBody>
+      </p:sp>
+      <p:sp>
+        <p:nvSpPr>
+          <p:cNvPr id="35" name="Rectangle 34"/>
+          <p:cNvSpPr/>
+          <p:nvPr/>
+        </p:nvSpPr>
+        <p:spPr>
+          <a:xfrm>
+            <a:off x="7521854" y="1691640"/>
+            <a:ext cx="1976932" cy="640080"/>
+          </a:xfrm>
+          <a:prstGeom prst="roundRect">
+            <a:avLst>
+              <a:gd name="adj" fmla="val 8000"/>
+            </a:avLst>
+          </a:prstGeom>
+          <a:solidFill>
+            <a:srgbClr val="D46D00"/>
+          </a:solidFill>
+          <a:ln>
+            <a:noFill/>
+          </a:ln>
+        </p:spPr>
+        <p:style>
+          <a:lnRef idx="1">
+            <a:schemeClr val="accent1"/>
+          </a:lnRef>
+          <a:fillRef idx="3">
+            <a:schemeClr val="accent1"/>
+          </a:fillRef>
+          <a:effectRef idx="2">
+            <a:schemeClr val="accent1"/>
+          </a:effectRef>
+          <a:fontRef idx="minor">
+            <a:schemeClr val="lt1"/>
+          </a:fontRef>
+        </p:style>
+        <p:txBody>
+          <a:bodyPr rtlCol="0" anchor="ctr"/>
+          <a:lstStyle/>
+          <a:p>
+            <a:pPr algn="ctr"/>
+          </a:p>
+        </p:txBody>
+      </p:sp>
+      <p:sp>
+        <p:nvSpPr>
+          <p:cNvPr id="36" name="Rectangle 35"/>
+          <p:cNvSpPr/>
+          <p:nvPr/>
+        </p:nvSpPr>
+        <p:spPr>
+          <a:xfrm>
+            <a:off x="7521854" y="1979676"/>
+            <a:ext cx="1976932" cy="352044"/>
+          </a:xfrm>
+          <a:prstGeom prst="rect">
+            <a:avLst/>
+          </a:prstGeom>
+          <a:solidFill>
+            <a:srgbClr val="D46D00"/>
+          </a:solidFill>
+          <a:ln>
+            <a:noFill/>
+          </a:ln>
+        </p:spPr>
+        <p:style>
+          <a:lnRef idx="1">
+            <a:schemeClr val="accent1"/>
+          </a:lnRef>
+          <a:fillRef idx="3">
+            <a:schemeClr val="accent1"/>
+          </a:fillRef>
+          <a:effectRef idx="2">
+            <a:schemeClr val="accent1"/>
+          </a:effectRef>
+          <a:fontRef idx="minor">
+            <a:schemeClr val="lt1"/>
+          </a:fontRef>
+        </p:style>
+        <p:txBody>
+          <a:bodyPr rtlCol="0" anchor="ctr"/>
+          <a:lstStyle/>
+          <a:p>
+            <a:pPr algn="ctr"/>
+          </a:p>
+        </p:txBody>
+      </p:sp>
+      <p:sp>
+        <p:nvSpPr>
+          <p:cNvPr id="37" name="TextBox 36"/>
+          <p:cNvSpPr txBox="1"/>
+          <p:nvPr/>
+        </p:nvSpPr>
+        <p:spPr>
+          <a:xfrm>
+            <a:off x="7649870" y="1755648"/>
+            <a:ext cx="1720900" cy="329184"/>
+          </a:xfrm>
+          <a:prstGeom prst="rect">
+            <a:avLst/>
+          </a:prstGeom>
+          <a:noFill/>
+        </p:spPr>
+        <p:txBody>
+          <a:bodyPr wrap="square">
+            <a:spAutoFit/>
+          </a:bodyPr>
+          <a:lstStyle/>
+          <a:p>
+            <a:pPr algn="l"/>
+            <a:r>
+              <a:rPr sz="1600" b="1">
+                <a:solidFill>
+                  <a:srgbClr val="FFFFFF"/>
+                </a:solidFill>
+                <a:latin typeface="Yu Gothic"/>
+              </a:rPr>
+              <a:t>④  Compose</a:t>
+            </a:r>
+          </a:p>
+        </p:txBody>
+      </p:sp>
+      <p:sp>
+        <p:nvSpPr>
+          <p:cNvPr id="38" name="TextBox 37"/>
+          <p:cNvSpPr txBox="1"/>
+          <p:nvPr/>
+        </p:nvSpPr>
+        <p:spPr>
+          <a:xfrm>
+            <a:off x="7649870" y="2093976"/>
+            <a:ext cx="1720900" cy="237744"/>
+          </a:xfrm>
+          <a:prstGeom prst="rect">
+            <a:avLst/>
+          </a:prstGeom>
+          <a:noFill/>
+        </p:spPr>
+        <p:txBody>
+          <a:bodyPr wrap="square">
+            <a:spAutoFit/>
+          </a:bodyPr>
+          <a:lstStyle/>
+          <a:p>
+            <a:pPr algn="l"/>
+            <a:r>
+              <a:rPr sz="1200" b="0">
+                <a:solidFill>
+                  <a:srgbClr val="FFFFCC"/>
+                </a:solidFill>
+                <a:latin typeface="Yu Gothic"/>
+              </a:rPr>
+              <a:t>のぞき窓</a:t>
+            </a:r>
+          </a:p>
+        </p:txBody>
+      </p:sp>
+      <p:sp>
+        <p:nvSpPr>
+          <p:cNvPr id="39" name="TextBox 38"/>
+          <p:cNvSpPr txBox="1"/>
+          <p:nvPr/>
+        </p:nvSpPr>
+        <p:spPr>
+          <a:xfrm>
+            <a:off x="7649870" y="2478024"/>
+            <a:ext cx="1720900" cy="1920239"/>
+          </a:xfrm>
+          <a:prstGeom prst="rect">
+            <a:avLst/>
+          </a:prstGeom>
+          <a:noFill/>
+        </p:spPr>
+        <p:txBody>
+          <a:bodyPr wrap="square">
+            <a:spAutoFit/>
+          </a:bodyPr>
+          <a:lstStyle/>
+          <a:p>
+            <a:pPr algn="l"/>
+            <a:r>
+              <a:rPr sz="1600" b="1">
+                <a:solidFill>
+                  <a:srgbClr val="5A2D00"/>
+                </a:solidFill>
+                <a:latin typeface="Yu Gothic"/>
+              </a:rPr>
+              <a:t>途中の
+状態を
+確認する</a:t>
+            </a:r>
+          </a:p>
+        </p:txBody>
+      </p:sp>
+      <p:sp>
+        <p:nvSpPr>
+          <p:cNvPr id="40" name="Rectangle 39"/>
+          <p:cNvSpPr/>
+          <p:nvPr/>
+        </p:nvSpPr>
+        <p:spPr>
+          <a:xfrm>
+            <a:off x="9535363" y="3003804"/>
+            <a:ext cx="292607" cy="118872"/>
+          </a:xfrm>
+          <a:prstGeom prst="rect">
+            <a:avLst/>
+          </a:prstGeom>
+          <a:solidFill>
+            <a:srgbClr val="5BA3F5"/>
+          </a:solidFill>
+          <a:ln>
+            <a:noFill/>
+          </a:ln>
+        </p:spPr>
+        <p:style>
+          <a:lnRef idx="1">
+            <a:schemeClr val="accent1"/>
+          </a:lnRef>
+          <a:fillRef idx="3">
+            <a:schemeClr val="accent1"/>
+          </a:fillRef>
+          <a:effectRef idx="2">
+            <a:schemeClr val="accent1"/>
+          </a:effectRef>
+          <a:fontRef idx="minor">
+            <a:schemeClr val="lt1"/>
+          </a:fontRef>
+        </p:style>
+        <p:txBody>
+          <a:bodyPr rtlCol="0" anchor="ctr"/>
+          <a:lstStyle/>
+          <a:p>
+            <a:pPr algn="ctr"/>
+          </a:p>
+        </p:txBody>
+      </p:sp>
+      <p:sp>
+        <p:nvSpPr>
+          <p:cNvPr id="41" name="Rounded Rectangle 40"/>
+          <p:cNvSpPr/>
+          <p:nvPr/>
+        </p:nvSpPr>
+        <p:spPr>
+          <a:xfrm>
+            <a:off x="9791395" y="2944368"/>
+            <a:ext cx="182880" cy="237744"/>
+          </a:xfrm>
+          <a:prstGeom prst="rightArrow">
+            <a:avLst/>
+          </a:prstGeom>
+          <a:solidFill>
+            <a:srgbClr val="5BA3F5"/>
+          </a:solidFill>
+          <a:ln>
+            <a:noFill/>
+          </a:ln>
+        </p:spPr>
+        <p:style>
+          <a:lnRef idx="1">
+            <a:schemeClr val="accent1"/>
+          </a:lnRef>
+          <a:fillRef idx="3">
+            <a:schemeClr val="accent1"/>
+          </a:fillRef>
+          <a:effectRef idx="2">
+            <a:schemeClr val="accent1"/>
+          </a:effectRef>
+          <a:fontRef idx="minor">
+            <a:schemeClr val="lt1"/>
+          </a:fontRef>
+        </p:style>
+        <p:txBody>
+          <a:bodyPr rtlCol="0" anchor="ctr"/>
+          <a:lstStyle/>
+          <a:p>
+            <a:pPr algn="ctr"/>
+          </a:p>
+        </p:txBody>
+      </p:sp>
+      <p:sp>
+        <p:nvSpPr>
+          <p:cNvPr id="42" name="Rectangle 41"/>
+          <p:cNvSpPr/>
+          <p:nvPr/>
+        </p:nvSpPr>
+        <p:spPr>
+          <a:xfrm>
+            <a:off x="9937699" y="1691640"/>
+            <a:ext cx="1976932" cy="2743200"/>
+          </a:xfrm>
+          <a:prstGeom prst="roundRect">
+            <a:avLst>
+              <a:gd name="adj" fmla="val 8000"/>
+            </a:avLst>
+          </a:prstGeom>
+          <a:solidFill>
+            <a:srgbClr val="F3E8FF"/>
+          </a:solidFill>
+          <a:ln w="15875">
+            <a:solidFill>
+              <a:srgbClr val="7220A8"/>
+            </a:solidFill>
+          </a:ln>
+        </p:spPr>
+        <p:style>
+          <a:lnRef idx="1">
+            <a:schemeClr val="accent1"/>
+          </a:lnRef>
+          <a:fillRef idx="3">
+            <a:schemeClr val="accent1"/>
+          </a:fillRef>
+          <a:effectRef idx="2">
+            <a:schemeClr val="accent1"/>
+          </a:effectRef>
+          <a:fontRef idx="minor">
+            <a:schemeClr val="lt1"/>
+          </a:fontRef>
+        </p:style>
+        <p:txBody>
+          <a:bodyPr rtlCol="0" anchor="ctr"/>
+          <a:lstStyle/>
+          <a:p>
+            <a:pPr algn="ctr"/>
+          </a:p>
+        </p:txBody>
+      </p:sp>
+      <p:sp>
+        <p:nvSpPr>
+          <p:cNvPr id="43" name="Rectangle 42"/>
+          <p:cNvSpPr/>
+          <p:nvPr/>
+        </p:nvSpPr>
+        <p:spPr>
+          <a:xfrm>
+            <a:off x="9937699" y="1691640"/>
+            <a:ext cx="1976932" cy="640080"/>
+          </a:xfrm>
+          <a:prstGeom prst="roundRect">
+            <a:avLst>
+              <a:gd name="adj" fmla="val 8000"/>
+            </a:avLst>
+          </a:prstGeom>
+          <a:solidFill>
+            <a:srgbClr val="7220A8"/>
+          </a:solidFill>
+          <a:ln>
+            <a:noFill/>
+          </a:ln>
+        </p:spPr>
+        <p:style>
+          <a:lnRef idx="1">
+            <a:schemeClr val="accent1"/>
+          </a:lnRef>
+          <a:fillRef idx="3">
+            <a:schemeClr val="accent1"/>
+          </a:fillRef>
+          <a:effectRef idx="2">
+            <a:schemeClr val="accent1"/>
+          </a:effectRef>
+          <a:fontRef idx="minor">
+            <a:schemeClr val="lt1"/>
+          </a:fontRef>
+        </p:style>
+        <p:txBody>
+          <a:bodyPr rtlCol="0" anchor="ctr"/>
+          <a:lstStyle/>
+          <a:p>
+            <a:pPr algn="ctr"/>
+          </a:p>
+        </p:txBody>
+      </p:sp>
+      <p:sp>
+        <p:nvSpPr>
+          <p:cNvPr id="44" name="Rectangle 43"/>
+          <p:cNvSpPr/>
+          <p:nvPr/>
+        </p:nvSpPr>
+        <p:spPr>
+          <a:xfrm>
+            <a:off x="9937699" y="1979676"/>
+            <a:ext cx="1976932" cy="352044"/>
+          </a:xfrm>
+          <a:prstGeom prst="rect">
+            <a:avLst/>
+          </a:prstGeom>
+          <a:solidFill>
+            <a:srgbClr val="7220A8"/>
+          </a:solidFill>
+          <a:ln>
+            <a:noFill/>
+          </a:ln>
+        </p:spPr>
+        <p:style>
+          <a:lnRef idx="1">
+            <a:schemeClr val="accent1"/>
+          </a:lnRef>
+          <a:fillRef idx="3">
+            <a:schemeClr val="accent1"/>
+          </a:fillRef>
+          <a:effectRef idx="2">
+            <a:schemeClr val="accent1"/>
+          </a:effectRef>
+          <a:fontRef idx="minor">
+            <a:schemeClr val="lt1"/>
+          </a:fontRef>
+        </p:style>
+        <p:txBody>
+          <a:bodyPr rtlCol="0" anchor="ctr"/>
+          <a:lstStyle/>
+          <a:p>
+            <a:pPr algn="ctr"/>
+          </a:p>
+        </p:txBody>
+      </p:sp>
+      <p:sp>
+        <p:nvSpPr>
+          <p:cNvPr id="45" name="TextBox 44"/>
+          <p:cNvSpPr txBox="1"/>
+          <p:nvPr/>
+        </p:nvSpPr>
+        <p:spPr>
+          <a:xfrm>
+            <a:off x="10065715" y="1755648"/>
+            <a:ext cx="1720900" cy="329184"/>
+          </a:xfrm>
+          <a:prstGeom prst="rect">
+            <a:avLst/>
+          </a:prstGeom>
+          <a:noFill/>
+        </p:spPr>
+        <p:txBody>
+          <a:bodyPr wrap="square">
+            <a:spAutoFit/>
+          </a:bodyPr>
+          <a:lstStyle/>
+          <a:p>
+            <a:pPr algn="l"/>
+            <a:r>
+              <a:rPr sz="1600" b="1">
+                <a:solidFill>
+                  <a:srgbClr val="FFFFFF"/>
+                </a:solidFill>
+                <a:latin typeface="Yu Gothic"/>
+              </a:rPr>
+              <a:t>⑤  最終判断</a:t>
+            </a:r>
+          </a:p>
+        </p:txBody>
+      </p:sp>
+      <p:sp>
+        <p:nvSpPr>
+          <p:cNvPr id="46" name="TextBox 45"/>
+          <p:cNvSpPr txBox="1"/>
+          <p:nvPr/>
+        </p:nvSpPr>
+        <p:spPr>
+          <a:xfrm>
+            <a:off x="10065715" y="2093976"/>
+            <a:ext cx="1720900" cy="237744"/>
+          </a:xfrm>
+          <a:prstGeom prst="rect">
+            <a:avLst/>
+          </a:prstGeom>
+          <a:noFill/>
+        </p:spPr>
+        <p:txBody>
+          <a:bodyPr wrap="square">
+            <a:spAutoFit/>
+          </a:bodyPr>
+          <a:lstStyle/>
+          <a:p>
+            <a:pPr algn="l"/>
+            <a:r>
+              <a:rPr sz="1200" b="0">
+                <a:solidFill>
+                  <a:srgbClr val="FFFFCC"/>
+                </a:solidFill>
+                <a:latin typeface="Yu Gothic"/>
+              </a:rPr>
+              <a:t>OK ／ 注意</a:t>
+            </a:r>
+          </a:p>
+        </p:txBody>
+      </p:sp>
+      <p:sp>
+        <p:nvSpPr>
+          <p:cNvPr id="47" name="TextBox 46"/>
+          <p:cNvSpPr txBox="1"/>
+          <p:nvPr/>
+        </p:nvSpPr>
+        <p:spPr>
+          <a:xfrm>
+            <a:off x="10065715" y="2478024"/>
+            <a:ext cx="1720900" cy="1920239"/>
+          </a:xfrm>
+          <a:prstGeom prst="rect">
+            <a:avLst/>
+          </a:prstGeom>
+          <a:noFill/>
+        </p:spPr>
+        <p:txBody>
+          <a:bodyPr wrap="square">
+            <a:spAutoFit/>
+          </a:bodyPr>
+          <a:lstStyle/>
+          <a:p>
+            <a:pPr algn="l"/>
+            <a:r>
+              <a:rPr sz="1600" b="1">
+                <a:solidFill>
+                  <a:srgbClr val="370A58"/>
+                </a:solidFill>
+                <a:latin typeface="Yu Gothic"/>
+              </a:rPr>
+              <a:t>件数0 → OK
+件数 &gt; 0
+→ 注意！</a:t>
+            </a:r>
+          </a:p>
+        </p:txBody>
+      </p:sp>
+      <p:sp>
+        <p:nvSpPr>
+          <p:cNvPr id="48" name="TextBox 47"/>
+          <p:cNvSpPr txBox="1"/>
+          <p:nvPr/>
+        </p:nvSpPr>
+        <p:spPr>
+          <a:xfrm>
+            <a:off x="571500" y="4389120"/>
+            <a:ext cx="2286000" cy="256032"/>
+          </a:xfrm>
+          <a:prstGeom prst="rect">
+            <a:avLst/>
+          </a:prstGeom>
+          <a:noFill/>
+        </p:spPr>
+        <p:txBody>
+          <a:bodyPr wrap="square">
+            <a:spAutoFit/>
+          </a:bodyPr>
+          <a:lstStyle/>
+          <a:p>
+            <a:pPr algn="l"/>
+            <a:r>
+              <a:rPr sz="1100" b="0">
+                <a:solidFill>
+                  <a:srgbClr val="556699"/>
+                </a:solidFill>
+                <a:latin typeface="Yu Gothic"/>
+              </a:rPr>
+              <a:t>🔑  キーワード</a:t>
+            </a:r>
+          </a:p>
+        </p:txBody>
+      </p:sp>
+      <p:sp>
+        <p:nvSpPr>
+          <p:cNvPr id="49" name="Rectangle 48"/>
+          <p:cNvSpPr/>
+          <p:nvPr/>
+        </p:nvSpPr>
+        <p:spPr>
+          <a:xfrm>
+            <a:off x="571500" y="4663440"/>
+            <a:ext cx="2084831" cy="365760"/>
+          </a:xfrm>
+          <a:prstGeom prst="roundRect">
+            <a:avLst>
+              <a:gd name="adj" fmla="val 50000"/>
+            </a:avLst>
+          </a:prstGeom>
+          <a:solidFill>
+            <a:srgbClr val="EAF7F0"/>
+          </a:solidFill>
+          <a:ln w="19050">
+            <a:solidFill>
+              <a:srgbClr val="1D7A4A"/>
+            </a:solidFill>
+          </a:ln>
+        </p:spPr>
+        <p:style>
+          <a:lnRef idx="1">
+            <a:schemeClr val="accent1"/>
+          </a:lnRef>
+          <a:fillRef idx="3">
+            <a:schemeClr val="accent1"/>
+          </a:fillRef>
+          <a:effectRef idx="2">
+            <a:schemeClr val="accent1"/>
+          </a:effectRef>
+          <a:fontRef idx="minor">
+            <a:schemeClr val="lt1"/>
+          </a:fontRef>
+        </p:style>
+        <p:txBody>
+          <a:bodyPr rtlCol="0" anchor="ctr"/>
+          <a:lstStyle/>
+          <a:p>
+            <a:pPr algn="ctr"/>
+          </a:p>
+        </p:txBody>
+      </p:sp>
+      <p:sp>
+        <p:nvSpPr>
+          <p:cNvPr id="50" name="TextBox 49"/>
+          <p:cNvSpPr txBox="1"/>
+          <p:nvPr/>
+        </p:nvSpPr>
+        <p:spPr>
+          <a:xfrm>
+            <a:off x="662940" y="4709159"/>
+            <a:ext cx="1901951" cy="274320"/>
+          </a:xfrm>
+          <a:prstGeom prst="rect">
+            <a:avLst/>
+          </a:prstGeom>
+          <a:noFill/>
+        </p:spPr>
+        <p:txBody>
+          <a:bodyPr wrap="square">
+            <a:spAutoFit/>
+          </a:bodyPr>
+          <a:lstStyle/>
+          <a:p>
+            <a:pPr algn="ctr"/>
+            <a:r>
+              <a:rPr sz="1250" b="1">
+                <a:solidFill>
+                  <a:srgbClr val="0D3D25"/>
+                </a:solidFill>
+                <a:latin typeface="Yu Gothic"/>
+              </a:rPr>
+              <a:t>Excelテーブル</a:t>
+            </a:r>
+          </a:p>
+        </p:txBody>
+      </p:sp>
+      <p:sp>
+        <p:nvSpPr>
+          <p:cNvPr id="51" name="Rectangle 50"/>
+          <p:cNvSpPr/>
+          <p:nvPr/>
+        </p:nvSpPr>
+        <p:spPr>
+          <a:xfrm>
+            <a:off x="2811780" y="4663440"/>
+            <a:ext cx="2084831" cy="365760"/>
+          </a:xfrm>
+          <a:prstGeom prst="roundRect">
+            <a:avLst>
+              <a:gd name="adj" fmla="val 50000"/>
+            </a:avLst>
+          </a:prstGeom>
+          <a:solidFill>
+            <a:srgbClr val="E8F2FF"/>
+          </a:solidFill>
+          <a:ln w="19050">
+            <a:solidFill>
+              <a:srgbClr val="1A6BC8"/>
+            </a:solidFill>
+          </a:ln>
+        </p:spPr>
+        <p:style>
+          <a:lnRef idx="1">
+            <a:schemeClr val="accent1"/>
+          </a:lnRef>
+          <a:fillRef idx="3">
+            <a:schemeClr val="accent1"/>
+          </a:fillRef>
+          <a:effectRef idx="2">
+            <a:schemeClr val="accent1"/>
+          </a:effectRef>
+          <a:fontRef idx="minor">
+            <a:schemeClr val="lt1"/>
+          </a:fontRef>
+        </p:style>
+        <p:txBody>
+          <a:bodyPr rtlCol="0" anchor="ctr"/>
+          <a:lstStyle/>
+          <a:p>
+            <a:pPr algn="ctr"/>
+          </a:p>
+        </p:txBody>
+      </p:sp>
+      <p:sp>
+        <p:nvSpPr>
+          <p:cNvPr id="52" name="TextBox 51"/>
+          <p:cNvSpPr txBox="1"/>
+          <p:nvPr/>
+        </p:nvSpPr>
+        <p:spPr>
+          <a:xfrm>
+            <a:off x="2903220" y="4709159"/>
+            <a:ext cx="1901951" cy="274320"/>
+          </a:xfrm>
+          <a:prstGeom prst="rect">
+            <a:avLst/>
+          </a:prstGeom>
+          <a:noFill/>
+        </p:spPr>
+        <p:txBody>
+          <a:bodyPr wrap="square">
+            <a:spAutoFit/>
+          </a:bodyPr>
+          <a:lstStyle/>
+          <a:p>
+            <a:pPr algn="ctr"/>
+            <a:r>
+              <a:rPr sz="1250" b="1">
+                <a:solidFill>
+                  <a:srgbClr val="0D3065"/>
+                </a:solidFill>
+                <a:latin typeface="Yu Gothic"/>
+              </a:rPr>
+              <a:t>1行ずつ</a:t>
+            </a:r>
+          </a:p>
+        </p:txBody>
+      </p:sp>
+      <p:sp>
+        <p:nvSpPr>
+          <p:cNvPr id="53" name="Rectangle 52"/>
+          <p:cNvSpPr/>
+          <p:nvPr/>
+        </p:nvSpPr>
+        <p:spPr>
+          <a:xfrm>
+            <a:off x="5052060" y="4663440"/>
+            <a:ext cx="2084831" cy="365760"/>
+          </a:xfrm>
+          <a:prstGeom prst="roundRect">
+            <a:avLst>
+              <a:gd name="adj" fmla="val 50000"/>
+            </a:avLst>
+          </a:prstGeom>
+          <a:solidFill>
+            <a:srgbClr val="FFEDE8"/>
+          </a:solidFill>
+          <a:ln w="19050">
+            <a:solidFill>
+              <a:srgbClr val="C03910"/>
+            </a:solidFill>
+          </a:ln>
+        </p:spPr>
+        <p:style>
+          <a:lnRef idx="1">
+            <a:schemeClr val="accent1"/>
+          </a:lnRef>
+          <a:fillRef idx="3">
+            <a:schemeClr val="accent1"/>
+          </a:fillRef>
+          <a:effectRef idx="2">
+            <a:schemeClr val="accent1"/>
+          </a:effectRef>
+          <a:fontRef idx="minor">
+            <a:schemeClr val="lt1"/>
+          </a:fontRef>
+        </p:style>
+        <p:txBody>
+          <a:bodyPr rtlCol="0" anchor="ctr"/>
+          <a:lstStyle/>
+          <a:p>
+            <a:pPr algn="ctr"/>
+          </a:p>
+        </p:txBody>
+      </p:sp>
+      <p:sp>
+        <p:nvSpPr>
+          <p:cNvPr id="54" name="TextBox 53"/>
+          <p:cNvSpPr txBox="1"/>
+          <p:nvPr/>
+        </p:nvSpPr>
+        <p:spPr>
+          <a:xfrm>
+            <a:off x="5143500" y="4709159"/>
+            <a:ext cx="1901951" cy="274320"/>
+          </a:xfrm>
+          <a:prstGeom prst="rect">
+            <a:avLst/>
+          </a:prstGeom>
+          <a:noFill/>
+        </p:spPr>
+        <p:txBody>
+          <a:bodyPr wrap="square">
+            <a:spAutoFit/>
+          </a:bodyPr>
+          <a:lstStyle/>
+          <a:p>
+            <a:pPr algn="ctr"/>
+            <a:r>
+              <a:rPr sz="1250" b="1">
+                <a:solidFill>
+                  <a:srgbClr val="5C1805"/>
+                </a:solidFill>
+                <a:latin typeface="Yu Gothic"/>
+              </a:rPr>
+              <a:t>未対応だけカウント</a:t>
+            </a:r>
+          </a:p>
+        </p:txBody>
+      </p:sp>
+      <p:sp>
+        <p:nvSpPr>
+          <p:cNvPr id="55" name="Rectangle 54"/>
+          <p:cNvSpPr/>
+          <p:nvPr/>
+        </p:nvSpPr>
+        <p:spPr>
+          <a:xfrm>
+            <a:off x="7292340" y="4663440"/>
+            <a:ext cx="2084831" cy="365760"/>
+          </a:xfrm>
+          <a:prstGeom prst="roundRect">
+            <a:avLst>
+              <a:gd name="adj" fmla="val 50000"/>
+            </a:avLst>
+          </a:prstGeom>
+          <a:solidFill>
+            <a:srgbClr val="FFF3DC"/>
+          </a:solidFill>
+          <a:ln w="19050">
+            <a:solidFill>
+              <a:srgbClr val="D46D00"/>
+            </a:solidFill>
+          </a:ln>
+        </p:spPr>
+        <p:style>
+          <a:lnRef idx="1">
+            <a:schemeClr val="accent1"/>
+          </a:lnRef>
+          <a:fillRef idx="3">
+            <a:schemeClr val="accent1"/>
+          </a:fillRef>
+          <a:effectRef idx="2">
+            <a:schemeClr val="accent1"/>
+          </a:effectRef>
+          <a:fontRef idx="minor">
+            <a:schemeClr val="lt1"/>
+          </a:fontRef>
+        </p:style>
+        <p:txBody>
+          <a:bodyPr rtlCol="0" anchor="ctr"/>
+          <a:lstStyle/>
+          <a:p>
+            <a:pPr algn="ctr"/>
+          </a:p>
+        </p:txBody>
+      </p:sp>
+      <p:sp>
+        <p:nvSpPr>
+          <p:cNvPr id="56" name="TextBox 55"/>
+          <p:cNvSpPr txBox="1"/>
+          <p:nvPr/>
+        </p:nvSpPr>
+        <p:spPr>
+          <a:xfrm>
+            <a:off x="7383780" y="4709159"/>
+            <a:ext cx="1901951" cy="274320"/>
+          </a:xfrm>
+          <a:prstGeom prst="rect">
+            <a:avLst/>
+          </a:prstGeom>
+          <a:noFill/>
+        </p:spPr>
+        <p:txBody>
+          <a:bodyPr wrap="square">
+            <a:spAutoFit/>
+          </a:bodyPr>
+          <a:lstStyle/>
+          <a:p>
+            <a:pPr algn="ctr"/>
+            <a:r>
+              <a:rPr sz="1250" b="1">
+                <a:solidFill>
+                  <a:srgbClr val="5A2D00"/>
+                </a:solidFill>
+                <a:latin typeface="Yu Gothic"/>
+              </a:rPr>
+              <a:t>Compose = のぞき窓</a:t>
+            </a:r>
+          </a:p>
+        </p:txBody>
+      </p:sp>
+      <p:sp>
+        <p:nvSpPr>
+          <p:cNvPr id="57" name="Rectangle 56"/>
+          <p:cNvSpPr/>
+          <p:nvPr/>
+        </p:nvSpPr>
+        <p:spPr>
+          <a:xfrm>
+            <a:off x="9532620" y="4663440"/>
+            <a:ext cx="2084831" cy="365760"/>
+          </a:xfrm>
+          <a:prstGeom prst="roundRect">
+            <a:avLst>
+              <a:gd name="adj" fmla="val 50000"/>
+            </a:avLst>
+          </a:prstGeom>
+          <a:solidFill>
+            <a:srgbClr val="F3E8FF"/>
+          </a:solidFill>
+          <a:ln w="19050">
+            <a:solidFill>
+              <a:srgbClr val="7220A8"/>
+            </a:solidFill>
+          </a:ln>
+        </p:spPr>
+        <p:style>
+          <a:lnRef idx="1">
+            <a:schemeClr val="accent1"/>
+          </a:lnRef>
+          <a:fillRef idx="3">
+            <a:schemeClr val="accent1"/>
+          </a:fillRef>
+          <a:effectRef idx="2">
+            <a:schemeClr val="accent1"/>
+          </a:effectRef>
+          <a:fontRef idx="minor">
+            <a:schemeClr val="lt1"/>
+          </a:fontRef>
+        </p:style>
+        <p:txBody>
+          <a:bodyPr rtlCol="0" anchor="ctr"/>
+          <a:lstStyle/>
+          <a:p>
+            <a:pPr algn="ctr"/>
+          </a:p>
+        </p:txBody>
+      </p:sp>
+      <p:sp>
+        <p:nvSpPr>
+          <p:cNvPr id="58" name="TextBox 57"/>
+          <p:cNvSpPr txBox="1"/>
+          <p:nvPr/>
+        </p:nvSpPr>
+        <p:spPr>
+          <a:xfrm>
+            <a:off x="9624060" y="4709159"/>
+            <a:ext cx="1901951" cy="274320"/>
+          </a:xfrm>
+          <a:prstGeom prst="rect">
+            <a:avLst/>
+          </a:prstGeom>
+          <a:noFill/>
+        </p:spPr>
+        <p:txBody>
+          <a:bodyPr wrap="square">
+            <a:spAutoFit/>
+          </a:bodyPr>
+          <a:lstStyle/>
+          <a:p>
+            <a:pPr algn="ctr"/>
+            <a:r>
+              <a:rPr sz="1250" b="1">
+                <a:solidFill>
+                  <a:srgbClr val="370A58"/>
+                </a:solidFill>
+                <a:latin typeface="Yu Gothic"/>
+              </a:rPr>
+              <a:t>実務でよくあるパターン</a:t>
+            </a:r>
+          </a:p>
+        </p:txBody>
+      </p:sp>
+      <p:sp>
+        <p:nvSpPr>
+          <p:cNvPr id="59" name="Rectangle 58"/>
+          <p:cNvSpPr/>
+          <p:nvPr/>
+        </p:nvSpPr>
+        <p:spPr>
+          <a:xfrm>
+            <a:off x="0" y="6784848"/>
+            <a:ext cx="12188952" cy="73152"/>
+          </a:xfrm>
+          <a:prstGeom prst="rect">
+            <a:avLst/>
+          </a:prstGeom>
+          <a:solidFill>
+            <a:srgbClr val="5BA3F5"/>
+          </a:solidFill>
+          <a:ln>
+            <a:noFill/>
+          </a:ln>
+        </p:spPr>
+        <p:style>
+          <a:lnRef idx="1">
+            <a:schemeClr val="accent1"/>
+          </a:lnRef>
+          <a:fillRef idx="3">
+            <a:schemeClr val="accent1"/>
+          </a:fillRef>
+          <a:effectRef idx="2">
+            <a:schemeClr val="accent1"/>
+          </a:effectRef>
+          <a:fontRef idx="minor">
+            <a:schemeClr val="lt1"/>
+          </a:fontRef>
+        </p:style>
+        <p:txBody>
+          <a:bodyPr rtlCol="0" anchor="ctr"/>
+          <a:lstStyle/>
+          <a:p>
+            <a:pPr algn="ctr"/>
+          </a:p>
+        </p:txBody>
+      </p:sp>
+    </p:spTree>
+  </p:cSld>
+  <p:clrMapOvr>
+    <a:masterClrMapping/>
+  </p:clrMapOvr>
+</p:sld>
+</file>
+
 <file path=ppt/slides/slide2.xml><?xml version="1.0" encoding="utf-8"?>
 <p:sld xmlns:a="http://schemas.openxmlformats.org/drawingml/2006/main" xmlns:r="http://schemas.openxmlformats.org/officeDocument/2006/relationships" xmlns:p="http://schemas.openxmlformats.org/presentationml/2006/main">
   <p:cSld name="Slide 1">

</xml_diff>